<commit_message>
Translate the deck to English, caption every window and number the pages
Each explorer capture and terminal gets a one-line caption saying what it
proves, and every slide but the title shows n / 10. Claims re-checked on the
ledger: the minimum bar row now reads 6 tec + 2 controls. Log the 10 s close
time resolution that blurs loan timings on the devnet.

Co-Authored-By: Claude Opus 5 <noreply@anthropic.com>
</commit_message>
<xml_diff>
--- a/deck/exit-lane.pptx
+++ b/deck/exit-lane.pptx
@@ -512,7 +512,7 @@
             <a:r>
               <a:rPr lang="en-US" dirty="0"/>
               <a:t>0:00 → 0:15 (15 s)
-CY-HACK, track 1. Un vault open-ended promet le retrait à tout moment. Il ne peut plus tenir cette promesse dès qu'il fonctionne bien. Voici pourquoi, ce qu'on a construit, et ce que le protocole nous a appris.</a:t>
+CY-HACK, track 1. An open-ended vault promises withdrawal at any time. It can no longer keep that promise once it works well. Here is why, what we built, and what the protocol taught us.</a:t>
             </a:r>
             <a:endParaRPr lang="en-US" dirty="0"/>
           </a:p>
@@ -601,7 +601,7 @@
             <a:r>
               <a:rPr lang="en-US" dirty="0"/>
               <a:t>3:50 → 4:00 (10 s)
-Tout est dans FEEDBACK.md, et en trois pages dans FEEDBACK.pdf. Les 143 hashes cités ont été relus sur le ledger avant soumission. Merci.</a:t>
+Everything is in FEEDBACK.md, and in three pages in FEEDBACK.pdf. The 143 hashes cited were re-checked on the ledger before submission. Thank you.</a:t>
             </a:r>
             <a:endParaRPr lang="en-US" dirty="0"/>
           </a:p>
@@ -690,7 +690,7 @@
             <a:r>
               <a:rPr lang="en-US" dirty="0"/>
               <a:t>0:15 → 0:40 (25 s)
-Une trésorière d'entreprise dépose 25 XRP. Un broker prête à des PME, sur quatre mois. Un seul LoanSet prend 100 % du vault, sans avertissement. Elle veut retirer : tecINSUFFICIENT_FUNDS, ici dans l'explorer. On l'a rencontré en écrivant la démo.</a:t>
+A corporate treasurer deposits 25 XRP. A broker lends to small businesses, over four months. A single LoanSet takes 100% of the vault, with no warning. She wants to withdraw: tecINSUFFICIENT_FUNDS, here in the explorer. We hit it while writing the demo.</a:t>
             </a:r>
             <a:endParaRPr lang="en-US" dirty="0"/>
           </a:p>
@@ -779,8 +779,8 @@
             <a:r>
               <a:rPr lang="en-US" dirty="0"/>
               <a:t>0:40 → 1:00 (20 s)
-Aucune transaction XLS-66 ne transfère un prêt. Mais la part de vault est un MPT, donc cessible. On la vend de gré à gré, à 97 % de sa valeur, avec deux escrows sous la même condition SHA-256 : pour prendre les parts, l'acheteur publie le secret qui paie la vendeuse.
-Q&amp;A : l'escrow de la vendeuse expire avant celui de l'acheteur pour qu'elle ait le temps d'encaisser. Limite : l'acheteur détient une option gratuite d'une heure (README, Known limitations). BatchV1_1 est actif, autre chemin atomique, non testé.</a:t>
+No XLS-66 transaction transfers a loan. But the vault share is an MPT, so it can be transferred. She sells it over the counter, at 97% of its value, with two escrows under the same SHA-256 condition: to take the shares, the buyer publishes the secret that pays the seller.
+Q&amp;A: the seller's escrow expires before the buyer's so she has time to collect. Limit: the buyer holds a free one-hour option (README, Known limitations). BatchV1_1 is enabled, another atomic path, not tested.</a:t>
             </a:r>
             <a:endParaRPr lang="en-US" dirty="0"/>
           </a:p>
@@ -869,12 +869,12 @@
             <a:r>
               <a:rPr lang="en-US" dirty="0"/>
               <a:t>1:00 → 2:00 (60 s)
-Passer au terminal, commande déjà tapée : node scripts/demo.mjs --auto (56 s mesurées). Une phrase par scène :
-1. Vault, dépôt, broker, couverture, et un prêt qui prend tout.
-2. Elle veut sortir : refusé.
-3. L'acheteur s'inscrit, deux escrows, il révèle le secret, elle le relit dans le ledger et encaisse.
-4. L'emprunteur rembourse. C'est l'acheteur, qui n'a jamais déposé, qui retire, avec le rendement.
-Si rien ne bouge pendant 15 s : Ctrl+C, revenir sur cette slide. Le terminal de droite est le run de référence, hashes dans le README.</a:t>
+Switch to the terminal, command already typed: node scripts/demo.mjs --auto (56 s measured). One sentence per scene:
+1. Vault, deposit, broker, cover, and a loan that takes everything.
+2. She wants out: refused.
+3. The buyer opts in, two escrows, he reveals the secret, she reads it back from the ledger and collects.
+4. The borrower repays. The buyer, who never deposited, is the one who withdraws, with the yield.
+If nothing moves for 15 s: Ctrl+C, come back to this slide. The terminal on the right is the reference run, hashes in the README.</a:t>
             </a:r>
             <a:endParaRPr lang="en-US" dirty="0"/>
           </a:p>
@@ -963,7 +963,7 @@
             <a:r>
               <a:rPr lang="en-US" dirty="0"/>
               <a:t>2:00 → 2:10 (10 s)
-Les huit étapes du minimum bar dans un seul run, chaque hash dans le README. Les quinze types XLS-65 et XLS-66 soumis au ledger, tous typés dans xrpl 4.6.0. Maintenant, les trois frictions les plus importantes, chacune avec sa correction.</a:t>
+The eight minimum bar steps in a single run, every hash in the README. The fifteen XLS-65 and XLS-66 types submitted to the ledger, all typed in xrpl 4.6.0. Now, the three most important frictions, each with its fix.</a:t>
             </a:r>
             <a:endParaRPr lang="en-US" dirty="0"/>
           </a:p>
@@ -1052,8 +1052,8 @@
             <a:r>
               <a:rPr lang="en-US" dirty="0"/>
               <a:t>2:10 → 2:40 (30 s)
-Un : fixCleanup3_4_0 est actif sur le devnet et absent d'xrpl.org. Il change deux choses. L'impairment : le tutoriel dit d'impairer avant l'échéance, le ledger répond tecTOO_SOON jusqu'à l'échéance, à gauche. La signature de l'emprunteur sur LoanSet : nouveau préfixe, que le helper de xrpl 4.6.0 n'utilise pas, à droite.
-Correction : lister l'amendement sur xrpl.org, mettre à jour le tutoriel, signer avec encodeForSigningCounterparty dans xrpl.js.</a:t>
+One: fixCleanup3_4_0 is enabled on the devnet and missing from xrpl.org. It changes two things. Impairment: the tutorial says to impair before the due date, the ledger answers tecTOO_SOON until the due date, on the left. The borrower's signature on LoanSet: a new prefix, which the xrpl 4.6.0 helper does not use, on the right.
+Fix: list the amendment on xrpl.org, update the tutorial, sign with encodeForSigningCounterparty in xrpl.js.</a:t>
             </a:r>
             <a:endParaRPr lang="en-US" dirty="0"/>
           </a:p>
@@ -1142,8 +1142,8 @@
             <a:r>
               <a:rPr lang="en-US" dirty="0"/>
               <a:t>2:40 → 3:05 (25 s)
-Deux : un prêt 10 secondes en retard, dans son délai de grâce. Sans flag : tecEXPIRED, à gauche. Avec tfLoanLatePayment : succès, à droite, et l'explorer affiche ce flag en hexadécimal. L'échec est défini dans XLS-66, mais pas dans la référence LoanPay d'xrpl.org.
-Correction : ajouter tecEXPIRED à la référence avec le flag comme remède, et nommer le flag dans l'explorer.</a:t>
+Two: a loan 10 seconds late, within its grace period. Without the flag: tecEXPIRED, on the left. With tfLoanLatePayment: success, on the right, and the explorer shows that flag in hex. The failure is defined in XLS-66, but not in the xrpl.org LoanPay reference.
+Fix: add tecEXPIRED to the reference with the flag as the remedy, and name the flag in the explorer.</a:t>
             </a:r>
             <a:endParaRPr lang="en-US" dirty="0"/>
           </a:p>
@@ -1232,8 +1232,8 @@
             <a:r>
               <a:rPr lang="en-US" dirty="0"/>
               <a:t>3:05 → 3:35 (30 s)
-Trois : broker à couverture minimale 10 %, liquidation 5 %. Défaut sur un prêt de 4 XRP. L'explorer montre 0,02 XRP pris sur la couverture : 4 × 10 % × 5 %, au drop près. Le déposant perd 3,98 XRP. C'est la formule documentée. En dessous : 21 secondes après le défaut, le broker retire les 0,98 XRP restants, parce que la dette, et donc le plancher, sont à zéro.
-Correction : afficher la part d'un défaut que la couverture absorbe, et un délai de retrait après un défaut.</a:t>
+Three: a broker with 10% minimum cover, 5% liquidation. Default on a 4 XRP loan. The explorer shows 0.02 XRP taken from the cover: 4 × 10% × 5%, to the drop. The depositor loses 3.98 XRP. That is the documented formula. Below: 21 seconds after the default, by ledger close time, the broker withdraws the remaining 0.98 XRP, because the debt, and so the floor, are at zero.
+Fix: show the share of a default the cover absorbs, and a withdrawal delay after a default.</a:t>
             </a:r>
             <a:endParaRPr lang="en-US" dirty="0"/>
           </a:p>
@@ -1322,7 +1322,7 @@
             <a:r>
               <a:rPr lang="en-US" dirty="0"/>
               <a:t>3:35 → 3:50 (15 s)
-Sept autres constats, chacun avec sa sévérité et sa correction dans le rapport. Citer seulement le 7 : la branche du hackathon a retiré la restriction V1.1 sur LoanBrokerSet, et le brief ne le dit pas.</a:t>
+Six more findings, each with its category, severity, repro steps and fix in the report. Only mention number 7: the hackathon branch reverted the V1.1 restriction on LoanBrokerSet, and the brief does not say so.</a:t>
             </a:r>
             <a:endParaRPr lang="en-US" dirty="0"/>
           </a:p>
@@ -1977,7 +1977,7 @@
                 <a:ea typeface="Poppins Light" pitchFamily="34" charset="-122"/>
                 <a:cs typeface="Poppins Light" pitchFamily="34" charset="-120"/>
               </a:rPr>
-              <a:t>Un vault open-ended promet le retrait à tout moment.</a:t>
+              <a:t>An open-ended vault promises withdrawal at any time.</a:t>
             </a:r>
             <a:endParaRPr lang="en-US" sz="1900" dirty="0"/>
           </a:p>
@@ -1997,7 +1997,7 @@
                 <a:ea typeface="Poppins Light" pitchFamily="34" charset="-122"/>
                 <a:cs typeface="Poppins Light" pitchFamily="34" charset="-120"/>
               </a:rPr>
-              <a:t>Il ne peut plus le tenir dès qu'il fonctionne bien.</a:t>
+              <a:t>It can no longer keep that promise once it works well.</a:t>
             </a:r>
             <a:endParaRPr lang="en-US" sz="1900" dirty="0"/>
           </a:p>
@@ -2036,7 +2036,7 @@
                 <a:ea typeface="Poppins" pitchFamily="34" charset="-122"/>
                 <a:cs typeface="Poppins" pitchFamily="34" charset="-120"/>
               </a:rPr>
-              <a:t>CY-HACK   ·   Track 1, vault open-ended   ·   Custom Hackathon Devnet   ·   xrpl@4.6.0</a:t>
+              <a:t>CY-HACK   ·   Track 1, open-ended vault   ·   Custom Hackathon Devnet   ·   xrpl@4.6.0</a:t>
             </a:r>
             <a:endParaRPr lang="en-US" sz="1100" dirty="0"/>
           </a:p>
@@ -2106,34 +2106,34 @@
         </p:nvSpPr>
         <p:spPr>
           <a:xfrm>
-            <a:off x="804672" y="713232"/>
-            <a:ext cx="10579608" cy="658368"/>
-          </a:xfrm>
-          <a:prstGeom prst="rect">
-            <a:avLst/>
-          </a:prstGeom>
-          <a:noFill/>
-          <a:ln/>
-        </p:spPr>
-        <p:txBody>
-          <a:bodyPr wrap="square" lIns="0" tIns="0" rIns="0" bIns="0" rtlCol="0" anchor="t"/>
-          <a:lstStyle/>
-          <a:p>
-            <a:pPr algn="l" indent="0" marL="0">
-              <a:buNone/>
-            </a:pPr>
-            <a:r>
-              <a:rPr lang="en-US" sz="3200" b="1" dirty="0">
-                <a:solidFill>
-                  <a:srgbClr val="FFFFFF"/>
+            <a:off x="10287000" y="6382512"/>
+            <a:ext cx="1097280" cy="228600"/>
+          </a:xfrm>
+          <a:prstGeom prst="rect">
+            <a:avLst/>
+          </a:prstGeom>
+          <a:noFill/>
+          <a:ln/>
+        </p:spPr>
+        <p:txBody>
+          <a:bodyPr wrap="square" lIns="0" tIns="0" rIns="0" bIns="0" rtlCol="0" anchor="ctr"/>
+          <a:lstStyle/>
+          <a:p>
+            <a:pPr algn="r" indent="0" marL="0">
+              <a:buNone/>
+            </a:pPr>
+            <a:r>
+              <a:rPr lang="en-US" sz="1000" dirty="0">
+                <a:solidFill>
+                  <a:srgbClr val="C9D4E8"/>
                 </a:solidFill>
                 <a:latin typeface="Poppins" pitchFamily="34" charset="0"/>
                 <a:ea typeface="Poppins" pitchFamily="34" charset="-122"/>
                 <a:cs typeface="Poppins" pitchFamily="34" charset="-120"/>
               </a:rPr>
-              <a:t>Dix constats, trois pages</a:t>
-            </a:r>
-            <a:endParaRPr lang="en-US" sz="3200" dirty="0"/>
+              <a:t>10 / 10</a:t>
+            </a:r>
+            <a:endParaRPr lang="en-US" sz="1000" dirty="0"/>
           </a:p>
         </p:txBody>
       </p:sp>
@@ -2145,8 +2145,8 @@
         </p:nvSpPr>
         <p:spPr>
           <a:xfrm>
-            <a:off x="768096" y="1965960"/>
-            <a:ext cx="7315200" cy="1143000"/>
+            <a:off x="804672" y="713232"/>
+            <a:ext cx="10579608" cy="658368"/>
           </a:xfrm>
           <a:prstGeom prst="rect">
             <a:avLst/>
@@ -2162,14 +2162,53 @@
               <a:buNone/>
             </a:pPr>
             <a:r>
-              <a:rPr lang="en-US" sz="7600" b="1" dirty="0">
-                <a:solidFill>
-                  <a:srgbClr val="6DC3FF"/>
+              <a:rPr lang="en-US" sz="3200" b="1" dirty="0">
+                <a:solidFill>
+                  <a:srgbClr val="FFFFFF"/>
                 </a:solidFill>
                 <a:latin typeface="Poppins" pitchFamily="34" charset="0"/>
                 <a:ea typeface="Poppins" pitchFamily="34" charset="-122"/>
                 <a:cs typeface="Poppins" pitchFamily="34" charset="-120"/>
               </a:rPr>
+              <a:t>Nine findings, three pages</a:t>
+            </a:r>
+            <a:endParaRPr lang="en-US" sz="3200" dirty="0"/>
+          </a:p>
+        </p:txBody>
+      </p:sp>
+      <p:sp>
+        <p:nvSpPr>
+          <p:cNvPr id="5" name="Text 2"/>
+          <p:cNvSpPr txBox="1"/>
+          <p:nvPr/>
+        </p:nvSpPr>
+        <p:spPr>
+          <a:xfrm>
+            <a:off x="768096" y="1965960"/>
+            <a:ext cx="7315200" cy="1143000"/>
+          </a:xfrm>
+          <a:prstGeom prst="rect">
+            <a:avLst/>
+          </a:prstGeom>
+          <a:noFill/>
+          <a:ln/>
+        </p:spPr>
+        <p:txBody>
+          <a:bodyPr wrap="square" lIns="0" tIns="0" rIns="0" bIns="0" rtlCol="0" anchor="t"/>
+          <a:lstStyle/>
+          <a:p>
+            <a:pPr algn="l" indent="0" marL="0">
+              <a:buNone/>
+            </a:pPr>
+            <a:r>
+              <a:rPr lang="en-US" sz="7600" b="1" dirty="0">
+                <a:solidFill>
+                  <a:srgbClr val="6DC3FF"/>
+                </a:solidFill>
+                <a:latin typeface="Poppins" pitchFamily="34" charset="0"/>
+                <a:ea typeface="Poppins" pitchFamily="34" charset="-122"/>
+                <a:cs typeface="Poppins" pitchFamily="34" charset="-120"/>
+              </a:rPr>
               <a:t>143 / 143</a:t>
             </a:r>
             <a:endParaRPr lang="en-US" sz="7600" dirty="0"/>
@@ -2178,7 +2217,7 @@
       </p:sp>
       <p:sp>
         <p:nvSpPr>
-          <p:cNvPr id="5" name="Text 2"/>
+          <p:cNvPr id="6" name="Text 3"/>
           <p:cNvSpPr txBox="1"/>
           <p:nvPr/>
         </p:nvSpPr>
@@ -2209,7 +2248,7 @@
                 <a:ea typeface="Poppins Light" pitchFamily="34" charset="-122"/>
                 <a:cs typeface="Poppins Light" pitchFamily="34" charset="-120"/>
               </a:rPr>
-              <a:t>hashes cités, relus sur le ledger avant soumission</a:t>
+              <a:t>hashes cited, re-checked on the ledger before submission</a:t>
             </a:r>
             <a:endParaRPr lang="en-US" sz="1900" dirty="0"/>
           </a:p>
@@ -2217,7 +2256,7 @@
       </p:sp>
       <p:sp>
         <p:nvSpPr>
-          <p:cNvPr id="6" name="Shape 3"/>
+          <p:cNvPr id="7" name="Shape 4"/>
           <p:cNvSpPr/>
           <p:nvPr/>
         </p:nvSpPr>
@@ -2237,7 +2276,7 @@
       </p:sp>
       <p:sp>
         <p:nvSpPr>
-          <p:cNvPr id="7" name="Text 4"/>
+          <p:cNvPr id="8" name="Text 5"/>
           <p:cNvSpPr txBox="1"/>
           <p:nvPr/>
         </p:nvSpPr>
@@ -2276,7 +2315,7 @@
       </p:sp>
       <p:sp>
         <p:nvSpPr>
-          <p:cNvPr id="8" name="Shape 5"/>
+          <p:cNvPr id="9" name="Shape 6"/>
           <p:cNvSpPr/>
           <p:nvPr/>
         </p:nvSpPr>
@@ -2298,7 +2337,7 @@
       </p:sp>
       <p:sp>
         <p:nvSpPr>
-          <p:cNvPr id="9" name="Text 6"/>
+          <p:cNvPr id="10" name="Text 7"/>
           <p:cNvSpPr txBox="1"/>
           <p:nvPr/>
         </p:nvSpPr>
@@ -2337,7 +2376,7 @@
       </p:sp>
       <p:sp>
         <p:nvSpPr>
-          <p:cNvPr id="10" name="Shape 7"/>
+          <p:cNvPr id="11" name="Shape 8"/>
           <p:cNvSpPr/>
           <p:nvPr/>
         </p:nvSpPr>
@@ -2359,7 +2398,7 @@
       </p:sp>
       <p:sp>
         <p:nvSpPr>
-          <p:cNvPr id="11" name="Text 8"/>
+          <p:cNvPr id="12" name="Text 9"/>
           <p:cNvSpPr txBox="1"/>
           <p:nvPr/>
         </p:nvSpPr>
@@ -2460,34 +2499,34 @@
         </p:nvSpPr>
         <p:spPr>
           <a:xfrm>
-            <a:off x="804672" y="713232"/>
-            <a:ext cx="10579608" cy="658368"/>
-          </a:xfrm>
-          <a:prstGeom prst="rect">
-            <a:avLst/>
-          </a:prstGeom>
-          <a:noFill/>
-          <a:ln/>
-        </p:spPr>
-        <p:txBody>
-          <a:bodyPr wrap="square" lIns="0" tIns="0" rIns="0" bIns="0" rtlCol="0" anchor="t"/>
-          <a:lstStyle/>
-          <a:p>
-            <a:pPr algn="l" indent="0" marL="0">
-              <a:buNone/>
-            </a:pPr>
-            <a:r>
-              <a:rPr lang="en-US" sz="3200" b="1" dirty="0">
-                <a:solidFill>
-                  <a:srgbClr val="001C5C"/>
+            <a:off x="10287000" y="6382512"/>
+            <a:ext cx="1097280" cy="228600"/>
+          </a:xfrm>
+          <a:prstGeom prst="rect">
+            <a:avLst/>
+          </a:prstGeom>
+          <a:noFill/>
+          <a:ln/>
+        </p:spPr>
+        <p:txBody>
+          <a:bodyPr wrap="square" lIns="0" tIns="0" rIns="0" bIns="0" rtlCol="0" anchor="ctr"/>
+          <a:lstStyle/>
+          <a:p>
+            <a:pPr algn="r" indent="0" marL="0">
+              <a:buNone/>
+            </a:pPr>
+            <a:r>
+              <a:rPr lang="en-US" sz="1000" dirty="0">
+                <a:solidFill>
+                  <a:srgbClr val="8A9199"/>
                 </a:solidFill>
                 <a:latin typeface="Poppins" pitchFamily="34" charset="0"/>
                 <a:ea typeface="Poppins" pitchFamily="34" charset="-122"/>
                 <a:cs typeface="Poppins" pitchFamily="34" charset="-120"/>
               </a:rPr>
-              <a:t>Ouvert en droit, fermé en fait</a:t>
-            </a:r>
-            <a:endParaRPr lang="en-US" sz="3200" dirty="0"/>
+              <a:t>2 / 10</a:t>
+            </a:r>
+            <a:endParaRPr lang="en-US" sz="1000" dirty="0"/>
           </a:p>
         </p:txBody>
       </p:sp>
@@ -2499,8 +2538,8 @@
         </p:nvSpPr>
         <p:spPr>
           <a:xfrm>
-            <a:off x="804672" y="1828800"/>
-            <a:ext cx="4389120" cy="633046"/>
+            <a:off x="804672" y="713232"/>
+            <a:ext cx="10579608" cy="658368"/>
           </a:xfrm>
           <a:prstGeom prst="rect">
             <a:avLst/>
@@ -2516,17 +2555,17 @@
               <a:buNone/>
             </a:pPr>
             <a:r>
-              <a:rPr lang="en-US" sz="3600" b="1" dirty="0">
-                <a:solidFill>
-                  <a:srgbClr val="006AFF"/>
+              <a:rPr lang="en-US" sz="3200" b="1" dirty="0">
+                <a:solidFill>
+                  <a:srgbClr val="001C5C"/>
                 </a:solidFill>
                 <a:latin typeface="Poppins" pitchFamily="34" charset="0"/>
                 <a:ea typeface="Poppins" pitchFamily="34" charset="-122"/>
                 <a:cs typeface="Poppins" pitchFamily="34" charset="-120"/>
               </a:rPr>
-              <a:t>100 %</a:t>
-            </a:r>
-            <a:endParaRPr lang="en-US" sz="3600" dirty="0"/>
+              <a:t>Open on paper, closed in practice</a:t>
+            </a:r>
+            <a:endParaRPr lang="en-US" sz="3200" dirty="0"/>
           </a:p>
         </p:txBody>
       </p:sp>
@@ -2538,8 +2577,8 @@
         </p:nvSpPr>
         <p:spPr>
           <a:xfrm>
-            <a:off x="804672" y="2480134"/>
-            <a:ext cx="4389120" cy="274320"/>
+            <a:off x="804672" y="1828800"/>
+            <a:ext cx="4389120" cy="633046"/>
           </a:xfrm>
           <a:prstGeom prst="rect">
             <a:avLst/>
@@ -2555,17 +2594,17 @@
               <a:buNone/>
             </a:pPr>
             <a:r>
-              <a:rPr lang="en-US" sz="1300" dirty="0">
-                <a:solidFill>
-                  <a:srgbClr val="5F666E"/>
+              <a:rPr lang="en-US" sz="3600" b="1" dirty="0">
+                <a:solidFill>
+                  <a:srgbClr val="006AFF"/>
                 </a:solidFill>
                 <a:latin typeface="Poppins" pitchFamily="34" charset="0"/>
                 <a:ea typeface="Poppins" pitchFamily="34" charset="-122"/>
                 <a:cs typeface="Poppins" pitchFamily="34" charset="-120"/>
               </a:rPr>
-              <a:t>du vault prêté par un seul LoanSet</a:t>
-            </a:r>
-            <a:endParaRPr lang="en-US" sz="1300" dirty="0"/>
+              <a:t>100%</a:t>
+            </a:r>
+            <a:endParaRPr lang="en-US" sz="3600" dirty="0"/>
           </a:p>
         </p:txBody>
       </p:sp>
@@ -2577,8 +2616,8 @@
         </p:nvSpPr>
         <p:spPr>
           <a:xfrm>
-            <a:off x="804672" y="3108960"/>
-            <a:ext cx="4389120" cy="633046"/>
+            <a:off x="804672" y="2480134"/>
+            <a:ext cx="4389120" cy="274320"/>
           </a:xfrm>
           <a:prstGeom prst="rect">
             <a:avLst/>
@@ -2594,17 +2633,17 @@
               <a:buNone/>
             </a:pPr>
             <a:r>
-              <a:rPr lang="en-US" sz="3600" b="1" dirty="0">
-                <a:solidFill>
-                  <a:srgbClr val="F2703A"/>
+              <a:rPr lang="en-US" sz="1300" dirty="0">
+                <a:solidFill>
+                  <a:srgbClr val="5F666E"/>
                 </a:solidFill>
                 <a:latin typeface="Poppins" pitchFamily="34" charset="0"/>
                 <a:ea typeface="Poppins" pitchFamily="34" charset="-122"/>
                 <a:cs typeface="Poppins" pitchFamily="34" charset="-120"/>
               </a:rPr>
-              <a:t>0 XRP</a:t>
-            </a:r>
-            <a:endParaRPr lang="en-US" sz="3600" dirty="0"/>
+              <a:t>of the vault lent by a single LoanSet</a:t>
+            </a:r>
+            <a:endParaRPr lang="en-US" sz="1300" dirty="0"/>
           </a:p>
         </p:txBody>
       </p:sp>
@@ -2616,8 +2655,8 @@
         </p:nvSpPr>
         <p:spPr>
           <a:xfrm>
-            <a:off x="804672" y="3760294"/>
-            <a:ext cx="4389120" cy="274320"/>
+            <a:off x="804672" y="3108960"/>
+            <a:ext cx="4389120" cy="633046"/>
           </a:xfrm>
           <a:prstGeom prst="rect">
             <a:avLst/>
@@ -2633,17 +2672,17 @@
               <a:buNone/>
             </a:pPr>
             <a:r>
-              <a:rPr lang="en-US" sz="1300" dirty="0">
-                <a:solidFill>
-                  <a:srgbClr val="5F666E"/>
+              <a:rPr lang="en-US" sz="3600" b="1" dirty="0">
+                <a:solidFill>
+                  <a:srgbClr val="F2703A"/>
                 </a:solidFill>
                 <a:latin typeface="Poppins" pitchFamily="34" charset="0"/>
                 <a:ea typeface="Poppins" pitchFamily="34" charset="-122"/>
                 <a:cs typeface="Poppins" pitchFamily="34" charset="-120"/>
               </a:rPr>
-              <a:t>retirable par la déposante</a:t>
-            </a:r>
-            <a:endParaRPr lang="en-US" sz="1300" dirty="0"/>
+              <a:t>0 XRP</a:t>
+            </a:r>
+            <a:endParaRPr lang="en-US" sz="3600" dirty="0"/>
           </a:p>
         </p:txBody>
       </p:sp>
@@ -2655,8 +2694,8 @@
         </p:nvSpPr>
         <p:spPr>
           <a:xfrm>
-            <a:off x="804672" y="4389120"/>
-            <a:ext cx="4389120" cy="633046"/>
+            <a:off x="804672" y="3760294"/>
+            <a:ext cx="4389120" cy="274320"/>
           </a:xfrm>
           <a:prstGeom prst="rect">
             <a:avLst/>
@@ -2672,17 +2711,17 @@
               <a:buNone/>
             </a:pPr>
             <a:r>
-              <a:rPr lang="en-US" sz="3600" b="1" dirty="0">
-                <a:solidFill>
-                  <a:srgbClr val="001C5C"/>
+              <a:rPr lang="en-US" sz="1300" dirty="0">
+                <a:solidFill>
+                  <a:srgbClr val="5F666E"/>
                 </a:solidFill>
                 <a:latin typeface="Poppins" pitchFamily="34" charset="0"/>
                 <a:ea typeface="Poppins" pitchFamily="34" charset="-122"/>
                 <a:cs typeface="Poppins" pitchFamily="34" charset="-120"/>
               </a:rPr>
-              <a:t>4 mois</a:t>
-            </a:r>
-            <a:endParaRPr lang="en-US" sz="3600" dirty="0"/>
+              <a:t>withdrawable by the depositor</a:t>
+            </a:r>
+            <a:endParaRPr lang="en-US" sz="1300" dirty="0"/>
           </a:p>
         </p:txBody>
       </p:sp>
@@ -2694,8 +2733,8 @@
         </p:nvSpPr>
         <p:spPr>
           <a:xfrm>
-            <a:off x="804672" y="5040454"/>
-            <a:ext cx="4389120" cy="274320"/>
+            <a:off x="804672" y="4389120"/>
+            <a:ext cx="4389120" cy="633046"/>
           </a:xfrm>
           <a:prstGeom prst="rect">
             <a:avLst/>
@@ -2711,15 +2750,54 @@
               <a:buNone/>
             </a:pPr>
             <a:r>
-              <a:rPr lang="en-US" sz="1300" dirty="0">
-                <a:solidFill>
-                  <a:srgbClr val="5F666E"/>
+              <a:rPr lang="en-US" sz="3600" b="1" dirty="0">
+                <a:solidFill>
+                  <a:srgbClr val="001C5C"/>
                 </a:solidFill>
                 <a:latin typeface="Poppins" pitchFamily="34" charset="0"/>
                 <a:ea typeface="Poppins" pitchFamily="34" charset="-122"/>
                 <a:cs typeface="Poppins" pitchFamily="34" charset="-120"/>
               </a:rPr>
-              <a:t>avant la dernière échéance</a:t>
+              <a:t>4 months</a:t>
+            </a:r>
+            <a:endParaRPr lang="en-US" sz="3600" dirty="0"/>
+          </a:p>
+        </p:txBody>
+      </p:sp>
+      <p:sp>
+        <p:nvSpPr>
+          <p:cNvPr id="10" name="Text 7"/>
+          <p:cNvSpPr txBox="1"/>
+          <p:nvPr/>
+        </p:nvSpPr>
+        <p:spPr>
+          <a:xfrm>
+            <a:off x="804672" y="5040454"/>
+            <a:ext cx="4389120" cy="274320"/>
+          </a:xfrm>
+          <a:prstGeom prst="rect">
+            <a:avLst/>
+          </a:prstGeom>
+          <a:noFill/>
+          <a:ln/>
+        </p:spPr>
+        <p:txBody>
+          <a:bodyPr wrap="square" lIns="0" tIns="0" rIns="0" bIns="0" rtlCol="0" anchor="t"/>
+          <a:lstStyle/>
+          <a:p>
+            <a:pPr algn="l" indent="0" marL="0">
+              <a:buNone/>
+            </a:pPr>
+            <a:r>
+              <a:rPr lang="en-US" sz="1300" dirty="0">
+                <a:solidFill>
+                  <a:srgbClr val="5F666E"/>
+                </a:solidFill>
+                <a:latin typeface="Poppins" pitchFamily="34" charset="0"/>
+                <a:ea typeface="Poppins" pitchFamily="34" charset="-122"/>
+                <a:cs typeface="Poppins" pitchFamily="34" charset="-120"/>
+              </a:rPr>
+              <a:t>until the last payment is due</a:t>
             </a:r>
             <a:endParaRPr lang="en-US" sz="1300" dirty="0"/>
           </a:p>
@@ -2727,7 +2805,7 @@
       </p:sp>
       <p:sp>
         <p:nvSpPr>
-          <p:cNvPr id="10" name="Shape 7"/>
+          <p:cNvPr id="11" name="Shape 8"/>
           <p:cNvSpPr/>
           <p:nvPr/>
         </p:nvSpPr>
@@ -2754,7 +2832,7 @@
       </p:sp>
       <p:sp>
         <p:nvSpPr>
-          <p:cNvPr id="11" name="Shape 8"/>
+          <p:cNvPr id="12" name="Shape 9"/>
           <p:cNvSpPr/>
           <p:nvPr/>
         </p:nvSpPr>
@@ -2774,7 +2852,7 @@
       </p:sp>
       <p:sp>
         <p:nvSpPr>
-          <p:cNvPr id="12" name="Shape 9"/>
+          <p:cNvPr id="13" name="Shape 10"/>
           <p:cNvSpPr/>
           <p:nvPr/>
         </p:nvSpPr>
@@ -2794,7 +2872,7 @@
       </p:sp>
       <p:sp>
         <p:nvSpPr>
-          <p:cNvPr id="13" name="Shape 10"/>
+          <p:cNvPr id="14" name="Shape 11"/>
           <p:cNvSpPr/>
           <p:nvPr/>
         </p:nvSpPr>
@@ -2814,7 +2892,7 @@
       </p:sp>
       <p:sp>
         <p:nvSpPr>
-          <p:cNvPr id="14" name="Text 11"/>
+          <p:cNvPr id="15" name="Text 12"/>
           <p:cNvSpPr txBox="1"/>
           <p:nvPr/>
         </p:nvSpPr>
@@ -2853,7 +2931,7 @@
       </p:sp>
       <p:sp>
         <p:nvSpPr>
-          <p:cNvPr id="15" name="Shape 12"/>
+          <p:cNvPr id="16" name="Shape 13"/>
           <p:cNvSpPr/>
           <p:nvPr/>
         </p:nvSpPr>
@@ -2873,7 +2951,7 @@
       </p:sp>
       <p:pic>
         <p:nvPicPr>
-          <p:cNvPr id="16" name="Image 1" descr="/Users/charlypupier/Documents/Hackathon XRPL/xrpl-lending/deck/shots/d-wall-type.png">    </p:cNvPr>
+          <p:cNvPr id="17" name="Image 1" descr="/Users/charlypupier/Documents/Hackathon XRPL/xrpl-lending/deck/shots/d-wall-type.png">    </p:cNvPr>
           <p:cNvPicPr>
             <a:picLocks noChangeAspect="1"/>
           </p:cNvPicPr>
@@ -2897,7 +2975,7 @@
       </p:pic>
       <p:pic>
         <p:nvPicPr>
-          <p:cNvPr id="17" name="Image 2" descr="/Users/charlypupier/Documents/Hackathon XRPL/xrpl-lending/deck/shots/d-wall-status.png">    </p:cNvPr>
+          <p:cNvPr id="18" name="Image 2" descr="/Users/charlypupier/Documents/Hackathon XRPL/xrpl-lending/deck/shots/d-wall-status.png">    </p:cNvPr>
           <p:cNvPicPr>
             <a:picLocks noChangeAspect="1"/>
           </p:cNvPicPr>
@@ -2919,6 +2997,45 @@
           </a:prstGeom>
         </p:spPr>
       </p:pic>
+      <p:sp>
+        <p:nvSpPr>
+          <p:cNvPr id="19" name="Text 14"/>
+          <p:cNvSpPr txBox="1"/>
+          <p:nvPr/>
+        </p:nvSpPr>
+        <p:spPr>
+          <a:xfrm>
+            <a:off x="5532120" y="5050669"/>
+            <a:ext cx="5852160" cy="201168"/>
+          </a:xfrm>
+          <a:prstGeom prst="rect">
+            <a:avLst/>
+          </a:prstGeom>
+          <a:noFill/>
+          <a:ln/>
+        </p:spPr>
+        <p:txBody>
+          <a:bodyPr wrap="square" lIns="0" tIns="0" rIns="0" bIns="0" rtlCol="0" anchor="t"/>
+          <a:lstStyle/>
+          <a:p>
+            <a:pPr algn="l" indent="0" marL="0">
+              <a:buNone/>
+            </a:pPr>
+            <a:r>
+              <a:rPr lang="en-US" sz="1150" dirty="0">
+                <a:solidFill>
+                  <a:srgbClr val="5F666E"/>
+                </a:solidFill>
+                <a:latin typeface="Poppins Light" pitchFamily="34" charset="0"/>
+                <a:ea typeface="Poppins Light" pitchFamily="34" charset="-122"/>
+                <a:cs typeface="Poppins Light" pitchFamily="34" charset="-120"/>
+              </a:rPr>
+              <a:t>The depositor's withdrawal: refused, the loan took the whole vault.</a:t>
+            </a:r>
+            <a:endParaRPr lang="en-US" sz="1150" dirty="0"/>
+          </a:p>
+        </p:txBody>
+      </p:sp>
     </p:spTree>
   </p:cSld>
   <p:clrMapOvr>
@@ -2983,110 +3100,149 @@
         </p:nvSpPr>
         <p:spPr>
           <a:xfrm>
-            <a:off x="804672" y="713232"/>
-            <a:ext cx="10579608" cy="658368"/>
-          </a:xfrm>
-          <a:prstGeom prst="rect">
-            <a:avLst/>
-          </a:prstGeom>
-          <a:noFill/>
-          <a:ln/>
-        </p:spPr>
-        <p:txBody>
-          <a:bodyPr wrap="square" lIns="0" tIns="0" rIns="0" bIns="0" rtlCol="0" anchor="t"/>
-          <a:lstStyle/>
-          <a:p>
-            <a:pPr algn="l" indent="0" marL="0">
-              <a:buNone/>
-            </a:pPr>
-            <a:r>
-              <a:rPr lang="en-US" sz="3200" b="1" dirty="0">
-                <a:solidFill>
-                  <a:srgbClr val="001C5C"/>
+            <a:off x="10287000" y="6382512"/>
+            <a:ext cx="1097280" cy="228600"/>
+          </a:xfrm>
+          <a:prstGeom prst="rect">
+            <a:avLst/>
+          </a:prstGeom>
+          <a:noFill/>
+          <a:ln/>
+        </p:spPr>
+        <p:txBody>
+          <a:bodyPr wrap="square" lIns="0" tIns="0" rIns="0" bIns="0" rtlCol="0" anchor="ctr"/>
+          <a:lstStyle/>
+          <a:p>
+            <a:pPr algn="r" indent="0" marL="0">
+              <a:buNone/>
+            </a:pPr>
+            <a:r>
+              <a:rPr lang="en-US" sz="1000" dirty="0">
+                <a:solidFill>
+                  <a:srgbClr val="8A9199"/>
                 </a:solidFill>
                 <a:latin typeface="Poppins" pitchFamily="34" charset="0"/>
                 <a:ea typeface="Poppins" pitchFamily="34" charset="-122"/>
                 <a:cs typeface="Poppins" pitchFamily="34" charset="-120"/>
               </a:rPr>
-              <a:t>Céder la part de vault, pas le prêt</a:t>
-            </a:r>
-            <a:endParaRPr lang="en-US" sz="3200" dirty="0"/>
-          </a:p>
-        </p:txBody>
-      </p:sp>
-      <p:sp>
-        <p:nvSpPr>
-          <p:cNvPr id="4" name="Shape 1"/>
-          <p:cNvSpPr/>
-          <p:nvPr/>
-        </p:nvSpPr>
-        <p:spPr>
-          <a:xfrm>
-            <a:off x="1033272" y="2395728"/>
-            <a:ext cx="7934706" cy="9144"/>
-          </a:xfrm>
-          <a:prstGeom prst="rect">
-            <a:avLst/>
-          </a:prstGeom>
-          <a:solidFill>
-            <a:srgbClr val="E2E5E8"/>
-          </a:solidFill>
-          <a:ln/>
-        </p:spPr>
-      </p:sp>
-      <p:sp>
-        <p:nvSpPr>
-          <p:cNvPr id="5" name="Shape 2"/>
-          <p:cNvSpPr/>
-          <p:nvPr/>
-        </p:nvSpPr>
-        <p:spPr>
-          <a:xfrm>
-            <a:off x="804672" y="2167128"/>
-            <a:ext cx="457200" cy="457200"/>
-          </a:xfrm>
-          <a:prstGeom prst="ellipse">
-            <a:avLst/>
-          </a:prstGeom>
-          <a:solidFill>
-            <a:srgbClr val="006AFF"/>
-          </a:solidFill>
-          <a:ln/>
-        </p:spPr>
-      </p:sp>
-      <p:sp>
-        <p:nvSpPr>
-          <p:cNvPr id="6" name="Text 3"/>
-          <p:cNvSpPr txBox="1"/>
-          <p:nvPr/>
-        </p:nvSpPr>
-        <p:spPr>
-          <a:xfrm>
-            <a:off x="804672" y="2167128"/>
-            <a:ext cx="457200" cy="457200"/>
-          </a:xfrm>
-          <a:prstGeom prst="rect">
-            <a:avLst/>
-          </a:prstGeom>
-          <a:noFill/>
-          <a:ln/>
-        </p:spPr>
-        <p:txBody>
-          <a:bodyPr wrap="square" lIns="0" tIns="0" rIns="0" bIns="0" rtlCol="0" anchor="ctr"/>
-          <a:lstStyle/>
-          <a:p>
-            <a:pPr algn="ctr" indent="0" marL="0">
-              <a:buNone/>
-            </a:pPr>
-            <a:r>
-              <a:rPr lang="en-US" sz="1500" b="1" dirty="0">
-                <a:solidFill>
-                  <a:srgbClr val="FFFFFF"/>
+              <a:t>3 / 10</a:t>
+            </a:r>
+            <a:endParaRPr lang="en-US" sz="1000" dirty="0"/>
+          </a:p>
+        </p:txBody>
+      </p:sp>
+      <p:sp>
+        <p:nvSpPr>
+          <p:cNvPr id="4" name="Text 1"/>
+          <p:cNvSpPr txBox="1"/>
+          <p:nvPr/>
+        </p:nvSpPr>
+        <p:spPr>
+          <a:xfrm>
+            <a:off x="804672" y="713232"/>
+            <a:ext cx="10579608" cy="658368"/>
+          </a:xfrm>
+          <a:prstGeom prst="rect">
+            <a:avLst/>
+          </a:prstGeom>
+          <a:noFill/>
+          <a:ln/>
+        </p:spPr>
+        <p:txBody>
+          <a:bodyPr wrap="square" lIns="0" tIns="0" rIns="0" bIns="0" rtlCol="0" anchor="t"/>
+          <a:lstStyle/>
+          <a:p>
+            <a:pPr algn="l" indent="0" marL="0">
+              <a:buNone/>
+            </a:pPr>
+            <a:r>
+              <a:rPr lang="en-US" sz="3200" b="1" dirty="0">
+                <a:solidFill>
+                  <a:srgbClr val="001C5C"/>
                 </a:solidFill>
                 <a:latin typeface="Poppins" pitchFamily="34" charset="0"/>
                 <a:ea typeface="Poppins" pitchFamily="34" charset="-122"/>
                 <a:cs typeface="Poppins" pitchFamily="34" charset="-120"/>
               </a:rPr>
+              <a:t>Sell the vault share, not the loan</a:t>
+            </a:r>
+            <a:endParaRPr lang="en-US" sz="3200" dirty="0"/>
+          </a:p>
+        </p:txBody>
+      </p:sp>
+      <p:sp>
+        <p:nvSpPr>
+          <p:cNvPr id="5" name="Shape 2"/>
+          <p:cNvSpPr/>
+          <p:nvPr/>
+        </p:nvSpPr>
+        <p:spPr>
+          <a:xfrm>
+            <a:off x="1033272" y="2395728"/>
+            <a:ext cx="7934706" cy="9144"/>
+          </a:xfrm>
+          <a:prstGeom prst="rect">
+            <a:avLst/>
+          </a:prstGeom>
+          <a:solidFill>
+            <a:srgbClr val="E2E5E8"/>
+          </a:solidFill>
+          <a:ln/>
+        </p:spPr>
+      </p:sp>
+      <p:sp>
+        <p:nvSpPr>
+          <p:cNvPr id="6" name="Shape 3"/>
+          <p:cNvSpPr/>
+          <p:nvPr/>
+        </p:nvSpPr>
+        <p:spPr>
+          <a:xfrm>
+            <a:off x="804672" y="2167128"/>
+            <a:ext cx="457200" cy="457200"/>
+          </a:xfrm>
+          <a:prstGeom prst="ellipse">
+            <a:avLst/>
+          </a:prstGeom>
+          <a:solidFill>
+            <a:srgbClr val="006AFF"/>
+          </a:solidFill>
+          <a:ln/>
+        </p:spPr>
+      </p:sp>
+      <p:sp>
+        <p:nvSpPr>
+          <p:cNvPr id="7" name="Text 4"/>
+          <p:cNvSpPr txBox="1"/>
+          <p:nvPr/>
+        </p:nvSpPr>
+        <p:spPr>
+          <a:xfrm>
+            <a:off x="804672" y="2167128"/>
+            <a:ext cx="457200" cy="457200"/>
+          </a:xfrm>
+          <a:prstGeom prst="rect">
+            <a:avLst/>
+          </a:prstGeom>
+          <a:noFill/>
+          <a:ln/>
+        </p:spPr>
+        <p:txBody>
+          <a:bodyPr wrap="square" lIns="0" tIns="0" rIns="0" bIns="0" rtlCol="0" anchor="ctr"/>
+          <a:lstStyle/>
+          <a:p>
+            <a:pPr algn="ctr" indent="0" marL="0">
+              <a:buNone/>
+            </a:pPr>
+            <a:r>
+              <a:rPr lang="en-US" sz="1500" b="1" dirty="0">
+                <a:solidFill>
+                  <a:srgbClr val="FFFFFF"/>
+                </a:solidFill>
+                <a:latin typeface="Poppins" pitchFamily="34" charset="0"/>
+                <a:ea typeface="Poppins" pitchFamily="34" charset="-122"/>
+                <a:cs typeface="Poppins" pitchFamily="34" charset="-120"/>
+              </a:rPr>
               <a:t>1</a:t>
             </a:r>
             <a:endParaRPr lang="en-US" sz="1500" dirty="0"/>
@@ -3095,7 +3251,7 @@
       </p:sp>
       <p:sp>
         <p:nvSpPr>
-          <p:cNvPr id="7" name="Text 4"/>
+          <p:cNvPr id="8" name="Text 5"/>
           <p:cNvSpPr txBox="1"/>
           <p:nvPr/>
         </p:nvSpPr>
@@ -3129,7 +3285,7 @@
                 <a:ea typeface="Poppins Medium" pitchFamily="34" charset="-122"/>
                 <a:cs typeface="Poppins Medium" pitchFamily="34" charset="-120"/>
               </a:rPr>
-              <a:t>L'acheteur verrouille son paiement</a:t>
+              <a:t>The buyer locks the payment</a:t>
             </a:r>
             <a:endParaRPr lang="en-US" sz="1700" dirty="0"/>
           </a:p>
@@ -3137,7 +3293,7 @@
       </p:sp>
       <p:sp>
         <p:nvSpPr>
-          <p:cNvPr id="8" name="Shape 5"/>
+          <p:cNvPr id="9" name="Shape 6"/>
           <p:cNvSpPr/>
           <p:nvPr/>
         </p:nvSpPr>
@@ -3159,7 +3315,7 @@
       </p:sp>
       <p:sp>
         <p:nvSpPr>
-          <p:cNvPr id="9" name="Text 6"/>
+          <p:cNvPr id="10" name="Text 7"/>
           <p:cNvSpPr txBox="1"/>
           <p:nvPr/>
         </p:nvSpPr>
@@ -3198,7 +3354,7 @@
       </p:sp>
       <p:sp>
         <p:nvSpPr>
-          <p:cNvPr id="10" name="Shape 7"/>
+          <p:cNvPr id="11" name="Shape 8"/>
           <p:cNvSpPr/>
           <p:nvPr/>
         </p:nvSpPr>
@@ -3218,7 +3374,7 @@
       </p:sp>
       <p:sp>
         <p:nvSpPr>
-          <p:cNvPr id="11" name="Text 8"/>
+          <p:cNvPr id="12" name="Text 9"/>
           <p:cNvSpPr txBox="1"/>
           <p:nvPr/>
         </p:nvSpPr>
@@ -3257,7 +3413,7 @@
       </p:sp>
       <p:sp>
         <p:nvSpPr>
-          <p:cNvPr id="12" name="Text 9"/>
+          <p:cNvPr id="13" name="Text 10"/>
           <p:cNvSpPr txBox="1"/>
           <p:nvPr/>
         </p:nvSpPr>
@@ -3291,7 +3447,7 @@
                 <a:ea typeface="Poppins Medium" pitchFamily="34" charset="-122"/>
                 <a:cs typeface="Poppins Medium" pitchFamily="34" charset="-120"/>
               </a:rPr>
-              <a:t>La vendeuse verrouille ses parts</a:t>
+              <a:t>The seller locks her shares</a:t>
             </a:r>
             <a:endParaRPr lang="en-US" sz="1700" dirty="0"/>
           </a:p>
@@ -3299,7 +3455,7 @@
       </p:sp>
       <p:sp>
         <p:nvSpPr>
-          <p:cNvPr id="13" name="Shape 10"/>
+          <p:cNvPr id="14" name="Shape 11"/>
           <p:cNvSpPr/>
           <p:nvPr/>
         </p:nvSpPr>
@@ -3321,7 +3477,7 @@
       </p:sp>
       <p:sp>
         <p:nvSpPr>
-          <p:cNvPr id="14" name="Text 11"/>
+          <p:cNvPr id="15" name="Text 12"/>
           <p:cNvSpPr txBox="1"/>
           <p:nvPr/>
         </p:nvSpPr>
@@ -3360,7 +3516,7 @@
       </p:sp>
       <p:sp>
         <p:nvSpPr>
-          <p:cNvPr id="15" name="Shape 12"/>
+          <p:cNvPr id="16" name="Shape 13"/>
           <p:cNvSpPr/>
           <p:nvPr/>
         </p:nvSpPr>
@@ -3380,7 +3536,7 @@
       </p:sp>
       <p:sp>
         <p:nvSpPr>
-          <p:cNvPr id="16" name="Text 13"/>
+          <p:cNvPr id="17" name="Text 14"/>
           <p:cNvSpPr txBox="1"/>
           <p:nvPr/>
         </p:nvSpPr>
@@ -3419,7 +3575,7 @@
       </p:sp>
       <p:sp>
         <p:nvSpPr>
-          <p:cNvPr id="17" name="Text 14"/>
+          <p:cNvPr id="18" name="Text 15"/>
           <p:cNvSpPr txBox="1"/>
           <p:nvPr/>
         </p:nvSpPr>
@@ -3453,7 +3609,7 @@
                 <a:ea typeface="Poppins Medium" pitchFamily="34" charset="-122"/>
                 <a:cs typeface="Poppins Medium" pitchFamily="34" charset="-120"/>
               </a:rPr>
-              <a:t>L'acheteur prend les parts et révèle le secret</a:t>
+              <a:t>The buyer takes the shares and reveals the secret</a:t>
             </a:r>
             <a:endParaRPr lang="en-US" sz="1700" dirty="0"/>
           </a:p>
@@ -3461,7 +3617,7 @@
       </p:sp>
       <p:sp>
         <p:nvSpPr>
-          <p:cNvPr id="18" name="Shape 15"/>
+          <p:cNvPr id="19" name="Shape 16"/>
           <p:cNvSpPr/>
           <p:nvPr/>
         </p:nvSpPr>
@@ -3483,7 +3639,7 @@
       </p:sp>
       <p:sp>
         <p:nvSpPr>
-          <p:cNvPr id="19" name="Text 16"/>
+          <p:cNvPr id="20" name="Text 17"/>
           <p:cNvSpPr txBox="1"/>
           <p:nvPr/>
         </p:nvSpPr>
@@ -3522,7 +3678,7 @@
       </p:sp>
       <p:sp>
         <p:nvSpPr>
-          <p:cNvPr id="20" name="Shape 17"/>
+          <p:cNvPr id="21" name="Shape 18"/>
           <p:cNvSpPr/>
           <p:nvPr/>
         </p:nvSpPr>
@@ -3542,7 +3698,7 @@
       </p:sp>
       <p:sp>
         <p:nvSpPr>
-          <p:cNvPr id="21" name="Text 18"/>
+          <p:cNvPr id="22" name="Text 19"/>
           <p:cNvSpPr txBox="1"/>
           <p:nvPr/>
         </p:nvSpPr>
@@ -3581,7 +3737,7 @@
       </p:sp>
       <p:sp>
         <p:nvSpPr>
-          <p:cNvPr id="22" name="Text 19"/>
+          <p:cNvPr id="23" name="Text 20"/>
           <p:cNvSpPr txBox="1"/>
           <p:nvPr/>
         </p:nvSpPr>
@@ -3615,7 +3771,7 @@
                 <a:ea typeface="Poppins Medium" pitchFamily="34" charset="-122"/>
                 <a:cs typeface="Poppins Medium" pitchFamily="34" charset="-120"/>
               </a:rPr>
-              <a:t>La vendeuse relit le secret et encaisse</a:t>
+              <a:t>The seller reads the secret and collects</a:t>
             </a:r>
             <a:endParaRPr lang="en-US" sz="1700" dirty="0"/>
           </a:p>
@@ -3623,7 +3779,7 @@
       </p:sp>
       <p:sp>
         <p:nvSpPr>
-          <p:cNvPr id="23" name="Shape 20"/>
+          <p:cNvPr id="24" name="Shape 21"/>
           <p:cNvSpPr/>
           <p:nvPr/>
         </p:nvSpPr>
@@ -3645,7 +3801,7 @@
       </p:sp>
       <p:sp>
         <p:nvSpPr>
-          <p:cNvPr id="24" name="Text 21"/>
+          <p:cNvPr id="25" name="Text 22"/>
           <p:cNvSpPr txBox="1"/>
           <p:nvPr/>
         </p:nvSpPr>
@@ -3684,7 +3840,7 @@
       </p:sp>
       <p:sp>
         <p:nvSpPr>
-          <p:cNvPr id="25" name="Shape 22"/>
+          <p:cNvPr id="26" name="Shape 23"/>
           <p:cNvSpPr/>
           <p:nvPr/>
         </p:nvSpPr>
@@ -3704,7 +3860,7 @@
       </p:sp>
       <p:sp>
         <p:nvSpPr>
-          <p:cNvPr id="26" name="Text 23"/>
+          <p:cNvPr id="27" name="Text 24"/>
           <p:cNvSpPr txBox="1"/>
           <p:nvPr/>
         </p:nvSpPr>
@@ -3735,7 +3891,7 @@
                 <a:ea typeface="Poppins Medium" pitchFamily="34" charset="-122"/>
                 <a:cs typeface="Poppins Medium" pitchFamily="34" charset="-120"/>
               </a:rPr>
-              <a:t>Prix : 97 % de la valeur de part.</a:t>
+              <a:t>Price: 97% of share value.</a:t>
             </a:r>
             <a:endParaRPr lang="en-US" sz="1600" dirty="0"/>
           </a:p>
@@ -3743,7 +3899,7 @@
       </p:sp>
       <p:sp>
         <p:nvSpPr>
-          <p:cNvPr id="27" name="Text 24"/>
+          <p:cNvPr id="28" name="Text 25"/>
           <p:cNvSpPr txBox="1"/>
           <p:nvPr/>
         </p:nvSpPr>
@@ -3774,7 +3930,7 @@
                 <a:ea typeface="Poppins" pitchFamily="34" charset="-122"/>
                 <a:cs typeface="Poppins" pitchFamily="34" charset="-120"/>
               </a:rPr>
-              <a:t>Une seule condition SHA-256 pour les deux escrows.</a:t>
+              <a:t>One SHA-256 condition for both escrows.</a:t>
             </a:r>
             <a:endParaRPr lang="en-US" sz="1600" dirty="0"/>
           </a:p>
@@ -3844,32 +4000,71 @@
         </p:nvSpPr>
         <p:spPr>
           <a:xfrm>
-            <a:off x="758952" y="2514600"/>
-            <a:ext cx="4754880" cy="914400"/>
-          </a:xfrm>
-          <a:prstGeom prst="rect">
-            <a:avLst/>
-          </a:prstGeom>
-          <a:noFill/>
-          <a:ln/>
-        </p:spPr>
-        <p:txBody>
-          <a:bodyPr wrap="square" lIns="0" tIns="0" rIns="0" bIns="0" rtlCol="0" anchor="t"/>
-          <a:lstStyle/>
-          <a:p>
-            <a:pPr algn="l" indent="0" marL="0">
-              <a:buNone/>
-            </a:pPr>
-            <a:r>
-              <a:rPr lang="en-US" sz="5600" b="1" dirty="0">
-                <a:solidFill>
-                  <a:srgbClr val="FFFFFF"/>
+            <a:off x="10287000" y="6382512"/>
+            <a:ext cx="1097280" cy="228600"/>
+          </a:xfrm>
+          <a:prstGeom prst="rect">
+            <a:avLst/>
+          </a:prstGeom>
+          <a:noFill/>
+          <a:ln/>
+        </p:spPr>
+        <p:txBody>
+          <a:bodyPr wrap="square" lIns="0" tIns="0" rIns="0" bIns="0" rtlCol="0" anchor="ctr"/>
+          <a:lstStyle/>
+          <a:p>
+            <a:pPr algn="r" indent="0" marL="0">
+              <a:buNone/>
+            </a:pPr>
+            <a:r>
+              <a:rPr lang="en-US" sz="1000" dirty="0">
+                <a:solidFill>
+                  <a:srgbClr val="C9D4E8"/>
                 </a:solidFill>
                 <a:latin typeface="Poppins" pitchFamily="34" charset="0"/>
                 <a:ea typeface="Poppins" pitchFamily="34" charset="-122"/>
                 <a:cs typeface="Poppins" pitchFamily="34" charset="-120"/>
               </a:rPr>
-              <a:t>Démo live.</a:t>
+              <a:t>4 / 10</a:t>
+            </a:r>
+            <a:endParaRPr lang="en-US" sz="1000" dirty="0"/>
+          </a:p>
+        </p:txBody>
+      </p:sp>
+      <p:sp>
+        <p:nvSpPr>
+          <p:cNvPr id="4" name="Text 1"/>
+          <p:cNvSpPr txBox="1"/>
+          <p:nvPr/>
+        </p:nvSpPr>
+        <p:spPr>
+          <a:xfrm>
+            <a:off x="758952" y="2514600"/>
+            <a:ext cx="4754880" cy="914400"/>
+          </a:xfrm>
+          <a:prstGeom prst="rect">
+            <a:avLst/>
+          </a:prstGeom>
+          <a:noFill/>
+          <a:ln/>
+        </p:spPr>
+        <p:txBody>
+          <a:bodyPr wrap="square" lIns="0" tIns="0" rIns="0" bIns="0" rtlCol="0" anchor="t"/>
+          <a:lstStyle/>
+          <a:p>
+            <a:pPr algn="l" indent="0" marL="0">
+              <a:buNone/>
+            </a:pPr>
+            <a:r>
+              <a:rPr lang="en-US" sz="5600" b="1" dirty="0">
+                <a:solidFill>
+                  <a:srgbClr val="FFFFFF"/>
+                </a:solidFill>
+                <a:latin typeface="Poppins" pitchFamily="34" charset="0"/>
+                <a:ea typeface="Poppins" pitchFamily="34" charset="-122"/>
+                <a:cs typeface="Poppins" pitchFamily="34" charset="-120"/>
+              </a:rPr>
+              <a:t>Live demo.</a:t>
             </a:r>
             <a:endParaRPr lang="en-US" sz="5600" dirty="0"/>
           </a:p>
@@ -3877,7 +4072,7 @@
       </p:sp>
       <p:sp>
         <p:nvSpPr>
-          <p:cNvPr id="4" name="Text 1"/>
+          <p:cNvPr id="5" name="Text 2"/>
           <p:cNvSpPr txBox="1"/>
           <p:nvPr/>
         </p:nvSpPr>
@@ -3911,7 +4106,7 @@
                 <a:ea typeface="Poppins Light" pitchFamily="34" charset="-122"/>
                 <a:cs typeface="Poppins Light" pitchFamily="34" charset="-120"/>
               </a:rPr>
-              <a:t>13 transactions en 56 secondes,</a:t>
+              <a:t>13 transactions in 56 seconds,</a:t>
             </a:r>
             <a:endParaRPr lang="en-US" sz="1800" dirty="0"/>
           </a:p>
@@ -3931,7 +4126,7 @@
                 <a:ea typeface="Poppins Light" pitchFamily="34" charset="-122"/>
                 <a:cs typeface="Poppins Light" pitchFamily="34" charset="-120"/>
               </a:rPr>
-              <a:t>sur le devnet, en direct.</a:t>
+              <a:t>on the devnet, live.</a:t>
             </a:r>
             <a:endParaRPr lang="en-US" sz="1800" dirty="0"/>
           </a:p>
@@ -3939,7 +4134,7 @@
       </p:sp>
       <p:sp>
         <p:nvSpPr>
-          <p:cNvPr id="5" name="Shape 2"/>
+          <p:cNvPr id="6" name="Shape 3"/>
           <p:cNvSpPr/>
           <p:nvPr/>
         </p:nvSpPr>
@@ -3966,7 +4161,7 @@
       </p:sp>
       <p:sp>
         <p:nvSpPr>
-          <p:cNvPr id="6" name="Shape 3"/>
+          <p:cNvPr id="7" name="Shape 4"/>
           <p:cNvSpPr/>
           <p:nvPr/>
         </p:nvSpPr>
@@ -3986,7 +4181,7 @@
       </p:sp>
       <p:sp>
         <p:nvSpPr>
-          <p:cNvPr id="7" name="Shape 4"/>
+          <p:cNvPr id="8" name="Shape 5"/>
           <p:cNvSpPr/>
           <p:nvPr/>
         </p:nvSpPr>
@@ -4006,7 +4201,7 @@
       </p:sp>
       <p:sp>
         <p:nvSpPr>
-          <p:cNvPr id="8" name="Shape 5"/>
+          <p:cNvPr id="9" name="Shape 6"/>
           <p:cNvSpPr/>
           <p:nvPr/>
         </p:nvSpPr>
@@ -4026,7 +4221,7 @@
       </p:sp>
       <p:sp>
         <p:nvSpPr>
-          <p:cNvPr id="9" name="Text 6"/>
+          <p:cNvPr id="10" name="Text 7"/>
           <p:cNvSpPr txBox="1"/>
           <p:nvPr/>
         </p:nvSpPr>
@@ -4065,7 +4260,7 @@
       </p:sp>
       <p:sp>
         <p:nvSpPr>
-          <p:cNvPr id="10" name="Shape 7"/>
+          <p:cNvPr id="11" name="Shape 8"/>
           <p:cNvSpPr/>
           <p:nvPr/>
         </p:nvSpPr>
@@ -4085,7 +4280,7 @@
       </p:sp>
       <p:sp>
         <p:nvSpPr>
-          <p:cNvPr id="11" name="Text 8"/>
+          <p:cNvPr id="12" name="Text 9"/>
           <p:cNvSpPr txBox="1"/>
           <p:nvPr/>
         </p:nvSpPr>
@@ -4138,7 +4333,7 @@
       </p:sp>
       <p:sp>
         <p:nvSpPr>
-          <p:cNvPr id="12" name="Text 9"/>
+          <p:cNvPr id="13" name="Text 10"/>
           <p:cNvSpPr txBox="1"/>
           <p:nvPr/>
         </p:nvSpPr>
@@ -4191,7 +4386,7 @@
       </p:sp>
       <p:sp>
         <p:nvSpPr>
-          <p:cNvPr id="13" name="Text 10"/>
+          <p:cNvPr id="14" name="Text 11"/>
           <p:cNvSpPr txBox="1"/>
           <p:nvPr/>
         </p:nvSpPr>
@@ -4244,7 +4439,7 @@
       </p:sp>
       <p:sp>
         <p:nvSpPr>
-          <p:cNvPr id="14" name="Text 11"/>
+          <p:cNvPr id="15" name="Text 12"/>
           <p:cNvSpPr txBox="1"/>
           <p:nvPr/>
         </p:nvSpPr>
@@ -4297,7 +4492,7 @@
       </p:sp>
       <p:sp>
         <p:nvSpPr>
-          <p:cNvPr id="15" name="Text 12"/>
+          <p:cNvPr id="16" name="Text 13"/>
           <p:cNvSpPr txBox="1"/>
           <p:nvPr/>
         </p:nvSpPr>
@@ -4328,7 +4523,7 @@
                 <a:ea typeface="Menlo" pitchFamily="34" charset="-122"/>
                 <a:cs typeface="Menlo" pitchFamily="34" charset="-120"/>
               </a:rPr>
-              <a:t>LoanSet 100 %           </a:t>
+              <a:t>LoanSet 100%            </a:t>
             </a:r>
             <a:pPr indent="0" marL="0">
               <a:buNone/>
@@ -4350,7 +4545,7 @@
       </p:sp>
       <p:sp>
         <p:nvSpPr>
-          <p:cNvPr id="16" name="Shape 13"/>
+          <p:cNvPr id="17" name="Shape 14"/>
           <p:cNvSpPr/>
           <p:nvPr/>
         </p:nvSpPr>
@@ -4370,7 +4565,7 @@
       </p:sp>
       <p:sp>
         <p:nvSpPr>
-          <p:cNvPr id="17" name="Text 14"/>
+          <p:cNvPr id="18" name="Text 15"/>
           <p:cNvSpPr txBox="1"/>
           <p:nvPr/>
         </p:nvSpPr>
@@ -4423,7 +4618,7 @@
       </p:sp>
       <p:sp>
         <p:nvSpPr>
-          <p:cNvPr id="18" name="Text 15"/>
+          <p:cNvPr id="19" name="Text 16"/>
           <p:cNvSpPr txBox="1"/>
           <p:nvPr/>
         </p:nvSpPr>
@@ -4476,7 +4671,7 @@
       </p:sp>
       <p:sp>
         <p:nvSpPr>
-          <p:cNvPr id="19" name="Text 16"/>
+          <p:cNvPr id="20" name="Text 17"/>
           <p:cNvSpPr txBox="1"/>
           <p:nvPr/>
         </p:nvSpPr>
@@ -4529,7 +4724,7 @@
       </p:sp>
       <p:sp>
         <p:nvSpPr>
-          <p:cNvPr id="20" name="Text 17"/>
+          <p:cNvPr id="21" name="Text 18"/>
           <p:cNvSpPr txBox="1"/>
           <p:nvPr/>
         </p:nvSpPr>
@@ -4582,7 +4777,7 @@
       </p:sp>
       <p:sp>
         <p:nvSpPr>
-          <p:cNvPr id="21" name="Text 18"/>
+          <p:cNvPr id="22" name="Text 19"/>
           <p:cNvSpPr txBox="1"/>
           <p:nvPr/>
         </p:nvSpPr>
@@ -4635,7 +4830,7 @@
       </p:sp>
       <p:sp>
         <p:nvSpPr>
-          <p:cNvPr id="22" name="Text 19"/>
+          <p:cNvPr id="23" name="Text 20"/>
           <p:cNvSpPr txBox="1"/>
           <p:nvPr/>
         </p:nvSpPr>
@@ -4688,7 +4883,7 @@
       </p:sp>
       <p:sp>
         <p:nvSpPr>
-          <p:cNvPr id="23" name="Text 20"/>
+          <p:cNvPr id="24" name="Text 21"/>
           <p:cNvSpPr txBox="1"/>
           <p:nvPr/>
         </p:nvSpPr>
@@ -4719,7 +4914,7 @@
                 <a:ea typeface="Menlo" pitchFamily="34" charset="-122"/>
                 <a:cs typeface="Menlo" pitchFamily="34" charset="-120"/>
               </a:rPr>
-              <a:t>Durée totale  00:56</a:t>
+              <a:t>Total time  00:56</a:t>
             </a:r>
             <a:endParaRPr lang="en-US" sz="1150" dirty="0"/>
           </a:p>
@@ -4789,32 +4984,71 @@
         </p:nvSpPr>
         <p:spPr>
           <a:xfrm>
-            <a:off x="804672" y="713232"/>
-            <a:ext cx="10579608" cy="658368"/>
-          </a:xfrm>
-          <a:prstGeom prst="rect">
-            <a:avLst/>
-          </a:prstGeom>
-          <a:noFill/>
-          <a:ln/>
-        </p:spPr>
-        <p:txBody>
-          <a:bodyPr wrap="square" lIns="0" tIns="0" rIns="0" bIns="0" rtlCol="0" anchor="t"/>
-          <a:lstStyle/>
-          <a:p>
-            <a:pPr algn="l" indent="0" marL="0">
-              <a:buNone/>
-            </a:pPr>
-            <a:r>
-              <a:rPr lang="en-US" sz="3200" b="1" dirty="0">
-                <a:solidFill>
-                  <a:srgbClr val="001C5C"/>
+            <a:off x="10287000" y="6382512"/>
+            <a:ext cx="1097280" cy="228600"/>
+          </a:xfrm>
+          <a:prstGeom prst="rect">
+            <a:avLst/>
+          </a:prstGeom>
+          <a:noFill/>
+          <a:ln/>
+        </p:spPr>
+        <p:txBody>
+          <a:bodyPr wrap="square" lIns="0" tIns="0" rIns="0" bIns="0" rtlCol="0" anchor="ctr"/>
+          <a:lstStyle/>
+          <a:p>
+            <a:pPr algn="r" indent="0" marL="0">
+              <a:buNone/>
+            </a:pPr>
+            <a:r>
+              <a:rPr lang="en-US" sz="1000" dirty="0">
+                <a:solidFill>
+                  <a:srgbClr val="8A9199"/>
                 </a:solidFill>
                 <a:latin typeface="Poppins" pitchFamily="34" charset="0"/>
                 <a:ea typeface="Poppins" pitchFamily="34" charset="-122"/>
                 <a:cs typeface="Poppins" pitchFamily="34" charset="-120"/>
               </a:rPr>
-              <a:t>Minimum bar : 8 sur 8</a:t>
+              <a:t>5 / 10</a:t>
+            </a:r>
+            <a:endParaRPr lang="en-US" sz="1000" dirty="0"/>
+          </a:p>
+        </p:txBody>
+      </p:sp>
+      <p:sp>
+        <p:nvSpPr>
+          <p:cNvPr id="4" name="Text 1"/>
+          <p:cNvSpPr txBox="1"/>
+          <p:nvPr/>
+        </p:nvSpPr>
+        <p:spPr>
+          <a:xfrm>
+            <a:off x="804672" y="713232"/>
+            <a:ext cx="10579608" cy="658368"/>
+          </a:xfrm>
+          <a:prstGeom prst="rect">
+            <a:avLst/>
+          </a:prstGeom>
+          <a:noFill/>
+          <a:ln/>
+        </p:spPr>
+        <p:txBody>
+          <a:bodyPr wrap="square" lIns="0" tIns="0" rIns="0" bIns="0" rtlCol="0" anchor="t"/>
+          <a:lstStyle/>
+          <a:p>
+            <a:pPr algn="l" indent="0" marL="0">
+              <a:buNone/>
+            </a:pPr>
+            <a:r>
+              <a:rPr lang="en-US" sz="3200" b="1" dirty="0">
+                <a:solidFill>
+                  <a:srgbClr val="001C5C"/>
+                </a:solidFill>
+                <a:latin typeface="Poppins" pitchFamily="34" charset="0"/>
+                <a:ea typeface="Poppins" pitchFamily="34" charset="-122"/>
+                <a:cs typeface="Poppins" pitchFamily="34" charset="-120"/>
+              </a:rPr>
+              <a:t>Minimum bar: 8 of 8</a:t>
             </a:r>
             <a:endParaRPr lang="en-US" sz="3200" dirty="0"/>
           </a:p>
@@ -4822,7 +5056,7 @@
       </p:sp>
       <p:sp>
         <p:nvSpPr>
-          <p:cNvPr id="4" name="Shape 1"/>
+          <p:cNvPr id="5" name="Shape 2"/>
           <p:cNvSpPr/>
           <p:nvPr/>
         </p:nvSpPr>
@@ -4849,7 +5083,7 @@
       </p:sp>
       <p:sp>
         <p:nvSpPr>
-          <p:cNvPr id="5" name="Shape 2"/>
+          <p:cNvPr id="6" name="Shape 3"/>
           <p:cNvSpPr/>
           <p:nvPr/>
         </p:nvSpPr>
@@ -4869,7 +5103,7 @@
       </p:sp>
       <p:sp>
         <p:nvSpPr>
-          <p:cNvPr id="6" name="Shape 3"/>
+          <p:cNvPr id="7" name="Shape 4"/>
           <p:cNvSpPr/>
           <p:nvPr/>
         </p:nvSpPr>
@@ -4889,7 +5123,7 @@
       </p:sp>
       <p:sp>
         <p:nvSpPr>
-          <p:cNvPr id="7" name="Shape 4"/>
+          <p:cNvPr id="8" name="Shape 5"/>
           <p:cNvSpPr/>
           <p:nvPr/>
         </p:nvSpPr>
@@ -4909,7 +5143,7 @@
       </p:sp>
       <p:sp>
         <p:nvSpPr>
-          <p:cNvPr id="8" name="Text 5"/>
+          <p:cNvPr id="9" name="Text 6"/>
           <p:cNvSpPr txBox="1"/>
           <p:nvPr/>
         </p:nvSpPr>
@@ -4940,7 +5174,7 @@
                 <a:ea typeface="Menlo" pitchFamily="34" charset="-122"/>
                 <a:cs typeface="Menlo" pitchFamily="34" charset="-120"/>
               </a:rPr>
-              <a:t>README.md  ›  un hash par étape</a:t>
+              <a:t>README.md  ›  one hash per step</a:t>
             </a:r>
             <a:endParaRPr lang="en-US" sz="900" dirty="0"/>
           </a:p>
@@ -4948,7 +5182,7 @@
       </p:sp>
       <p:sp>
         <p:nvSpPr>
-          <p:cNvPr id="9" name="Shape 6"/>
+          <p:cNvPr id="10" name="Shape 7"/>
           <p:cNvSpPr/>
           <p:nvPr/>
         </p:nvSpPr>
@@ -4968,7 +5202,7 @@
       </p:sp>
       <p:sp>
         <p:nvSpPr>
-          <p:cNvPr id="10" name="Text 7"/>
+          <p:cNvPr id="11" name="Text 8"/>
           <p:cNvSpPr txBox="1"/>
           <p:nvPr/>
         </p:nvSpPr>
@@ -4999,7 +5233,7 @@
                 <a:ea typeface="Menlo" pitchFamily="34" charset="-122"/>
                 <a:cs typeface="Menlo" pitchFamily="34" charset="-120"/>
               </a:rPr>
-              <a:t>1  Vault open-ended        </a:t>
+              <a:t>1  Open-ended vault        </a:t>
             </a:r>
             <a:pPr indent="0" marL="0">
               <a:buNone/>
@@ -5021,7 +5255,7 @@
       </p:sp>
       <p:sp>
         <p:nvSpPr>
-          <p:cNvPr id="11" name="Text 8"/>
+          <p:cNvPr id="12" name="Text 9"/>
           <p:cNvSpPr txBox="1"/>
           <p:nvPr/>
         </p:nvSpPr>
@@ -5052,7 +5286,7 @@
                 <a:ea typeface="Menlo" pitchFamily="34" charset="-122"/>
                 <a:cs typeface="Menlo" pitchFamily="34" charset="-120"/>
               </a:rPr>
-              <a:t>2  Dépôt                   </a:t>
+              <a:t>2  Deposit                 </a:t>
             </a:r>
             <a:pPr indent="0" marL="0">
               <a:buNone/>
@@ -5074,7 +5308,7 @@
       </p:sp>
       <p:sp>
         <p:nvSpPr>
-          <p:cNvPr id="12" name="Text 9"/>
+          <p:cNvPr id="13" name="Text 10"/>
           <p:cNvSpPr txBox="1"/>
           <p:nvPr/>
         </p:nvSpPr>
@@ -5105,7 +5339,7 @@
                 <a:ea typeface="Menlo" pitchFamily="34" charset="-122"/>
                 <a:cs typeface="Menlo" pitchFamily="34" charset="-120"/>
               </a:rPr>
-              <a:t>3  Broker + couverture     </a:t>
+              <a:t>3  Broker + cover          </a:t>
             </a:r>
             <a:pPr indent="0" marL="0">
               <a:buNone/>
@@ -5127,7 +5361,7 @@
       </p:sp>
       <p:sp>
         <p:nvSpPr>
-          <p:cNvPr id="13" name="Text 10"/>
+          <p:cNvPr id="14" name="Text 11"/>
           <p:cNvSpPr txBox="1"/>
           <p:nvPr/>
         </p:nvSpPr>
@@ -5180,7 +5414,7 @@
       </p:sp>
       <p:sp>
         <p:nvSpPr>
-          <p:cNvPr id="14" name="Text 11"/>
+          <p:cNvPr id="15" name="Text 12"/>
           <p:cNvSpPr txBox="1"/>
           <p:nvPr/>
         </p:nvSpPr>
@@ -5211,7 +5445,7 @@
                 <a:ea typeface="Menlo" pitchFamily="34" charset="-122"/>
                 <a:cs typeface="Menlo" pitchFamily="34" charset="-120"/>
               </a:rPr>
-              <a:t>5  Remboursement           </a:t>
+              <a:t>5  Repayment               </a:t>
             </a:r>
             <a:pPr indent="0" marL="0">
               <a:buNone/>
@@ -5233,7 +5467,7 @@
       </p:sp>
       <p:sp>
         <p:nvSpPr>
-          <p:cNvPr id="15" name="Text 12"/>
+          <p:cNvPr id="16" name="Text 13"/>
           <p:cNvSpPr txBox="1"/>
           <p:nvPr/>
         </p:nvSpPr>
@@ -5264,7 +5498,7 @@
                 <a:ea typeface="Menlo" pitchFamily="34" charset="-122"/>
                 <a:cs typeface="Menlo" pitchFamily="34" charset="-120"/>
               </a:rPr>
-              <a:t>6  Capital + rendement     </a:t>
+              <a:t>6  Principal + yield       </a:t>
             </a:r>
             <a:pPr indent="0" marL="0">
               <a:buNone/>
@@ -5286,7 +5520,7 @@
       </p:sp>
       <p:sp>
         <p:nvSpPr>
-          <p:cNvPr id="16" name="Text 13"/>
+          <p:cNvPr id="17" name="Text 14"/>
           <p:cNvSpPr txBox="1"/>
           <p:nvPr/>
         </p:nvSpPr>
@@ -5317,7 +5551,7 @@
                 <a:ea typeface="Menlo" pitchFamily="34" charset="-122"/>
                 <a:cs typeface="Menlo" pitchFamily="34" charset="-120"/>
               </a:rPr>
-              <a:t>7  Garde-fous provoqués    </a:t>
+              <a:t>7  Guardrails triggered    </a:t>
             </a:r>
             <a:pPr indent="0" marL="0">
               <a:buNone/>
@@ -5331,7 +5565,7 @@
                 <a:ea typeface="Menlo" pitchFamily="34" charset="-122"/>
                 <a:cs typeface="Menlo" pitchFamily="34" charset="-120"/>
               </a:rPr>
-              <a:t>5 × tec + 1 contrôle</a:t>
+              <a:t>6 × tec + 2 controls</a:t>
             </a:r>
             <a:endParaRPr lang="en-US" sz="1200" dirty="0"/>
           </a:p>
@@ -5339,7 +5573,7 @@
       </p:sp>
       <p:sp>
         <p:nvSpPr>
-          <p:cNvPr id="17" name="Text 14"/>
+          <p:cNvPr id="18" name="Text 15"/>
           <p:cNvSpPr txBox="1"/>
           <p:nvPr/>
         </p:nvSpPr>
@@ -5392,7 +5626,7 @@
       </p:sp>
       <p:sp>
         <p:nvSpPr>
-          <p:cNvPr id="18" name="Text 15"/>
+          <p:cNvPr id="19" name="Text 16"/>
           <p:cNvSpPr txBox="1"/>
           <p:nvPr/>
         </p:nvSpPr>
@@ -5423,7 +5657,7 @@
                 <a:ea typeface="Menlo" pitchFamily="34" charset="-122"/>
                 <a:cs typeface="Menlo" pitchFamily="34" charset="-120"/>
               </a:rPr>
-              <a:t>   valeur de part  1.000000000  →  </a:t>
+              <a:t>   share value  1.000000000  →  </a:t>
             </a:r>
             <a:pPr indent="0" marL="0">
               <a:buNone/>
@@ -5445,7 +5679,7 @@
       </p:sp>
       <p:sp>
         <p:nvSpPr>
-          <p:cNvPr id="19" name="Text 16"/>
+          <p:cNvPr id="20" name="Text 17"/>
           <p:cNvSpPr txBox="1"/>
           <p:nvPr/>
         </p:nvSpPr>
@@ -5484,7 +5718,7 @@
       </p:sp>
       <p:sp>
         <p:nvSpPr>
-          <p:cNvPr id="20" name="Text 17"/>
+          <p:cNvPr id="21" name="Text 18"/>
           <p:cNvSpPr txBox="1"/>
           <p:nvPr/>
         </p:nvSpPr>
@@ -5515,7 +5749,7 @@
                 <a:ea typeface="Poppins" pitchFamily="34" charset="-122"/>
                 <a:cs typeface="Poppins" pitchFamily="34" charset="-120"/>
               </a:rPr>
-              <a:t>types XLS-65/66 soumis au ledger</a:t>
+              <a:t>XLS-65/66 types submitted to the ledger</a:t>
             </a:r>
             <a:endParaRPr lang="en-US" sz="1300" dirty="0"/>
           </a:p>
@@ -5523,7 +5757,7 @@
       </p:sp>
       <p:sp>
         <p:nvSpPr>
-          <p:cNvPr id="21" name="Text 18"/>
+          <p:cNvPr id="22" name="Text 19"/>
           <p:cNvSpPr txBox="1"/>
           <p:nvPr/>
         </p:nvSpPr>
@@ -5562,7 +5796,7 @@
       </p:sp>
       <p:sp>
         <p:nvSpPr>
-          <p:cNvPr id="22" name="Text 19"/>
+          <p:cNvPr id="23" name="Text 20"/>
           <p:cNvSpPr txBox="1"/>
           <p:nvPr/>
         </p:nvSpPr>
@@ -5593,7 +5827,7 @@
                 <a:ea typeface="Poppins" pitchFamily="34" charset="-122"/>
                 <a:cs typeface="Poppins" pitchFamily="34" charset="-120"/>
               </a:rPr>
-              <a:t>type manquant dans xrpl@4.6.0</a:t>
+              <a:t>missing types in xrpl@4.6.0</a:t>
             </a:r>
             <a:endParaRPr lang="en-US" sz="1300" dirty="0"/>
           </a:p>
@@ -5663,32 +5897,71 @@
         </p:nvSpPr>
         <p:spPr>
           <a:xfrm>
-            <a:off x="804672" y="713232"/>
-            <a:ext cx="10579608" cy="658368"/>
-          </a:xfrm>
-          <a:prstGeom prst="rect">
-            <a:avLst/>
-          </a:prstGeom>
-          <a:noFill/>
-          <a:ln/>
-        </p:spPr>
-        <p:txBody>
-          <a:bodyPr wrap="square" lIns="0" tIns="0" rIns="0" bIns="0" rtlCol="0" anchor="t"/>
-          <a:lstStyle/>
-          <a:p>
-            <a:pPr algn="l" indent="0" marL="0">
-              <a:buNone/>
-            </a:pPr>
-            <a:r>
-              <a:rPr lang="en-US" sz="3200" b="1" dirty="0">
-                <a:solidFill>
-                  <a:srgbClr val="001C5C"/>
+            <a:off x="10287000" y="6382512"/>
+            <a:ext cx="1097280" cy="228600"/>
+          </a:xfrm>
+          <a:prstGeom prst="rect">
+            <a:avLst/>
+          </a:prstGeom>
+          <a:noFill/>
+          <a:ln/>
+        </p:spPr>
+        <p:txBody>
+          <a:bodyPr wrap="square" lIns="0" tIns="0" rIns="0" bIns="0" rtlCol="0" anchor="ctr"/>
+          <a:lstStyle/>
+          <a:p>
+            <a:pPr algn="r" indent="0" marL="0">
+              <a:buNone/>
+            </a:pPr>
+            <a:r>
+              <a:rPr lang="en-US" sz="1000" dirty="0">
+                <a:solidFill>
+                  <a:srgbClr val="8A9199"/>
                 </a:solidFill>
                 <a:latin typeface="Poppins" pitchFamily="34" charset="0"/>
                 <a:ea typeface="Poppins" pitchFamily="34" charset="-122"/>
                 <a:cs typeface="Poppins" pitchFamily="34" charset="-120"/>
               </a:rPr>
-              <a:t>fixCleanup3_4_0 : actif, absent d'xrpl.org</a:t>
+              <a:t>6 / 10</a:t>
+            </a:r>
+            <a:endParaRPr lang="en-US" sz="1000" dirty="0"/>
+          </a:p>
+        </p:txBody>
+      </p:sp>
+      <p:sp>
+        <p:nvSpPr>
+          <p:cNvPr id="4" name="Text 1"/>
+          <p:cNvSpPr txBox="1"/>
+          <p:nvPr/>
+        </p:nvSpPr>
+        <p:spPr>
+          <a:xfrm>
+            <a:off x="804672" y="713232"/>
+            <a:ext cx="10579608" cy="658368"/>
+          </a:xfrm>
+          <a:prstGeom prst="rect">
+            <a:avLst/>
+          </a:prstGeom>
+          <a:noFill/>
+          <a:ln/>
+        </p:spPr>
+        <p:txBody>
+          <a:bodyPr wrap="square" lIns="0" tIns="0" rIns="0" bIns="0" rtlCol="0" anchor="t"/>
+          <a:lstStyle/>
+          <a:p>
+            <a:pPr algn="l" indent="0" marL="0">
+              <a:buNone/>
+            </a:pPr>
+            <a:r>
+              <a:rPr lang="en-US" sz="3200" b="1" dirty="0">
+                <a:solidFill>
+                  <a:srgbClr val="001C5C"/>
+                </a:solidFill>
+                <a:latin typeface="Poppins" pitchFamily="34" charset="0"/>
+                <a:ea typeface="Poppins" pitchFamily="34" charset="-122"/>
+                <a:cs typeface="Poppins" pitchFamily="34" charset="-120"/>
+              </a:rPr>
+              <a:t>fixCleanup3_4_0: enabled, missing from xrpl.org</a:t>
             </a:r>
             <a:endParaRPr lang="en-US" sz="3200" dirty="0"/>
           </a:p>
@@ -5696,7 +5969,7 @@
       </p:sp>
       <p:sp>
         <p:nvSpPr>
-          <p:cNvPr id="4" name="Text 1"/>
+          <p:cNvPr id="5" name="Text 2"/>
           <p:cNvSpPr txBox="1"/>
           <p:nvPr/>
         </p:nvSpPr>
@@ -5727,7 +6000,7 @@
                 <a:ea typeface="Poppins Light" pitchFamily="34" charset="-122"/>
                 <a:cs typeface="Poppins Light" pitchFamily="34" charset="-120"/>
               </a:rPr>
-              <a:t>Deux comportements de prêt changent sur le devnet.</a:t>
+              <a:t>Two lending behaviours change on the devnet.</a:t>
             </a:r>
             <a:endParaRPr lang="en-US" sz="1600" dirty="0"/>
           </a:p>
@@ -5735,7 +6008,7 @@
       </p:sp>
       <p:sp>
         <p:nvSpPr>
-          <p:cNvPr id="5" name="Shape 2"/>
+          <p:cNvPr id="6" name="Shape 3"/>
           <p:cNvSpPr/>
           <p:nvPr/>
         </p:nvSpPr>
@@ -5762,7 +6035,7 @@
       </p:sp>
       <p:sp>
         <p:nvSpPr>
-          <p:cNvPr id="6" name="Shape 3"/>
+          <p:cNvPr id="7" name="Shape 4"/>
           <p:cNvSpPr/>
           <p:nvPr/>
         </p:nvSpPr>
@@ -5782,7 +6055,7 @@
       </p:sp>
       <p:sp>
         <p:nvSpPr>
-          <p:cNvPr id="7" name="Shape 4"/>
+          <p:cNvPr id="8" name="Shape 5"/>
           <p:cNvSpPr/>
           <p:nvPr/>
         </p:nvSpPr>
@@ -5802,7 +6075,7 @@
       </p:sp>
       <p:sp>
         <p:nvSpPr>
-          <p:cNvPr id="8" name="Shape 5"/>
+          <p:cNvPr id="9" name="Shape 6"/>
           <p:cNvSpPr/>
           <p:nvPr/>
         </p:nvSpPr>
@@ -5822,7 +6095,7 @@
       </p:sp>
       <p:sp>
         <p:nvSpPr>
-          <p:cNvPr id="9" name="Text 6"/>
+          <p:cNvPr id="10" name="Text 7"/>
           <p:cNvSpPr txBox="1"/>
           <p:nvPr/>
         </p:nvSpPr>
@@ -5853,7 +6126,7 @@
                 <a:ea typeface="Menlo" pitchFamily="34" charset="-122"/>
                 <a:cs typeface="Menlo" pitchFamily="34" charset="-120"/>
               </a:rPr>
-              <a:t>LoanManage tfLoanImpair  ›  échéance T</a:t>
+              <a:t>LoanManage tfLoanImpair  ›  due date T</a:t>
             </a:r>
             <a:endParaRPr lang="en-US" sz="900" dirty="0"/>
           </a:p>
@@ -5861,7 +6134,7 @@
       </p:sp>
       <p:sp>
         <p:nvSpPr>
-          <p:cNvPr id="10" name="Shape 7"/>
+          <p:cNvPr id="11" name="Shape 8"/>
           <p:cNvSpPr/>
           <p:nvPr/>
         </p:nvSpPr>
@@ -5881,7 +6154,7 @@
       </p:sp>
       <p:sp>
         <p:nvSpPr>
-          <p:cNvPr id="11" name="Shape 8"/>
+          <p:cNvPr id="12" name="Shape 9"/>
           <p:cNvSpPr/>
           <p:nvPr/>
         </p:nvSpPr>
@@ -5901,7 +6174,7 @@
       </p:sp>
       <p:sp>
         <p:nvSpPr>
-          <p:cNvPr id="12" name="Text 9"/>
+          <p:cNvPr id="13" name="Text 10"/>
           <p:cNvSpPr txBox="1"/>
           <p:nvPr/>
         </p:nvSpPr>
@@ -5954,7 +6227,7 @@
       </p:sp>
       <p:sp>
         <p:nvSpPr>
-          <p:cNvPr id="13" name="Shape 10"/>
+          <p:cNvPr id="14" name="Shape 11"/>
           <p:cNvSpPr/>
           <p:nvPr/>
         </p:nvSpPr>
@@ -5974,7 +6247,7 @@
       </p:sp>
       <p:sp>
         <p:nvSpPr>
-          <p:cNvPr id="14" name="Text 11"/>
+          <p:cNvPr id="15" name="Text 12"/>
           <p:cNvSpPr txBox="1"/>
           <p:nvPr/>
         </p:nvSpPr>
@@ -6027,7 +6300,7 @@
       </p:sp>
       <p:sp>
         <p:nvSpPr>
-          <p:cNvPr id="15" name="Text 12"/>
+          <p:cNvPr id="16" name="Text 13"/>
           <p:cNvSpPr txBox="1"/>
           <p:nvPr/>
         </p:nvSpPr>
@@ -6080,7 +6353,7 @@
       </p:sp>
       <p:sp>
         <p:nvSpPr>
-          <p:cNvPr id="16" name="Shape 13"/>
+          <p:cNvPr id="17" name="Shape 14"/>
           <p:cNvSpPr/>
           <p:nvPr/>
         </p:nvSpPr>
@@ -6107,7 +6380,7 @@
       </p:sp>
       <p:sp>
         <p:nvSpPr>
-          <p:cNvPr id="17" name="Shape 14"/>
+          <p:cNvPr id="18" name="Shape 15"/>
           <p:cNvSpPr/>
           <p:nvPr/>
         </p:nvSpPr>
@@ -6127,7 +6400,7 @@
       </p:sp>
       <p:sp>
         <p:nvSpPr>
-          <p:cNvPr id="18" name="Shape 15"/>
+          <p:cNvPr id="19" name="Shape 16"/>
           <p:cNvSpPr/>
           <p:nvPr/>
         </p:nvSpPr>
@@ -6147,7 +6420,7 @@
       </p:sp>
       <p:sp>
         <p:nvSpPr>
-          <p:cNvPr id="19" name="Shape 16"/>
+          <p:cNvPr id="20" name="Shape 17"/>
           <p:cNvSpPr/>
           <p:nvPr/>
         </p:nvSpPr>
@@ -6167,7 +6440,7 @@
       </p:sp>
       <p:sp>
         <p:nvSpPr>
-          <p:cNvPr id="20" name="Text 17"/>
+          <p:cNvPr id="21" name="Text 18"/>
           <p:cNvSpPr txBox="1"/>
           <p:nvPr/>
         </p:nvSpPr>
@@ -6206,7 +6479,7 @@
       </p:sp>
       <p:sp>
         <p:nvSpPr>
-          <p:cNvPr id="21" name="Shape 18"/>
+          <p:cNvPr id="22" name="Shape 19"/>
           <p:cNvSpPr/>
           <p:nvPr/>
         </p:nvSpPr>
@@ -6226,7 +6499,7 @@
       </p:sp>
       <p:sp>
         <p:nvSpPr>
-          <p:cNvPr id="22" name="Shape 19"/>
+          <p:cNvPr id="23" name="Shape 20"/>
           <p:cNvSpPr/>
           <p:nvPr/>
         </p:nvSpPr>
@@ -6246,7 +6519,7 @@
       </p:sp>
       <p:sp>
         <p:nvSpPr>
-          <p:cNvPr id="23" name="Text 20"/>
+          <p:cNvPr id="24" name="Text 21"/>
           <p:cNvSpPr txBox="1"/>
           <p:nvPr/>
         </p:nvSpPr>
@@ -6285,7 +6558,7 @@
       </p:sp>
       <p:sp>
         <p:nvSpPr>
-          <p:cNvPr id="24" name="Text 21"/>
+          <p:cNvPr id="25" name="Text 22"/>
           <p:cNvSpPr txBox="1"/>
           <p:nvPr/>
         </p:nvSpPr>
@@ -6324,7 +6597,7 @@
       </p:sp>
       <p:sp>
         <p:nvSpPr>
-          <p:cNvPr id="25" name="Text 22"/>
+          <p:cNvPr id="26" name="Text 23"/>
           <p:cNvSpPr txBox="1"/>
           <p:nvPr/>
         </p:nvSpPr>
@@ -6363,7 +6636,7 @@
       </p:sp>
       <p:sp>
         <p:nvSpPr>
-          <p:cNvPr id="26" name="Text 23"/>
+          <p:cNvPr id="27" name="Text 24"/>
           <p:cNvSpPr txBox="1"/>
           <p:nvPr/>
         </p:nvSpPr>
@@ -6416,7 +6689,85 @@
       </p:sp>
       <p:sp>
         <p:nvSpPr>
-          <p:cNvPr id="27" name="Shape 24"/>
+          <p:cNvPr id="28" name="Text 25"/>
+          <p:cNvSpPr txBox="1"/>
+          <p:nvPr/>
+        </p:nvSpPr>
+        <p:spPr>
+          <a:xfrm>
+            <a:off x="804672" y="4343400"/>
+            <a:ext cx="5106924" cy="201168"/>
+          </a:xfrm>
+          <a:prstGeom prst="rect">
+            <a:avLst/>
+          </a:prstGeom>
+          <a:noFill/>
+          <a:ln/>
+        </p:spPr>
+        <p:txBody>
+          <a:bodyPr wrap="square" lIns="0" tIns="0" rIns="0" bIns="0" rtlCol="0" anchor="t"/>
+          <a:lstStyle/>
+          <a:p>
+            <a:pPr algn="l" indent="0" marL="0">
+              <a:buNone/>
+            </a:pPr>
+            <a:r>
+              <a:rPr lang="en-US" sz="1150" dirty="0">
+                <a:solidFill>
+                  <a:srgbClr val="5F666E"/>
+                </a:solidFill>
+                <a:latin typeface="Poppins Light" pitchFamily="34" charset="0"/>
+                <a:ea typeface="Poppins Light" pitchFamily="34" charset="-122"/>
+                <a:cs typeface="Poppins Light" pitchFamily="34" charset="-120"/>
+              </a:rPr>
+              <a:t>Impairment refused before the due date, accepted 5 s after.</a:t>
+            </a:r>
+            <a:endParaRPr lang="en-US" sz="1150" dirty="0"/>
+          </a:p>
+        </p:txBody>
+      </p:sp>
+      <p:sp>
+        <p:nvSpPr>
+          <p:cNvPr id="29" name="Text 26"/>
+          <p:cNvSpPr txBox="1"/>
+          <p:nvPr/>
+        </p:nvSpPr>
+        <p:spPr>
+          <a:xfrm>
+            <a:off x="6277356" y="4343400"/>
+            <a:ext cx="5106924" cy="201168"/>
+          </a:xfrm>
+          <a:prstGeom prst="rect">
+            <a:avLst/>
+          </a:prstGeom>
+          <a:noFill/>
+          <a:ln/>
+        </p:spPr>
+        <p:txBody>
+          <a:bodyPr wrap="square" lIns="0" tIns="0" rIns="0" bIns="0" rtlCol="0" anchor="t"/>
+          <a:lstStyle/>
+          <a:p>
+            <a:pPr algn="l" indent="0" marL="0">
+              <a:buNone/>
+            </a:pPr>
+            <a:r>
+              <a:rPr lang="en-US" sz="1150" dirty="0">
+                <a:solidFill>
+                  <a:srgbClr val="5F666E"/>
+                </a:solidFill>
+                <a:latin typeface="Poppins Light" pitchFamily="34" charset="0"/>
+                <a:ea typeface="Poppins Light" pitchFamily="34" charset="-122"/>
+                <a:cs typeface="Poppins Light" pitchFamily="34" charset="-120"/>
+              </a:rPr>
+              <a:t>The xrpl@4.6.0 helper is rejected, the new encoding passes.</a:t>
+            </a:r>
+            <a:endParaRPr lang="en-US" sz="1150" dirty="0"/>
+          </a:p>
+        </p:txBody>
+      </p:sp>
+      <p:sp>
+        <p:nvSpPr>
+          <p:cNvPr id="30" name="Shape 27"/>
           <p:cNvSpPr/>
           <p:nvPr/>
         </p:nvSpPr>
@@ -6436,7 +6787,7 @@
       </p:sp>
       <p:sp>
         <p:nvSpPr>
-          <p:cNvPr id="28" name="Text 25"/>
+          <p:cNvPr id="31" name="Text 28"/>
           <p:cNvSpPr txBox="1"/>
           <p:nvPr/>
         </p:nvSpPr>
@@ -6467,7 +6818,7 @@
                 <a:ea typeface="Poppins Medium" pitchFamily="34" charset="-122"/>
                 <a:cs typeface="Poppins Medium" pitchFamily="34" charset="-120"/>
               </a:rPr>
-              <a:t>Tutoriel Manage a Loan</a:t>
+              <a:t>Manage a Loan tutorial</a:t>
             </a:r>
             <a:endParaRPr lang="en-US" sz="1500" dirty="0"/>
           </a:p>
@@ -6475,7 +6826,7 @@
       </p:sp>
       <p:sp>
         <p:nvSpPr>
-          <p:cNvPr id="29" name="Text 26"/>
+          <p:cNvPr id="32" name="Text 29"/>
           <p:cNvSpPr txBox="1"/>
           <p:nvPr/>
         </p:nvSpPr>
@@ -6506,7 +6857,7 @@
                 <a:ea typeface="Poppins" pitchFamily="34" charset="-122"/>
                 <a:cs typeface="Poppins" pitchFamily="34" charset="-120"/>
               </a:rPr>
-              <a:t>« impair a loan before a payment due date passes »</a:t>
+              <a:t>“impair a loan before a payment due date passes”</a:t>
             </a:r>
             <a:endParaRPr lang="en-US" sz="1500" dirty="0"/>
           </a:p>
@@ -6514,7 +6865,7 @@
       </p:sp>
       <p:sp>
         <p:nvSpPr>
-          <p:cNvPr id="30" name="Text 27"/>
+          <p:cNvPr id="33" name="Text 30"/>
           <p:cNvSpPr txBox="1"/>
           <p:nvPr/>
         </p:nvSpPr>
@@ -6553,7 +6904,7 @@
       </p:sp>
       <p:sp>
         <p:nvSpPr>
-          <p:cNvPr id="31" name="Text 28"/>
+          <p:cNvPr id="34" name="Text 31"/>
           <p:cNvSpPr txBox="1"/>
           <p:nvPr/>
         </p:nvSpPr>
@@ -6584,7 +6935,7 @@
                 <a:ea typeface="Poppins" pitchFamily="34" charset="-122"/>
                 <a:cs typeface="Poppins" pitchFamily="34" charset="-120"/>
               </a:rPr>
-              <a:t>signLoanSetByCounterparty signe avec l'ancien préfixe.</a:t>
+              <a:t>signLoanSetByCounterparty signs with the previous prefix.</a:t>
             </a:r>
             <a:endParaRPr lang="en-US" sz="1500" dirty="0"/>
           </a:p>
@@ -6592,7 +6943,7 @@
       </p:sp>
       <p:sp>
         <p:nvSpPr>
-          <p:cNvPr id="32" name="Text 29"/>
+          <p:cNvPr id="35" name="Text 32"/>
           <p:cNvSpPr txBox="1"/>
           <p:nvPr/>
         </p:nvSpPr>
@@ -6623,7 +6974,7 @@
                 <a:ea typeface="Poppins Medium" pitchFamily="34" charset="-122"/>
                 <a:cs typeface="Poppins Medium" pitchFamily="34" charset="-120"/>
               </a:rPr>
-              <a:t>Correction proposée</a:t>
+              <a:t>Proposed fix</a:t>
             </a:r>
             <a:endParaRPr lang="en-US" sz="1500" dirty="0"/>
           </a:p>
@@ -6631,7 +6982,7 @@
       </p:sp>
       <p:sp>
         <p:nvSpPr>
-          <p:cNvPr id="33" name="Text 30"/>
+          <p:cNvPr id="36" name="Text 33"/>
           <p:cNvSpPr txBox="1"/>
           <p:nvPr/>
         </p:nvSpPr>
@@ -6662,7 +7013,7 @@
                 <a:ea typeface="Poppins" pitchFamily="34" charset="-122"/>
                 <a:cs typeface="Poppins" pitchFamily="34" charset="-120"/>
               </a:rPr>
-              <a:t>lister l'amendement, signer avec encodeForSigningCounterparty.</a:t>
+              <a:t>list the amendment, sign with encodeForSigningCounterparty.</a:t>
             </a:r>
             <a:endParaRPr lang="en-US" sz="1500" dirty="0"/>
           </a:p>
@@ -6732,32 +7083,71 @@
         </p:nvSpPr>
         <p:spPr>
           <a:xfrm>
-            <a:off x="804672" y="713232"/>
-            <a:ext cx="10579608" cy="658368"/>
-          </a:xfrm>
-          <a:prstGeom prst="rect">
-            <a:avLst/>
-          </a:prstGeom>
-          <a:noFill/>
-          <a:ln/>
-        </p:spPr>
-        <p:txBody>
-          <a:bodyPr wrap="square" lIns="0" tIns="0" rIns="0" bIns="0" rtlCol="0" anchor="t"/>
-          <a:lstStyle/>
-          <a:p>
-            <a:pPr algn="l" indent="0" marL="0">
-              <a:buNone/>
-            </a:pPr>
-            <a:r>
-              <a:rPr lang="en-US" sz="3200" b="1" dirty="0">
-                <a:solidFill>
-                  <a:srgbClr val="001C5C"/>
+            <a:off x="10287000" y="6382512"/>
+            <a:ext cx="1097280" cy="228600"/>
+          </a:xfrm>
+          <a:prstGeom prst="rect">
+            <a:avLst/>
+          </a:prstGeom>
+          <a:noFill/>
+          <a:ln/>
+        </p:spPr>
+        <p:txBody>
+          <a:bodyPr wrap="square" lIns="0" tIns="0" rIns="0" bIns="0" rtlCol="0" anchor="ctr"/>
+          <a:lstStyle/>
+          <a:p>
+            <a:pPr algn="r" indent="0" marL="0">
+              <a:buNone/>
+            </a:pPr>
+            <a:r>
+              <a:rPr lang="en-US" sz="1000" dirty="0">
+                <a:solidFill>
+                  <a:srgbClr val="8A9199"/>
                 </a:solidFill>
                 <a:latin typeface="Poppins" pitchFamily="34" charset="0"/>
                 <a:ea typeface="Poppins" pitchFamily="34" charset="-122"/>
                 <a:cs typeface="Poppins" pitchFamily="34" charset="-120"/>
               </a:rPr>
-              <a:t>Un LoanPay en retard exige tfLoanLatePayment</a:t>
+              <a:t>7 / 10</a:t>
+            </a:r>
+            <a:endParaRPr lang="en-US" sz="1000" dirty="0"/>
+          </a:p>
+        </p:txBody>
+      </p:sp>
+      <p:sp>
+        <p:nvSpPr>
+          <p:cNvPr id="4" name="Text 1"/>
+          <p:cNvSpPr txBox="1"/>
+          <p:nvPr/>
+        </p:nvSpPr>
+        <p:spPr>
+          <a:xfrm>
+            <a:off x="804672" y="713232"/>
+            <a:ext cx="10579608" cy="658368"/>
+          </a:xfrm>
+          <a:prstGeom prst="rect">
+            <a:avLst/>
+          </a:prstGeom>
+          <a:noFill/>
+          <a:ln/>
+        </p:spPr>
+        <p:txBody>
+          <a:bodyPr wrap="square" lIns="0" tIns="0" rIns="0" bIns="0" rtlCol="0" anchor="t"/>
+          <a:lstStyle/>
+          <a:p>
+            <a:pPr algn="l" indent="0" marL="0">
+              <a:buNone/>
+            </a:pPr>
+            <a:r>
+              <a:rPr lang="en-US" sz="3200" b="1" dirty="0">
+                <a:solidFill>
+                  <a:srgbClr val="001C5C"/>
+                </a:solidFill>
+                <a:latin typeface="Poppins" pitchFamily="34" charset="0"/>
+                <a:ea typeface="Poppins" pitchFamily="34" charset="-122"/>
+                <a:cs typeface="Poppins" pitchFamily="34" charset="-120"/>
+              </a:rPr>
+              <a:t>A late LoanPay requires tfLoanLatePayment</a:t>
             </a:r>
             <a:endParaRPr lang="en-US" sz="3200" dirty="0"/>
           </a:p>
@@ -6765,7 +7155,7 @@
       </p:sp>
       <p:sp>
         <p:nvSpPr>
-          <p:cNvPr id="4" name="Text 1"/>
+          <p:cNvPr id="5" name="Text 2"/>
           <p:cNvSpPr txBox="1"/>
           <p:nvPr/>
         </p:nvSpPr>
@@ -6796,7 +7186,7 @@
                 <a:ea typeface="Poppins Light" pitchFamily="34" charset="-122"/>
                 <a:cs typeface="Poppins Light" pitchFamily="34" charset="-120"/>
               </a:rPr>
-              <a:t>Prêt en retard, encore dans son délai de grâce.</a:t>
+              <a:t>Loan past due, still within its grace period.</a:t>
             </a:r>
             <a:endParaRPr lang="en-US" sz="1600" dirty="0"/>
           </a:p>
@@ -6804,7 +7194,7 @@
       </p:sp>
       <p:sp>
         <p:nvSpPr>
-          <p:cNvPr id="5" name="Shape 2"/>
+          <p:cNvPr id="6" name="Shape 3"/>
           <p:cNvSpPr/>
           <p:nvPr/>
         </p:nvSpPr>
@@ -6831,7 +7221,7 @@
       </p:sp>
       <p:sp>
         <p:nvSpPr>
-          <p:cNvPr id="6" name="Shape 3"/>
+          <p:cNvPr id="7" name="Shape 4"/>
           <p:cNvSpPr/>
           <p:nvPr/>
         </p:nvSpPr>
@@ -6851,7 +7241,7 @@
       </p:sp>
       <p:sp>
         <p:nvSpPr>
-          <p:cNvPr id="7" name="Shape 4"/>
+          <p:cNvPr id="8" name="Shape 5"/>
           <p:cNvSpPr/>
           <p:nvPr/>
         </p:nvSpPr>
@@ -6871,7 +7261,7 @@
       </p:sp>
       <p:sp>
         <p:nvSpPr>
-          <p:cNvPr id="8" name="Shape 5"/>
+          <p:cNvPr id="9" name="Shape 6"/>
           <p:cNvSpPr/>
           <p:nvPr/>
         </p:nvSpPr>
@@ -6891,7 +7281,7 @@
       </p:sp>
       <p:sp>
         <p:nvSpPr>
-          <p:cNvPr id="9" name="Text 6"/>
+          <p:cNvPr id="10" name="Text 7"/>
           <p:cNvSpPr txBox="1"/>
           <p:nvPr/>
         </p:nvSpPr>
@@ -6930,7 +7320,7 @@
       </p:sp>
       <p:sp>
         <p:nvSpPr>
-          <p:cNvPr id="10" name="Shape 7"/>
+          <p:cNvPr id="11" name="Shape 8"/>
           <p:cNvSpPr/>
           <p:nvPr/>
         </p:nvSpPr>
@@ -6950,7 +7340,7 @@
       </p:sp>
       <p:pic>
         <p:nvPicPr>
-          <p:cNvPr id="11" name="Image 1" descr="/Users/charlypupier/Documents/Hackathon XRPL/xrpl-lending/deck/shots/f1a-type.png">    </p:cNvPr>
+          <p:cNvPr id="12" name="Image 1" descr="/Users/charlypupier/Documents/Hackathon XRPL/xrpl-lending/deck/shots/f1a-type.png">    </p:cNvPr>
           <p:cNvPicPr>
             <a:picLocks noChangeAspect="1"/>
           </p:cNvPicPr>
@@ -6974,7 +7364,7 @@
       </p:pic>
       <p:pic>
         <p:nvPicPr>
-          <p:cNvPr id="12" name="Image 2" descr="/Users/charlypupier/Documents/Hackathon XRPL/xrpl-lending/deck/shots/f1a-status.png">    </p:cNvPr>
+          <p:cNvPr id="13" name="Image 2" descr="/Users/charlypupier/Documents/Hackathon XRPL/xrpl-lending/deck/shots/f1a-status.png">    </p:cNvPr>
           <p:cNvPicPr>
             <a:picLocks noChangeAspect="1"/>
           </p:cNvPicPr>
@@ -6998,7 +7388,7 @@
       </p:pic>
       <p:sp>
         <p:nvSpPr>
-          <p:cNvPr id="13" name="Shape 8"/>
+          <p:cNvPr id="14" name="Shape 9"/>
           <p:cNvSpPr/>
           <p:nvPr/>
         </p:nvSpPr>
@@ -7025,7 +7415,7 @@
       </p:sp>
       <p:sp>
         <p:nvSpPr>
-          <p:cNvPr id="14" name="Shape 9"/>
+          <p:cNvPr id="15" name="Shape 10"/>
           <p:cNvSpPr/>
           <p:nvPr/>
         </p:nvSpPr>
@@ -7045,7 +7435,7 @@
       </p:sp>
       <p:sp>
         <p:nvSpPr>
-          <p:cNvPr id="15" name="Shape 10"/>
+          <p:cNvPr id="16" name="Shape 11"/>
           <p:cNvSpPr/>
           <p:nvPr/>
         </p:nvSpPr>
@@ -7065,7 +7455,7 @@
       </p:sp>
       <p:sp>
         <p:nvSpPr>
-          <p:cNvPr id="16" name="Shape 11"/>
+          <p:cNvPr id="17" name="Shape 12"/>
           <p:cNvSpPr/>
           <p:nvPr/>
         </p:nvSpPr>
@@ -7085,7 +7475,7 @@
       </p:sp>
       <p:sp>
         <p:nvSpPr>
-          <p:cNvPr id="17" name="Text 12"/>
+          <p:cNvPr id="18" name="Text 13"/>
           <p:cNvSpPr txBox="1"/>
           <p:nvPr/>
         </p:nvSpPr>
@@ -7124,7 +7514,7 @@
       </p:sp>
       <p:sp>
         <p:nvSpPr>
-          <p:cNvPr id="18" name="Shape 13"/>
+          <p:cNvPr id="19" name="Shape 14"/>
           <p:cNvSpPr/>
           <p:nvPr/>
         </p:nvSpPr>
@@ -7144,7 +7534,7 @@
       </p:sp>
       <p:pic>
         <p:nvPicPr>
-          <p:cNvPr id="19" name="Image 3" descr="/Users/charlypupier/Documents/Hackathon XRPL/xrpl-lending/deck/shots/f1b-type.png">    </p:cNvPr>
+          <p:cNvPr id="20" name="Image 3" descr="/Users/charlypupier/Documents/Hackathon XRPL/xrpl-lending/deck/shots/f1b-type.png">    </p:cNvPr>
           <p:cNvPicPr>
             <a:picLocks noChangeAspect="1"/>
           </p:cNvPicPr>
@@ -7168,7 +7558,7 @@
       </p:pic>
       <p:pic>
         <p:nvPicPr>
-          <p:cNvPr id="20" name="Image 4" descr="/Users/charlypupier/Documents/Hackathon XRPL/xrpl-lending/deck/shots/f1b-flags.png">    </p:cNvPr>
+          <p:cNvPr id="21" name="Image 4" descr="/Users/charlypupier/Documents/Hackathon XRPL/xrpl-lending/deck/shots/f1b-flags.png">    </p:cNvPr>
           <p:cNvPicPr>
             <a:picLocks noChangeAspect="1"/>
           </p:cNvPicPr>
@@ -7192,7 +7582,85 @@
       </p:pic>
       <p:sp>
         <p:nvSpPr>
-          <p:cNvPr id="21" name="Shape 14"/>
+          <p:cNvPr id="22" name="Text 15"/>
+          <p:cNvSpPr txBox="1"/>
+          <p:nvPr/>
+        </p:nvSpPr>
+        <p:spPr>
+          <a:xfrm>
+            <a:off x="804672" y="4282608"/>
+            <a:ext cx="5106924" cy="201168"/>
+          </a:xfrm>
+          <a:prstGeom prst="rect">
+            <a:avLst/>
+          </a:prstGeom>
+          <a:noFill/>
+          <a:ln/>
+        </p:spPr>
+        <p:txBody>
+          <a:bodyPr wrap="square" lIns="0" tIns="0" rIns="0" bIns="0" rtlCol="0" anchor="t"/>
+          <a:lstStyle/>
+          <a:p>
+            <a:pPr algn="l" indent="0" marL="0">
+              <a:buNone/>
+            </a:pPr>
+            <a:r>
+              <a:rPr lang="en-US" sz="1150" dirty="0">
+                <a:solidFill>
+                  <a:srgbClr val="5F666E"/>
+                </a:solidFill>
+                <a:latin typeface="Poppins Light" pitchFamily="34" charset="0"/>
+                <a:ea typeface="Poppins Light" pitchFamily="34" charset="-122"/>
+                <a:cs typeface="Poppins Light" pitchFamily="34" charset="-120"/>
+              </a:rPr>
+              <a:t>Same loan, same amount, no flag: tecEXPIRED.</a:t>
+            </a:r>
+            <a:endParaRPr lang="en-US" sz="1150" dirty="0"/>
+          </a:p>
+        </p:txBody>
+      </p:sp>
+      <p:sp>
+        <p:nvSpPr>
+          <p:cNvPr id="23" name="Text 16"/>
+          <p:cNvSpPr txBox="1"/>
+          <p:nvPr/>
+        </p:nvSpPr>
+        <p:spPr>
+          <a:xfrm>
+            <a:off x="6277356" y="4282608"/>
+            <a:ext cx="5106924" cy="201168"/>
+          </a:xfrm>
+          <a:prstGeom prst="rect">
+            <a:avLst/>
+          </a:prstGeom>
+          <a:noFill/>
+          <a:ln/>
+        </p:spPr>
+        <p:txBody>
+          <a:bodyPr wrap="square" lIns="0" tIns="0" rIns="0" bIns="0" rtlCol="0" anchor="t"/>
+          <a:lstStyle/>
+          <a:p>
+            <a:pPr algn="l" indent="0" marL="0">
+              <a:buNone/>
+            </a:pPr>
+            <a:r>
+              <a:rPr lang="en-US" sz="1150" dirty="0">
+                <a:solidFill>
+                  <a:srgbClr val="5F666E"/>
+                </a:solidFill>
+                <a:latin typeface="Poppins Light" pitchFamily="34" charset="0"/>
+                <a:ea typeface="Poppins Light" pitchFamily="34" charset="-122"/>
+                <a:cs typeface="Poppins Light" pitchFamily="34" charset="-120"/>
+              </a:rPr>
+              <a:t>Same loan, same amount, with tfLoanLatePayment: success.</a:t>
+            </a:r>
+            <a:endParaRPr lang="en-US" sz="1150" dirty="0"/>
+          </a:p>
+        </p:txBody>
+      </p:sp>
+      <p:sp>
+        <p:nvSpPr>
+          <p:cNvPr id="24" name="Shape 17"/>
           <p:cNvSpPr/>
           <p:nvPr/>
         </p:nvSpPr>
@@ -7212,7 +7680,7 @@
       </p:sp>
       <p:sp>
         <p:nvSpPr>
-          <p:cNvPr id="22" name="Text 15"/>
+          <p:cNvPr id="25" name="Text 18"/>
           <p:cNvSpPr txBox="1"/>
           <p:nvPr/>
         </p:nvSpPr>
@@ -7251,7 +7719,7 @@
       </p:sp>
       <p:sp>
         <p:nvSpPr>
-          <p:cNvPr id="23" name="Text 16"/>
+          <p:cNvPr id="26" name="Text 19"/>
           <p:cNvSpPr txBox="1"/>
           <p:nvPr/>
         </p:nvSpPr>
@@ -7282,7 +7750,7 @@
                 <a:ea typeface="Poppins" pitchFamily="34" charset="-122"/>
                 <a:cs typeface="Poppins" pitchFamily="34" charset="-120"/>
               </a:rPr>
-              <a:t>l'échec est défini (condition 11).</a:t>
+              <a:t>the failure is defined (condition 11).</a:t>
             </a:r>
             <a:endParaRPr lang="en-US" sz="1500" dirty="0"/>
           </a:p>
@@ -7290,7 +7758,7 @@
       </p:sp>
       <p:sp>
         <p:nvSpPr>
-          <p:cNvPr id="24" name="Text 17"/>
+          <p:cNvPr id="27" name="Text 20"/>
           <p:cNvSpPr txBox="1"/>
           <p:nvPr/>
         </p:nvSpPr>
@@ -7321,7 +7789,7 @@
                 <a:ea typeface="Poppins Medium" pitchFamily="34" charset="-122"/>
                 <a:cs typeface="Poppins Medium" pitchFamily="34" charset="-120"/>
               </a:rPr>
-              <a:t>Référence LoanPay</a:t>
+              <a:t>LoanPay reference</a:t>
             </a:r>
             <a:endParaRPr lang="en-US" sz="1500" dirty="0"/>
           </a:p>
@@ -7329,7 +7797,7 @@
       </p:sp>
       <p:sp>
         <p:nvSpPr>
-          <p:cNvPr id="25" name="Text 18"/>
+          <p:cNvPr id="28" name="Text 21"/>
           <p:cNvSpPr txBox="1"/>
           <p:nvPr/>
         </p:nvSpPr>
@@ -7360,7 +7828,7 @@
                 <a:ea typeface="Poppins" pitchFamily="34" charset="-122"/>
                 <a:cs typeface="Poppins" pitchFamily="34" charset="-120"/>
               </a:rPr>
-              <a:t>huit codes d'erreur listés sur xrpl.org, tecEXPIRED n'y figure pas.</a:t>
+              <a:t>eight error codes listed on xrpl.org, tecEXPIRED is not one of them.</a:t>
             </a:r>
             <a:endParaRPr lang="en-US" sz="1500" dirty="0"/>
           </a:p>
@@ -7368,7 +7836,7 @@
       </p:sp>
       <p:sp>
         <p:nvSpPr>
-          <p:cNvPr id="26" name="Text 19"/>
+          <p:cNvPr id="29" name="Text 22"/>
           <p:cNvSpPr txBox="1"/>
           <p:nvPr/>
         </p:nvSpPr>
@@ -7399,7 +7867,7 @@
                 <a:ea typeface="Poppins Medium" pitchFamily="34" charset="-122"/>
                 <a:cs typeface="Poppins Medium" pitchFamily="34" charset="-120"/>
               </a:rPr>
-              <a:t>Correction proposée</a:t>
+              <a:t>Proposed fix</a:t>
             </a:r>
             <a:endParaRPr lang="en-US" sz="1500" dirty="0"/>
           </a:p>
@@ -7407,7 +7875,7 @@
       </p:sp>
       <p:sp>
         <p:nvSpPr>
-          <p:cNvPr id="27" name="Text 20"/>
+          <p:cNvPr id="30" name="Text 23"/>
           <p:cNvSpPr txBox="1"/>
           <p:nvPr/>
         </p:nvSpPr>
@@ -7438,7 +7906,7 @@
                 <a:ea typeface="Poppins" pitchFamily="34" charset="-122"/>
                 <a:cs typeface="Poppins" pitchFamily="34" charset="-120"/>
               </a:rPr>
-              <a:t>tecEXPIRED dans la référence LoanPay, flag nommé dans l'explorer.</a:t>
+              <a:t>tecEXPIRED in the LoanPay reference, flag named in the explorer.</a:t>
             </a:r>
             <a:endParaRPr lang="en-US" sz="1500" dirty="0"/>
           </a:p>
@@ -7508,34 +7976,34 @@
         </p:nvSpPr>
         <p:spPr>
           <a:xfrm>
-            <a:off x="804672" y="713232"/>
-            <a:ext cx="10579608" cy="658368"/>
-          </a:xfrm>
-          <a:prstGeom prst="rect">
-            <a:avLst/>
-          </a:prstGeom>
-          <a:noFill/>
-          <a:ln/>
-        </p:spPr>
-        <p:txBody>
-          <a:bodyPr wrap="square" lIns="0" tIns="0" rIns="0" bIns="0" rtlCol="0" anchor="t"/>
-          <a:lstStyle/>
-          <a:p>
-            <a:pPr algn="l" indent="0" marL="0">
-              <a:buNone/>
-            </a:pPr>
-            <a:r>
-              <a:rPr lang="en-US" sz="3200" b="1" dirty="0">
-                <a:solidFill>
-                  <a:srgbClr val="001C5C"/>
+            <a:off x="10287000" y="6382512"/>
+            <a:ext cx="1097280" cy="228600"/>
+          </a:xfrm>
+          <a:prstGeom prst="rect">
+            <a:avLst/>
+          </a:prstGeom>
+          <a:noFill/>
+          <a:ln/>
+        </p:spPr>
+        <p:txBody>
+          <a:bodyPr wrap="square" lIns="0" tIns="0" rIns="0" bIns="0" rtlCol="0" anchor="ctr"/>
+          <a:lstStyle/>
+          <a:p>
+            <a:pPr algn="r" indent="0" marL="0">
+              <a:buNone/>
+            </a:pPr>
+            <a:r>
+              <a:rPr lang="en-US" sz="1000" dirty="0">
+                <a:solidFill>
+                  <a:srgbClr val="8A9199"/>
                 </a:solidFill>
                 <a:latin typeface="Poppins" pitchFamily="34" charset="0"/>
                 <a:ea typeface="Poppins" pitchFamily="34" charset="-122"/>
                 <a:cs typeface="Poppins" pitchFamily="34" charset="-120"/>
               </a:rPr>
-              <a:t>First-loss capital : 0,5 % d'un prêt en défaut</a:t>
-            </a:r>
-            <a:endParaRPr lang="en-US" sz="3200" dirty="0"/>
+              <a:t>8 / 10</a:t>
+            </a:r>
+            <a:endParaRPr lang="en-US" sz="1000" dirty="0"/>
           </a:p>
         </p:txBody>
       </p:sp>
@@ -7547,8 +8015,8 @@
         </p:nvSpPr>
         <p:spPr>
           <a:xfrm>
-            <a:off x="804672" y="1691640"/>
-            <a:ext cx="5120640" cy="633046"/>
+            <a:off x="804672" y="713232"/>
+            <a:ext cx="10579608" cy="658368"/>
           </a:xfrm>
           <a:prstGeom prst="rect">
             <a:avLst/>
@@ -7564,7 +8032,7 @@
               <a:buNone/>
             </a:pPr>
             <a:r>
-              <a:rPr lang="en-US" sz="3600" b="1" dirty="0">
+              <a:rPr lang="en-US" sz="3200" b="1" dirty="0">
                 <a:solidFill>
                   <a:srgbClr val="001C5C"/>
                 </a:solidFill>
@@ -7572,9 +8040,9 @@
                 <a:ea typeface="Poppins" pitchFamily="34" charset="-122"/>
                 <a:cs typeface="Poppins" pitchFamily="34" charset="-120"/>
               </a:rPr>
-              <a:t>1 XRP</a:t>
-            </a:r>
-            <a:endParaRPr lang="en-US" sz="3600" dirty="0"/>
+              <a:t>First-loss capital: 0.5% of a defaulted loan</a:t>
+            </a:r>
+            <a:endParaRPr lang="en-US" sz="3200" dirty="0"/>
           </a:p>
         </p:txBody>
       </p:sp>
@@ -7586,8 +8054,8 @@
         </p:nvSpPr>
         <p:spPr>
           <a:xfrm>
-            <a:off x="804672" y="2342974"/>
-            <a:ext cx="5120640" cy="274320"/>
+            <a:off x="804672" y="1691640"/>
+            <a:ext cx="5120640" cy="633046"/>
           </a:xfrm>
           <a:prstGeom prst="rect">
             <a:avLst/>
@@ -7603,17 +8071,17 @@
               <a:buNone/>
             </a:pPr>
             <a:r>
-              <a:rPr lang="en-US" sz="1300" dirty="0">
-                <a:solidFill>
-                  <a:srgbClr val="5F666E"/>
+              <a:rPr lang="en-US" sz="3600" b="1" dirty="0">
+                <a:solidFill>
+                  <a:srgbClr val="001C5C"/>
                 </a:solidFill>
                 <a:latin typeface="Poppins" pitchFamily="34" charset="0"/>
                 <a:ea typeface="Poppins" pitchFamily="34" charset="-122"/>
                 <a:cs typeface="Poppins" pitchFamily="34" charset="-120"/>
               </a:rPr>
-              <a:t>de couverture posée par le broker</a:t>
-            </a:r>
-            <a:endParaRPr lang="en-US" sz="1300" dirty="0"/>
+              <a:t>1 XRP</a:t>
+            </a:r>
+            <a:endParaRPr lang="en-US" sz="3600" dirty="0"/>
           </a:p>
         </p:txBody>
       </p:sp>
@@ -7625,8 +8093,8 @@
         </p:nvSpPr>
         <p:spPr>
           <a:xfrm>
-            <a:off x="804672" y="2697480"/>
-            <a:ext cx="5120640" cy="633046"/>
+            <a:off x="804672" y="2342974"/>
+            <a:ext cx="5120640" cy="274320"/>
           </a:xfrm>
           <a:prstGeom prst="rect">
             <a:avLst/>
@@ -7642,17 +8110,17 @@
               <a:buNone/>
             </a:pPr>
             <a:r>
-              <a:rPr lang="en-US" sz="3600" b="1" dirty="0">
-                <a:solidFill>
-                  <a:srgbClr val="F2703A"/>
+              <a:rPr lang="en-US" sz="1300" dirty="0">
+                <a:solidFill>
+                  <a:srgbClr val="5F666E"/>
                 </a:solidFill>
                 <a:latin typeface="Poppins" pitchFamily="34" charset="0"/>
                 <a:ea typeface="Poppins" pitchFamily="34" charset="-122"/>
                 <a:cs typeface="Poppins" pitchFamily="34" charset="-120"/>
               </a:rPr>
-              <a:t>0,02 XRP</a:t>
-            </a:r>
-            <a:endParaRPr lang="en-US" sz="3600" dirty="0"/>
+              <a:t>of cover posted by the broker</a:t>
+            </a:r>
+            <a:endParaRPr lang="en-US" sz="1300" dirty="0"/>
           </a:p>
         </p:txBody>
       </p:sp>
@@ -7664,8 +8132,8 @@
         </p:nvSpPr>
         <p:spPr>
           <a:xfrm>
-            <a:off x="804672" y="3348814"/>
-            <a:ext cx="5120640" cy="274320"/>
+            <a:off x="804672" y="2697480"/>
+            <a:ext cx="5120640" cy="633046"/>
           </a:xfrm>
           <a:prstGeom prst="rect">
             <a:avLst/>
@@ -7681,17 +8149,17 @@
               <a:buNone/>
             </a:pPr>
             <a:r>
-              <a:rPr lang="en-US" sz="1300" dirty="0">
-                <a:solidFill>
-                  <a:srgbClr val="5F666E"/>
+              <a:rPr lang="en-US" sz="3600" b="1" dirty="0">
+                <a:solidFill>
+                  <a:srgbClr val="F2703A"/>
                 </a:solidFill>
                 <a:latin typeface="Poppins" pitchFamily="34" charset="0"/>
                 <a:ea typeface="Poppins" pitchFamily="34" charset="-122"/>
                 <a:cs typeface="Poppins" pitchFamily="34" charset="-120"/>
               </a:rPr>
-              <a:t>prélevés sur la couverture au défaut</a:t>
-            </a:r>
-            <a:endParaRPr lang="en-US" sz="1300" dirty="0"/>
+              <a:t>0.02 XRP</a:t>
+            </a:r>
+            <a:endParaRPr lang="en-US" sz="3600" dirty="0"/>
           </a:p>
         </p:txBody>
       </p:sp>
@@ -7703,8 +8171,8 @@
         </p:nvSpPr>
         <p:spPr>
           <a:xfrm>
-            <a:off x="804672" y="3703320"/>
-            <a:ext cx="5120640" cy="633046"/>
+            <a:off x="804672" y="3348814"/>
+            <a:ext cx="5120640" cy="274320"/>
           </a:xfrm>
           <a:prstGeom prst="rect">
             <a:avLst/>
@@ -7720,17 +8188,17 @@
               <a:buNone/>
             </a:pPr>
             <a:r>
-              <a:rPr lang="en-US" sz="3600" b="1" dirty="0">
-                <a:solidFill>
-                  <a:srgbClr val="001C5C"/>
+              <a:rPr lang="en-US" sz="1300" dirty="0">
+                <a:solidFill>
+                  <a:srgbClr val="5F666E"/>
                 </a:solidFill>
                 <a:latin typeface="Poppins" pitchFamily="34" charset="0"/>
                 <a:ea typeface="Poppins" pitchFamily="34" charset="-122"/>
                 <a:cs typeface="Poppins" pitchFamily="34" charset="-120"/>
               </a:rPr>
-              <a:t>3,98 XRP</a:t>
-            </a:r>
-            <a:endParaRPr lang="en-US" sz="3600" dirty="0"/>
+              <a:t>taken from the cover at default</a:t>
+            </a:r>
+            <a:endParaRPr lang="en-US" sz="1300" dirty="0"/>
           </a:p>
         </p:txBody>
       </p:sp>
@@ -7742,8 +8210,8 @@
         </p:nvSpPr>
         <p:spPr>
           <a:xfrm>
-            <a:off x="804672" y="4354654"/>
-            <a:ext cx="5120640" cy="274320"/>
+            <a:off x="804672" y="3703320"/>
+            <a:ext cx="5120640" cy="633046"/>
           </a:xfrm>
           <a:prstGeom prst="rect">
             <a:avLst/>
@@ -7759,15 +8227,54 @@
               <a:buNone/>
             </a:pPr>
             <a:r>
-              <a:rPr lang="en-US" sz="1300" dirty="0">
-                <a:solidFill>
-                  <a:srgbClr val="5F666E"/>
+              <a:rPr lang="en-US" sz="3600" b="1" dirty="0">
+                <a:solidFill>
+                  <a:srgbClr val="001C5C"/>
                 </a:solidFill>
                 <a:latin typeface="Poppins" pitchFamily="34" charset="0"/>
                 <a:ea typeface="Poppins" pitchFamily="34" charset="-122"/>
                 <a:cs typeface="Poppins" pitchFamily="34" charset="-120"/>
               </a:rPr>
-              <a:t>perdus par le déposant, 79,6 %</a:t>
+              <a:t>3.98 XRP</a:t>
+            </a:r>
+            <a:endParaRPr lang="en-US" sz="3600" dirty="0"/>
+          </a:p>
+        </p:txBody>
+      </p:sp>
+      <p:sp>
+        <p:nvSpPr>
+          <p:cNvPr id="10" name="Text 7"/>
+          <p:cNvSpPr txBox="1"/>
+          <p:nvPr/>
+        </p:nvSpPr>
+        <p:spPr>
+          <a:xfrm>
+            <a:off x="804672" y="4354654"/>
+            <a:ext cx="5120640" cy="274320"/>
+          </a:xfrm>
+          <a:prstGeom prst="rect">
+            <a:avLst/>
+          </a:prstGeom>
+          <a:noFill/>
+          <a:ln/>
+        </p:spPr>
+        <p:txBody>
+          <a:bodyPr wrap="square" lIns="0" tIns="0" rIns="0" bIns="0" rtlCol="0" anchor="t"/>
+          <a:lstStyle/>
+          <a:p>
+            <a:pPr algn="l" indent="0" marL="0">
+              <a:buNone/>
+            </a:pPr>
+            <a:r>
+              <a:rPr lang="en-US" sz="1300" dirty="0">
+                <a:solidFill>
+                  <a:srgbClr val="5F666E"/>
+                </a:solidFill>
+                <a:latin typeface="Poppins" pitchFamily="34" charset="0"/>
+                <a:ea typeface="Poppins" pitchFamily="34" charset="-122"/>
+                <a:cs typeface="Poppins" pitchFamily="34" charset="-120"/>
+              </a:rPr>
+              <a:t>lost by the depositor, 79.6%</a:t>
             </a:r>
             <a:endParaRPr lang="en-US" sz="1300" dirty="0"/>
           </a:p>
@@ -7775,7 +8282,7 @@
       </p:sp>
       <p:sp>
         <p:nvSpPr>
-          <p:cNvPr id="10" name="Shape 7"/>
+          <p:cNvPr id="11" name="Shape 8"/>
           <p:cNvSpPr/>
           <p:nvPr/>
         </p:nvSpPr>
@@ -7795,7 +8302,7 @@
       </p:sp>
       <p:sp>
         <p:nvSpPr>
-          <p:cNvPr id="11" name="Text 8"/>
+          <p:cNvPr id="12" name="Text 9"/>
           <p:cNvSpPr txBox="1"/>
           <p:nvPr/>
         </p:nvSpPr>
@@ -7826,7 +8333,7 @@
                 <a:ea typeface="Menlo" pitchFamily="34" charset="-122"/>
                 <a:cs typeface="Menlo" pitchFamily="34" charset="-120"/>
               </a:rPr>
-              <a:t>4 XRP de dette × CoverRateMinimum 10 % × CoverRateLiquidation 5 %</a:t>
+              <a:t>4 XRP debt × CoverRateMinimum 10% × CoverRateLiquidation 5%</a:t>
             </a:r>
             <a:endParaRPr lang="en-US" sz="1050" dirty="0"/>
           </a:p>
@@ -7834,7 +8341,7 @@
       </p:sp>
       <p:sp>
         <p:nvSpPr>
-          <p:cNvPr id="12" name="Text 9"/>
+          <p:cNvPr id="13" name="Text 10"/>
           <p:cNvSpPr txBox="1"/>
           <p:nvPr/>
         </p:nvSpPr>
@@ -7865,7 +8372,7 @@
                 <a:ea typeface="Poppins" pitchFamily="34" charset="-122"/>
                 <a:cs typeface="Poppins" pitchFamily="34" charset="-120"/>
               </a:rPr>
-              <a:t>Même ratio sur un prêt de 50 XRP : 0,25 XRP.</a:t>
+              <a:t>Same ratio on a 50 XRP loan: 0.25 XRP.</a:t>
             </a:r>
             <a:endParaRPr lang="en-US" sz="1250" dirty="0"/>
           </a:p>
@@ -7873,7 +8380,7 @@
       </p:sp>
       <p:sp>
         <p:nvSpPr>
-          <p:cNvPr id="13" name="Text 10"/>
+          <p:cNvPr id="14" name="Text 11"/>
           <p:cNvSpPr txBox="1"/>
           <p:nvPr/>
         </p:nvSpPr>
@@ -7904,7 +8411,7 @@
                 <a:ea typeface="Poppins Medium" pitchFamily="34" charset="-122"/>
                 <a:cs typeface="Poppins Medium" pitchFamily="34" charset="-120"/>
               </a:rPr>
-              <a:t>Correction proposée</a:t>
+              <a:t>Proposed fix</a:t>
             </a:r>
             <a:endParaRPr lang="en-US" sz="1300" dirty="0"/>
           </a:p>
@@ -7912,7 +8419,7 @@
       </p:sp>
       <p:sp>
         <p:nvSpPr>
-          <p:cNvPr id="14" name="Text 11"/>
+          <p:cNvPr id="15" name="Text 12"/>
           <p:cNvSpPr txBox="1"/>
           <p:nvPr/>
         </p:nvSpPr>
@@ -7946,7 +8453,7 @@
                 <a:ea typeface="Poppins" pitchFamily="34" charset="-122"/>
                 <a:cs typeface="Poppins" pitchFamily="34" charset="-120"/>
               </a:rPr>
-              <a:t>Afficher la part d'un défaut que la couverture absorbe.</a:t>
+              <a:t>Show the share of a default the cover absorbs.</a:t>
             </a:r>
             <a:endParaRPr lang="en-US" sz="1300" dirty="0"/>
           </a:p>
@@ -7966,7 +8473,7 @@
                 <a:ea typeface="Poppins" pitchFamily="34" charset="-122"/>
                 <a:cs typeface="Poppins" pitchFamily="34" charset="-120"/>
               </a:rPr>
-              <a:t>Un délai sur LoanBrokerCoverWithdraw après un défaut.</a:t>
+              <a:t>A delay on LoanBrokerCoverWithdraw after a default.</a:t>
             </a:r>
             <a:endParaRPr lang="en-US" sz="1300" dirty="0"/>
           </a:p>
@@ -7974,18 +8481,18 @@
       </p:sp>
       <p:sp>
         <p:nvSpPr>
-          <p:cNvPr id="15" name="Shape 12"/>
+          <p:cNvPr id="16" name="Shape 13"/>
           <p:cNvSpPr/>
           <p:nvPr/>
         </p:nvSpPr>
         <p:spPr>
           <a:xfrm>
-            <a:off x="6812280" y="1645920"/>
-            <a:ext cx="4572000" cy="2322576"/>
+            <a:off x="7086600" y="1554480"/>
+            <a:ext cx="4297680" cy="2212848"/>
           </a:xfrm>
           <a:prstGeom prst="roundRect">
             <a:avLst>
-              <a:gd name="adj" fmla="val 5512"/>
+              <a:gd name="adj" fmla="val 5785"/>
             </a:avLst>
           </a:prstGeom>
           <a:solidFill>
@@ -8001,40 +8508,20 @@
       </p:sp>
       <p:sp>
         <p:nvSpPr>
-          <p:cNvPr id="16" name="Shape 13"/>
-          <p:cNvSpPr/>
-          <p:nvPr/>
-        </p:nvSpPr>
-        <p:spPr>
-          <a:xfrm>
-            <a:off x="7031736" y="1787652"/>
-            <a:ext cx="100584" cy="100584"/>
-          </a:xfrm>
-          <a:prstGeom prst="ellipse">
-            <a:avLst/>
-          </a:prstGeom>
-          <a:solidFill>
-            <a:srgbClr val="FF5F57"/>
-          </a:solidFill>
-          <a:ln/>
-        </p:spPr>
-      </p:sp>
-      <p:sp>
-        <p:nvSpPr>
           <p:cNvPr id="17" name="Shape 14"/>
           <p:cNvSpPr/>
           <p:nvPr/>
         </p:nvSpPr>
         <p:spPr>
           <a:xfrm>
-            <a:off x="7214616" y="1787652"/>
+            <a:off x="7306056" y="1696212"/>
             <a:ext cx="100584" cy="100584"/>
           </a:xfrm>
           <a:prstGeom prst="ellipse">
             <a:avLst/>
           </a:prstGeom>
           <a:solidFill>
-            <a:srgbClr val="FEBC2E"/>
+            <a:srgbClr val="FF5F57"/>
           </a:solidFill>
           <a:ln/>
         </p:spPr>
@@ -8047,13 +8534,33 @@
         </p:nvSpPr>
         <p:spPr>
           <a:xfrm>
-            <a:off x="7397496" y="1787652"/>
+            <a:off x="7488936" y="1696212"/>
             <a:ext cx="100584" cy="100584"/>
           </a:xfrm>
           <a:prstGeom prst="ellipse">
             <a:avLst/>
           </a:prstGeom>
           <a:solidFill>
+            <a:srgbClr val="FEBC2E"/>
+          </a:solidFill>
+          <a:ln/>
+        </p:spPr>
+      </p:sp>
+      <p:sp>
+        <p:nvSpPr>
+          <p:cNvPr id="19" name="Shape 16"/>
+          <p:cNvSpPr/>
+          <p:nvPr/>
+        </p:nvSpPr>
+        <p:spPr>
+          <a:xfrm>
+            <a:off x="7671816" y="1696212"/>
+            <a:ext cx="100584" cy="100584"/>
+          </a:xfrm>
+          <a:prstGeom prst="ellipse">
+            <a:avLst/>
+          </a:prstGeom>
+          <a:solidFill>
             <a:srgbClr val="28C840"/>
           </a:solidFill>
           <a:ln/>
@@ -8061,14 +8568,14 @@
       </p:sp>
       <p:sp>
         <p:nvSpPr>
-          <p:cNvPr id="19" name="Text 16"/>
-          <p:cNvSpPr txBox="1"/>
-          <p:nvPr/>
-        </p:nvSpPr>
-        <p:spPr>
-          <a:xfrm>
-            <a:off x="7708392" y="1645920"/>
-            <a:ext cx="3474720" cy="384048"/>
+          <p:cNvPr id="20" name="Text 17"/>
+          <p:cNvSpPr txBox="1"/>
+          <p:nvPr/>
+        </p:nvSpPr>
+        <p:spPr>
+          <a:xfrm>
+            <a:off x="7982712" y="1554480"/>
+            <a:ext cx="3200400" cy="384048"/>
           </a:xfrm>
           <a:prstGeom prst="rect">
             <a:avLst/>
@@ -8100,14 +8607,14 @@
       </p:sp>
       <p:sp>
         <p:nvSpPr>
-          <p:cNvPr id="20" name="Shape 17"/>
+          <p:cNvPr id="21" name="Shape 18"/>
           <p:cNvSpPr/>
           <p:nvPr/>
         </p:nvSpPr>
         <p:spPr>
           <a:xfrm>
-            <a:off x="6812280" y="2029968"/>
-            <a:ext cx="4572000" cy="9144"/>
+            <a:off x="7086600" y="1938528"/>
+            <a:ext cx="4297680" cy="9144"/>
           </a:xfrm>
           <a:prstGeom prst="rect">
             <a:avLst/>
@@ -8120,7 +8627,7 @@
       </p:sp>
       <p:pic>
         <p:nvPicPr>
-          <p:cNvPr id="21" name="Image 1" descr="/Users/charlypupier/Documents/Hackathon XRPL/xrpl-lending/deck/shots/f3a-type.png">    </p:cNvPr>
+          <p:cNvPr id="22" name="Image 1" descr="/Users/charlypupier/Documents/Hackathon XRPL/xrpl-lending/deck/shots/f3a-type.png">    </p:cNvPr>
           <p:cNvPicPr>
             <a:picLocks noChangeAspect="1"/>
           </p:cNvPicPr>
@@ -8134,8 +8641,8 @@
         </p:blipFill>
         <p:spPr>
           <a:xfrm>
-            <a:off x="6995160" y="2157984"/>
-            <a:ext cx="3556581" cy="557349"/>
+            <a:off x="7269480" y="2066544"/>
+            <a:ext cx="3324630" cy="521000"/>
           </a:xfrm>
           <a:prstGeom prst="rect">
             <a:avLst/>
@@ -8144,7 +8651,7 @@
       </p:pic>
       <p:pic>
         <p:nvPicPr>
-          <p:cNvPr id="22" name="Image 2" descr="/Users/charlypupier/Documents/Hackathon XRPL/xrpl-lending/deck/shots/f3a-meta.png">    </p:cNvPr>
+          <p:cNvPr id="23" name="Image 2" descr="/Users/charlypupier/Documents/Hackathon XRPL/xrpl-lending/deck/shots/f3a-meta.png">    </p:cNvPr>
           <p:cNvPicPr>
             <a:picLocks noChangeAspect="1"/>
           </p:cNvPicPr>
@@ -8158,8 +8665,8 @@
         </p:blipFill>
         <p:spPr>
           <a:xfrm>
-            <a:off x="6995160" y="2715333"/>
-            <a:ext cx="3786487" cy="1125147"/>
+            <a:off x="7269480" y="2587544"/>
+            <a:ext cx="3539542" cy="1051768"/>
           </a:xfrm>
           <a:prstGeom prst="rect">
             <a:avLst/>
@@ -8168,18 +8675,57 @@
       </p:pic>
       <p:sp>
         <p:nvSpPr>
-          <p:cNvPr id="23" name="Shape 18"/>
+          <p:cNvPr id="24" name="Text 19"/>
+          <p:cNvSpPr txBox="1"/>
+          <p:nvPr/>
+        </p:nvSpPr>
+        <p:spPr>
+          <a:xfrm>
+            <a:off x="7086600" y="3840480"/>
+            <a:ext cx="4297680" cy="201168"/>
+          </a:xfrm>
+          <a:prstGeom prst="rect">
+            <a:avLst/>
+          </a:prstGeom>
+          <a:noFill/>
+          <a:ln/>
+        </p:spPr>
+        <p:txBody>
+          <a:bodyPr wrap="square" lIns="0" tIns="0" rIns="0" bIns="0" rtlCol="0" anchor="t"/>
+          <a:lstStyle/>
+          <a:p>
+            <a:pPr algn="l" indent="0" marL="0">
+              <a:buNone/>
+            </a:pPr>
+            <a:r>
+              <a:rPr lang="en-US" sz="1150" dirty="0">
+                <a:solidFill>
+                  <a:srgbClr val="5F666E"/>
+                </a:solidFill>
+                <a:latin typeface="Poppins Light" pitchFamily="34" charset="0"/>
+                <a:ea typeface="Poppins Light" pitchFamily="34" charset="-122"/>
+                <a:cs typeface="Poppins Light" pitchFamily="34" charset="-120"/>
+              </a:rPr>
+              <a:t>Default: 0.02 XRP taken from the broker's cover.</a:t>
+            </a:r>
+            <a:endParaRPr lang="en-US" sz="1150" dirty="0"/>
+          </a:p>
+        </p:txBody>
+      </p:sp>
+      <p:sp>
+        <p:nvSpPr>
+          <p:cNvPr id="25" name="Shape 20"/>
           <p:cNvSpPr/>
           <p:nvPr/>
         </p:nvSpPr>
         <p:spPr>
           <a:xfrm>
-            <a:off x="6812280" y="4169664"/>
-            <a:ext cx="4572000" cy="1850113"/>
+            <a:off x="7086600" y="4133088"/>
+            <a:ext cx="4297680" cy="1771198"/>
           </a:xfrm>
           <a:prstGeom prst="roundRect">
             <a:avLst>
-              <a:gd name="adj" fmla="val 6919"/>
+              <a:gd name="adj" fmla="val 7228"/>
             </a:avLst>
           </a:prstGeom>
           <a:solidFill>
@@ -8195,59 +8741,59 @@
       </p:sp>
       <p:sp>
         <p:nvSpPr>
-          <p:cNvPr id="24" name="Shape 19"/>
-          <p:cNvSpPr/>
-          <p:nvPr/>
-        </p:nvSpPr>
-        <p:spPr>
-          <a:xfrm>
-            <a:off x="7031736" y="4311396"/>
-            <a:ext cx="100584" cy="100584"/>
-          </a:xfrm>
-          <a:prstGeom prst="ellipse">
-            <a:avLst/>
-          </a:prstGeom>
-          <a:solidFill>
-            <a:srgbClr val="FF5F57"/>
-          </a:solidFill>
-          <a:ln/>
-        </p:spPr>
-      </p:sp>
-      <p:sp>
-        <p:nvSpPr>
-          <p:cNvPr id="25" name="Shape 20"/>
-          <p:cNvSpPr/>
-          <p:nvPr/>
-        </p:nvSpPr>
-        <p:spPr>
-          <a:xfrm>
-            <a:off x="7214616" y="4311396"/>
-            <a:ext cx="100584" cy="100584"/>
-          </a:xfrm>
-          <a:prstGeom prst="ellipse">
-            <a:avLst/>
-          </a:prstGeom>
-          <a:solidFill>
-            <a:srgbClr val="FEBC2E"/>
-          </a:solidFill>
-          <a:ln/>
-        </p:spPr>
-      </p:sp>
-      <p:sp>
-        <p:nvSpPr>
           <p:cNvPr id="26" name="Shape 21"/>
           <p:cNvSpPr/>
           <p:nvPr/>
         </p:nvSpPr>
         <p:spPr>
           <a:xfrm>
-            <a:off x="7397496" y="4311396"/>
+            <a:off x="7306056" y="4274820"/>
             <a:ext cx="100584" cy="100584"/>
           </a:xfrm>
           <a:prstGeom prst="ellipse">
             <a:avLst/>
           </a:prstGeom>
           <a:solidFill>
+            <a:srgbClr val="FF5F57"/>
+          </a:solidFill>
+          <a:ln/>
+        </p:spPr>
+      </p:sp>
+      <p:sp>
+        <p:nvSpPr>
+          <p:cNvPr id="27" name="Shape 22"/>
+          <p:cNvSpPr/>
+          <p:nvPr/>
+        </p:nvSpPr>
+        <p:spPr>
+          <a:xfrm>
+            <a:off x="7488936" y="4274820"/>
+            <a:ext cx="100584" cy="100584"/>
+          </a:xfrm>
+          <a:prstGeom prst="ellipse">
+            <a:avLst/>
+          </a:prstGeom>
+          <a:solidFill>
+            <a:srgbClr val="FEBC2E"/>
+          </a:solidFill>
+          <a:ln/>
+        </p:spPr>
+      </p:sp>
+      <p:sp>
+        <p:nvSpPr>
+          <p:cNvPr id="28" name="Shape 23"/>
+          <p:cNvSpPr/>
+          <p:nvPr/>
+        </p:nvSpPr>
+        <p:spPr>
+          <a:xfrm>
+            <a:off x="7671816" y="4274820"/>
+            <a:ext cx="100584" cy="100584"/>
+          </a:xfrm>
+          <a:prstGeom prst="ellipse">
+            <a:avLst/>
+          </a:prstGeom>
+          <a:solidFill>
             <a:srgbClr val="28C840"/>
           </a:solidFill>
           <a:ln/>
@@ -8255,14 +8801,14 @@
       </p:sp>
       <p:sp>
         <p:nvSpPr>
-          <p:cNvPr id="27" name="Text 22"/>
-          <p:cNvSpPr txBox="1"/>
-          <p:nvPr/>
-        </p:nvSpPr>
-        <p:spPr>
-          <a:xfrm>
-            <a:off x="7708392" y="4169664"/>
-            <a:ext cx="3474720" cy="384048"/>
+          <p:cNvPr id="29" name="Text 24"/>
+          <p:cNvSpPr txBox="1"/>
+          <p:nvPr/>
+        </p:nvSpPr>
+        <p:spPr>
+          <a:xfrm>
+            <a:off x="7982712" y="4133088"/>
+            <a:ext cx="3200400" cy="384048"/>
           </a:xfrm>
           <a:prstGeom prst="rect">
             <a:avLst/>
@@ -8286,7 +8832,7 @@
                 <a:ea typeface="Menlo" pitchFamily="34" charset="-122"/>
                 <a:cs typeface="Menlo" pitchFamily="34" charset="-120"/>
               </a:rPr>
-              <a:t>21 s après le défaut  ›  68DD97D9…</a:t>
+              <a:t>21 s after the default  ›  68DD97D9…</a:t>
             </a:r>
             <a:endParaRPr lang="en-US" sz="900" dirty="0"/>
           </a:p>
@@ -8294,14 +8840,14 @@
       </p:sp>
       <p:sp>
         <p:nvSpPr>
-          <p:cNvPr id="28" name="Shape 23"/>
+          <p:cNvPr id="30" name="Shape 25"/>
           <p:cNvSpPr/>
           <p:nvPr/>
         </p:nvSpPr>
         <p:spPr>
           <a:xfrm>
-            <a:off x="6812280" y="4553712"/>
-            <a:ext cx="4572000" cy="9144"/>
+            <a:off x="7086600" y="4517136"/>
+            <a:ext cx="4297680" cy="9144"/>
           </a:xfrm>
           <a:prstGeom prst="rect">
             <a:avLst/>
@@ -8314,7 +8860,7 @@
       </p:sp>
       <p:pic>
         <p:nvPicPr>
-          <p:cNvPr id="29" name="Image 3" descr="/Users/charlypupier/Documents/Hackathon XRPL/xrpl-lending/deck/shots/f3b-type.png">    </p:cNvPr>
+          <p:cNvPr id="31" name="Image 3" descr="/Users/charlypupier/Documents/Hackathon XRPL/xrpl-lending/deck/shots/f3b-type.png">    </p:cNvPr>
           <p:cNvPicPr>
             <a:picLocks noChangeAspect="1"/>
           </p:cNvPicPr>
@@ -8328,8 +8874,8 @@
         </p:blipFill>
         <p:spPr>
           <a:xfrm>
-            <a:off x="6995160" y="4681728"/>
-            <a:ext cx="4206240" cy="732804"/>
+            <a:off x="7269480" y="4645152"/>
+            <a:ext cx="3931920" cy="685012"/>
           </a:xfrm>
           <a:prstGeom prst="rect">
             <a:avLst/>
@@ -8338,7 +8884,7 @@
       </p:pic>
       <p:pic>
         <p:nvPicPr>
-          <p:cNvPr id="30" name="Image 4" descr="/Users/charlypupier/Documents/Hackathon XRPL/xrpl-lending/deck/shots/f3b-amount.png">    </p:cNvPr>
+          <p:cNvPr id="32" name="Image 4" descr="/Users/charlypupier/Documents/Hackathon XRPL/xrpl-lending/deck/shots/f3b-amount.png">    </p:cNvPr>
           <p:cNvPicPr>
             <a:picLocks noChangeAspect="1"/>
           </p:cNvPicPr>
@@ -8352,8 +8898,8 @@
         </p:blipFill>
         <p:spPr>
           <a:xfrm>
-            <a:off x="6995160" y="5414532"/>
-            <a:ext cx="4059936" cy="238615"/>
+            <a:off x="7269480" y="5330164"/>
+            <a:ext cx="3795158" cy="223053"/>
           </a:xfrm>
           <a:prstGeom prst="rect">
             <a:avLst/>
@@ -8362,7 +8908,7 @@
       </p:pic>
       <p:pic>
         <p:nvPicPr>
-          <p:cNvPr id="31" name="Image 5" descr="/Users/charlypupier/Documents/Hackathon XRPL/xrpl-lending/deck/shots/f3b-date.png">    </p:cNvPr>
+          <p:cNvPr id="33" name="Image 5" descr="/Users/charlypupier/Documents/Hackathon XRPL/xrpl-lending/deck/shots/f3b-date.png">    </p:cNvPr>
           <p:cNvPicPr>
             <a:picLocks noChangeAspect="1"/>
           </p:cNvPicPr>
@@ -8376,14 +8922,53 @@
         </p:blipFill>
         <p:spPr>
           <a:xfrm>
-            <a:off x="6995160" y="5653147"/>
-            <a:ext cx="4059936" cy="238615"/>
+            <a:off x="7269480" y="5553217"/>
+            <a:ext cx="3795158" cy="223053"/>
           </a:xfrm>
           <a:prstGeom prst="rect">
             <a:avLst/>
           </a:prstGeom>
         </p:spPr>
       </p:pic>
+      <p:sp>
+        <p:nvSpPr>
+          <p:cNvPr id="34" name="Text 26"/>
+          <p:cNvSpPr txBox="1"/>
+          <p:nvPr/>
+        </p:nvSpPr>
+        <p:spPr>
+          <a:xfrm>
+            <a:off x="7086600" y="5977438"/>
+            <a:ext cx="4297680" cy="201168"/>
+          </a:xfrm>
+          <a:prstGeom prst="rect">
+            <a:avLst/>
+          </a:prstGeom>
+          <a:noFill/>
+          <a:ln/>
+        </p:spPr>
+        <p:txBody>
+          <a:bodyPr wrap="square" lIns="0" tIns="0" rIns="0" bIns="0" rtlCol="0" anchor="t"/>
+          <a:lstStyle/>
+          <a:p>
+            <a:pPr algn="l" indent="0" marL="0">
+              <a:buNone/>
+            </a:pPr>
+            <a:r>
+              <a:rPr lang="en-US" sz="1150" dirty="0">
+                <a:solidFill>
+                  <a:srgbClr val="5F666E"/>
+                </a:solidFill>
+                <a:latin typeface="Poppins Light" pitchFamily="34" charset="0"/>
+                <a:ea typeface="Poppins Light" pitchFamily="34" charset="-122"/>
+                <a:cs typeface="Poppins Light" pitchFamily="34" charset="-120"/>
+              </a:rPr>
+              <a:t>21 s later, the broker withdraws the remaining cover.</a:t>
+            </a:r>
+            <a:endParaRPr lang="en-US" sz="1150" dirty="0"/>
+          </a:p>
+        </p:txBody>
+      </p:sp>
     </p:spTree>
   </p:cSld>
   <p:clrMapOvr>
@@ -8448,110 +9033,149 @@
         </p:nvSpPr>
         <p:spPr>
           <a:xfrm>
-            <a:off x="804672" y="713232"/>
-            <a:ext cx="10579608" cy="658368"/>
-          </a:xfrm>
-          <a:prstGeom prst="rect">
-            <a:avLst/>
-          </a:prstGeom>
-          <a:noFill/>
-          <a:ln/>
-        </p:spPr>
-        <p:txBody>
-          <a:bodyPr wrap="square" lIns="0" tIns="0" rIns="0" bIns="0" rtlCol="0" anchor="t"/>
-          <a:lstStyle/>
-          <a:p>
-            <a:pPr algn="l" indent="0" marL="0">
-              <a:buNone/>
-            </a:pPr>
-            <a:r>
-              <a:rPr lang="en-US" sz="3200" b="1" dirty="0">
-                <a:solidFill>
-                  <a:srgbClr val="001C5C"/>
+            <a:off x="10287000" y="6382512"/>
+            <a:ext cx="1097280" cy="228600"/>
+          </a:xfrm>
+          <a:prstGeom prst="rect">
+            <a:avLst/>
+          </a:prstGeom>
+          <a:noFill/>
+          <a:ln/>
+        </p:spPr>
+        <p:txBody>
+          <a:bodyPr wrap="square" lIns="0" tIns="0" rIns="0" bIns="0" rtlCol="0" anchor="ctr"/>
+          <a:lstStyle/>
+          <a:p>
+            <a:pPr algn="r" indent="0" marL="0">
+              <a:buNone/>
+            </a:pPr>
+            <a:r>
+              <a:rPr lang="en-US" sz="1000" dirty="0">
+                <a:solidFill>
+                  <a:srgbClr val="8A9199"/>
                 </a:solidFill>
                 <a:latin typeface="Poppins" pitchFamily="34" charset="0"/>
                 <a:ea typeface="Poppins" pitchFamily="34" charset="-122"/>
                 <a:cs typeface="Poppins" pitchFamily="34" charset="-120"/>
               </a:rPr>
-              <a:t>Sept autres constats</a:t>
-            </a:r>
-            <a:endParaRPr lang="en-US" sz="3200" dirty="0"/>
-          </a:p>
-        </p:txBody>
-      </p:sp>
-      <p:sp>
-        <p:nvSpPr>
-          <p:cNvPr id="4" name="Shape 1"/>
-          <p:cNvSpPr/>
-          <p:nvPr/>
-        </p:nvSpPr>
-        <p:spPr>
-          <a:xfrm>
-            <a:off x="804672" y="1783080"/>
-            <a:ext cx="5015484" cy="9144"/>
-          </a:xfrm>
-          <a:prstGeom prst="rect">
-            <a:avLst/>
-          </a:prstGeom>
-          <a:solidFill>
-            <a:srgbClr val="E2E5E8"/>
-          </a:solidFill>
-          <a:ln/>
-        </p:spPr>
-      </p:sp>
-      <p:sp>
-        <p:nvSpPr>
-          <p:cNvPr id="5" name="Shape 2"/>
-          <p:cNvSpPr/>
-          <p:nvPr/>
-        </p:nvSpPr>
-        <p:spPr>
-          <a:xfrm>
-            <a:off x="804672" y="2020824"/>
-            <a:ext cx="310896" cy="310896"/>
-          </a:xfrm>
-          <a:prstGeom prst="ellipse">
-            <a:avLst/>
-          </a:prstGeom>
-          <a:solidFill>
-            <a:srgbClr val="001C5C"/>
-          </a:solidFill>
-          <a:ln/>
-        </p:spPr>
-      </p:sp>
-      <p:sp>
-        <p:nvSpPr>
-          <p:cNvPr id="6" name="Text 3"/>
-          <p:cNvSpPr txBox="1"/>
-          <p:nvPr/>
-        </p:nvSpPr>
-        <p:spPr>
-          <a:xfrm>
-            <a:off x="804672" y="2020824"/>
-            <a:ext cx="310896" cy="310896"/>
-          </a:xfrm>
-          <a:prstGeom prst="rect">
-            <a:avLst/>
-          </a:prstGeom>
-          <a:noFill/>
-          <a:ln/>
-        </p:spPr>
-        <p:txBody>
-          <a:bodyPr wrap="square" lIns="0" tIns="0" rIns="0" bIns="0" rtlCol="0" anchor="ctr"/>
-          <a:lstStyle/>
-          <a:p>
-            <a:pPr algn="ctr" indent="0" marL="0">
-              <a:buNone/>
-            </a:pPr>
-            <a:r>
-              <a:rPr lang="en-US" sz="1100" b="1" dirty="0">
-                <a:solidFill>
-                  <a:srgbClr val="FFFFFF"/>
+              <a:t>9 / 10</a:t>
+            </a:r>
+            <a:endParaRPr lang="en-US" sz="1000" dirty="0"/>
+          </a:p>
+        </p:txBody>
+      </p:sp>
+      <p:sp>
+        <p:nvSpPr>
+          <p:cNvPr id="4" name="Text 1"/>
+          <p:cNvSpPr txBox="1"/>
+          <p:nvPr/>
+        </p:nvSpPr>
+        <p:spPr>
+          <a:xfrm>
+            <a:off x="804672" y="713232"/>
+            <a:ext cx="10579608" cy="658368"/>
+          </a:xfrm>
+          <a:prstGeom prst="rect">
+            <a:avLst/>
+          </a:prstGeom>
+          <a:noFill/>
+          <a:ln/>
+        </p:spPr>
+        <p:txBody>
+          <a:bodyPr wrap="square" lIns="0" tIns="0" rIns="0" bIns="0" rtlCol="0" anchor="t"/>
+          <a:lstStyle/>
+          <a:p>
+            <a:pPr algn="l" indent="0" marL="0">
+              <a:buNone/>
+            </a:pPr>
+            <a:r>
+              <a:rPr lang="en-US" sz="3200" b="1" dirty="0">
+                <a:solidFill>
+                  <a:srgbClr val="001C5C"/>
                 </a:solidFill>
                 <a:latin typeface="Poppins" pitchFamily="34" charset="0"/>
                 <a:ea typeface="Poppins" pitchFamily="34" charset="-122"/>
                 <a:cs typeface="Poppins" pitchFamily="34" charset="-120"/>
               </a:rPr>
+              <a:t>Six more findings</a:t>
+            </a:r>
+            <a:endParaRPr lang="en-US" sz="3200" dirty="0"/>
+          </a:p>
+        </p:txBody>
+      </p:sp>
+      <p:sp>
+        <p:nvSpPr>
+          <p:cNvPr id="5" name="Shape 2"/>
+          <p:cNvSpPr/>
+          <p:nvPr/>
+        </p:nvSpPr>
+        <p:spPr>
+          <a:xfrm>
+            <a:off x="804672" y="1783080"/>
+            <a:ext cx="5015484" cy="9144"/>
+          </a:xfrm>
+          <a:prstGeom prst="rect">
+            <a:avLst/>
+          </a:prstGeom>
+          <a:solidFill>
+            <a:srgbClr val="E2E5E8"/>
+          </a:solidFill>
+          <a:ln/>
+        </p:spPr>
+      </p:sp>
+      <p:sp>
+        <p:nvSpPr>
+          <p:cNvPr id="6" name="Shape 3"/>
+          <p:cNvSpPr/>
+          <p:nvPr/>
+        </p:nvSpPr>
+        <p:spPr>
+          <a:xfrm>
+            <a:off x="804672" y="2020824"/>
+            <a:ext cx="310896" cy="310896"/>
+          </a:xfrm>
+          <a:prstGeom prst="ellipse">
+            <a:avLst/>
+          </a:prstGeom>
+          <a:solidFill>
+            <a:srgbClr val="001C5C"/>
+          </a:solidFill>
+          <a:ln/>
+        </p:spPr>
+      </p:sp>
+      <p:sp>
+        <p:nvSpPr>
+          <p:cNvPr id="7" name="Text 4"/>
+          <p:cNvSpPr txBox="1"/>
+          <p:nvPr/>
+        </p:nvSpPr>
+        <p:spPr>
+          <a:xfrm>
+            <a:off x="804672" y="2020824"/>
+            <a:ext cx="310896" cy="310896"/>
+          </a:xfrm>
+          <a:prstGeom prst="rect">
+            <a:avLst/>
+          </a:prstGeom>
+          <a:noFill/>
+          <a:ln/>
+        </p:spPr>
+        <p:txBody>
+          <a:bodyPr wrap="square" lIns="0" tIns="0" rIns="0" bIns="0" rtlCol="0" anchor="ctr"/>
+          <a:lstStyle/>
+          <a:p>
+            <a:pPr algn="ctr" indent="0" marL="0">
+              <a:buNone/>
+            </a:pPr>
+            <a:r>
+              <a:rPr lang="en-US" sz="1100" b="1" dirty="0">
+                <a:solidFill>
+                  <a:srgbClr val="FFFFFF"/>
+                </a:solidFill>
+                <a:latin typeface="Poppins" pitchFamily="34" charset="0"/>
+                <a:ea typeface="Poppins" pitchFamily="34" charset="-122"/>
+                <a:cs typeface="Poppins" pitchFamily="34" charset="-120"/>
+              </a:rPr>
               <a:t>4</a:t>
             </a:r>
             <a:endParaRPr lang="en-US" sz="1100" dirty="0"/>
@@ -8560,7 +9184,7 @@
       </p:sp>
       <p:sp>
         <p:nvSpPr>
-          <p:cNvPr id="7" name="Text 4"/>
+          <p:cNvPr id="8" name="Text 5"/>
           <p:cNvSpPr txBox="1"/>
           <p:nvPr/>
         </p:nvSpPr>
@@ -8591,7 +9215,7 @@
                 <a:ea typeface="Poppins Medium" pitchFamily="34" charset="-122"/>
                 <a:cs typeface="Poppins Medium" pitchFamily="34" charset="-120"/>
               </a:rPr>
-              <a:t>Exception du porteur unique absente d'xrpl.org</a:t>
+              <a:t>Sole-holder exception missing from xrpl.org</a:t>
             </a:r>
             <a:endParaRPr lang="en-US" sz="1400" dirty="0"/>
           </a:p>
@@ -8599,7 +9223,7 @@
       </p:sp>
       <p:sp>
         <p:nvSpPr>
-          <p:cNvPr id="8" name="Shape 5"/>
+          <p:cNvPr id="9" name="Shape 6"/>
           <p:cNvSpPr/>
           <p:nvPr/>
         </p:nvSpPr>
@@ -8621,7 +9245,7 @@
       </p:sp>
       <p:sp>
         <p:nvSpPr>
-          <p:cNvPr id="9" name="Text 6"/>
+          <p:cNvPr id="10" name="Text 7"/>
           <p:cNvSpPr txBox="1"/>
           <p:nvPr/>
         </p:nvSpPr>
@@ -8660,7 +9284,7 @@
       </p:sp>
       <p:sp>
         <p:nvSpPr>
-          <p:cNvPr id="10" name="Shape 7"/>
+          <p:cNvPr id="11" name="Shape 8"/>
           <p:cNvSpPr/>
           <p:nvPr/>
         </p:nvSpPr>
@@ -8680,7 +9304,7 @@
       </p:sp>
       <p:sp>
         <p:nvSpPr>
-          <p:cNvPr id="11" name="Shape 8"/>
+          <p:cNvPr id="12" name="Shape 9"/>
           <p:cNvSpPr/>
           <p:nvPr/>
         </p:nvSpPr>
@@ -8700,7 +9324,7 @@
       </p:sp>
       <p:sp>
         <p:nvSpPr>
-          <p:cNvPr id="12" name="Text 9"/>
+          <p:cNvPr id="13" name="Text 10"/>
           <p:cNvSpPr txBox="1"/>
           <p:nvPr/>
         </p:nvSpPr>
@@ -8739,7 +9363,7 @@
       </p:sp>
       <p:sp>
         <p:nvSpPr>
-          <p:cNvPr id="13" name="Text 10"/>
+          <p:cNvPr id="14" name="Text 11"/>
           <p:cNvSpPr txBox="1"/>
           <p:nvPr/>
         </p:nvSpPr>
@@ -8770,7 +9394,7 @@
                 <a:ea typeface="Poppins Medium" pitchFamily="34" charset="-122"/>
                 <a:cs typeface="Poppins Medium" pitchFamily="34" charset="-120"/>
               </a:rPr>
-              <a:t>loan_info et loan_broker_info absents</a:t>
+              <a:t>No loan_info or loan_broker_info</a:t>
             </a:r>
             <a:endParaRPr lang="en-US" sz="1400" dirty="0"/>
           </a:p>
@@ -8778,7 +9402,7 @@
       </p:sp>
       <p:sp>
         <p:nvSpPr>
-          <p:cNvPr id="14" name="Shape 11"/>
+          <p:cNvPr id="15" name="Shape 12"/>
           <p:cNvSpPr/>
           <p:nvPr/>
         </p:nvSpPr>
@@ -8800,7 +9424,7 @@
       </p:sp>
       <p:sp>
         <p:nvSpPr>
-          <p:cNvPr id="15" name="Text 12"/>
+          <p:cNvPr id="16" name="Text 13"/>
           <p:cNvSpPr txBox="1"/>
           <p:nvPr/>
         </p:nvSpPr>
@@ -8839,7 +9463,7 @@
       </p:sp>
       <p:sp>
         <p:nvSpPr>
-          <p:cNvPr id="16" name="Shape 13"/>
+          <p:cNvPr id="17" name="Shape 14"/>
           <p:cNvSpPr/>
           <p:nvPr/>
         </p:nvSpPr>
@@ -8859,7 +9483,7 @@
       </p:sp>
       <p:sp>
         <p:nvSpPr>
-          <p:cNvPr id="17" name="Shape 14"/>
+          <p:cNvPr id="18" name="Shape 15"/>
           <p:cNvSpPr/>
           <p:nvPr/>
         </p:nvSpPr>
@@ -8879,7 +9503,7 @@
       </p:sp>
       <p:sp>
         <p:nvSpPr>
-          <p:cNvPr id="18" name="Text 15"/>
+          <p:cNvPr id="19" name="Text 16"/>
           <p:cNvSpPr txBox="1"/>
           <p:nvPr/>
         </p:nvSpPr>
@@ -8918,7 +9542,7 @@
       </p:sp>
       <p:sp>
         <p:nvSpPr>
-          <p:cNvPr id="19" name="Text 16"/>
+          <p:cNvPr id="20" name="Text 17"/>
           <p:cNvSpPr txBox="1"/>
           <p:nvPr/>
         </p:nvSpPr>
@@ -8949,7 +9573,7 @@
                 <a:ea typeface="Poppins Medium" pitchFamily="34" charset="-122"/>
                 <a:cs typeface="Poppins Medium" pitchFamily="34" charset="-120"/>
               </a:rPr>
-              <a:t>Quatre codes, deux à trois causes chacun</a:t>
+              <a:t>Four codes, two or three causes each</a:t>
             </a:r>
             <a:endParaRPr lang="en-US" sz="1400" dirty="0"/>
           </a:p>
@@ -8957,7 +9581,7 @@
       </p:sp>
       <p:sp>
         <p:nvSpPr>
-          <p:cNvPr id="20" name="Shape 17"/>
+          <p:cNvPr id="21" name="Shape 18"/>
           <p:cNvSpPr/>
           <p:nvPr/>
         </p:nvSpPr>
@@ -8979,7 +9603,7 @@
       </p:sp>
       <p:sp>
         <p:nvSpPr>
-          <p:cNvPr id="21" name="Text 18"/>
+          <p:cNvPr id="22" name="Text 19"/>
           <p:cNvSpPr txBox="1"/>
           <p:nvPr/>
         </p:nvSpPr>
@@ -9018,7 +9642,7 @@
       </p:sp>
       <p:sp>
         <p:nvSpPr>
-          <p:cNvPr id="22" name="Shape 19"/>
+          <p:cNvPr id="23" name="Shape 20"/>
           <p:cNvSpPr/>
           <p:nvPr/>
         </p:nvSpPr>
@@ -9038,7 +9662,7 @@
       </p:sp>
       <p:sp>
         <p:nvSpPr>
-          <p:cNvPr id="23" name="Shape 20"/>
+          <p:cNvPr id="24" name="Shape 21"/>
           <p:cNvSpPr/>
           <p:nvPr/>
         </p:nvSpPr>
@@ -9058,7 +9682,7 @@
       </p:sp>
       <p:sp>
         <p:nvSpPr>
-          <p:cNvPr id="24" name="Text 21"/>
+          <p:cNvPr id="25" name="Text 22"/>
           <p:cNvSpPr txBox="1"/>
           <p:nvPr/>
         </p:nvSpPr>
@@ -9097,7 +9721,7 @@
       </p:sp>
       <p:sp>
         <p:nvSpPr>
-          <p:cNvPr id="25" name="Text 22"/>
+          <p:cNvPr id="26" name="Text 23"/>
           <p:cNvSpPr txBox="1"/>
           <p:nvPr/>
         </p:nvSpPr>
@@ -9128,7 +9752,7 @@
                 <a:ea typeface="Poppins Medium" pitchFamily="34" charset="-122"/>
                 <a:cs typeface="Poppins Medium" pitchFamily="34" charset="-120"/>
               </a:rPr>
-              <a:t>Restriction V1.1 de LoanBrokerSet retirée</a:t>
+              <a:t>V1.1 LoanBrokerSet restriction reverted</a:t>
             </a:r>
             <a:endParaRPr lang="en-US" sz="1400" dirty="0"/>
           </a:p>
@@ -9136,7 +9760,7 @@
       </p:sp>
       <p:sp>
         <p:nvSpPr>
-          <p:cNvPr id="26" name="Shape 23"/>
+          <p:cNvPr id="27" name="Shape 24"/>
           <p:cNvSpPr/>
           <p:nvPr/>
         </p:nvSpPr>
@@ -9158,7 +9782,7 @@
       </p:sp>
       <p:sp>
         <p:nvSpPr>
-          <p:cNvPr id="27" name="Text 24"/>
+          <p:cNvPr id="28" name="Text 25"/>
           <p:cNvSpPr txBox="1"/>
           <p:nvPr/>
         </p:nvSpPr>
@@ -9197,7 +9821,7 @@
       </p:sp>
       <p:sp>
         <p:nvSpPr>
-          <p:cNvPr id="28" name="Shape 25"/>
+          <p:cNvPr id="29" name="Shape 26"/>
           <p:cNvSpPr/>
           <p:nvPr/>
         </p:nvSpPr>
@@ -9217,7 +9841,7 @@
       </p:sp>
       <p:sp>
         <p:nvSpPr>
-          <p:cNvPr id="29" name="Shape 26"/>
+          <p:cNvPr id="30" name="Shape 27"/>
           <p:cNvSpPr/>
           <p:nvPr/>
         </p:nvSpPr>
@@ -9237,7 +9861,7 @@
       </p:sp>
       <p:sp>
         <p:nvSpPr>
-          <p:cNvPr id="30" name="Text 27"/>
+          <p:cNvPr id="31" name="Text 28"/>
           <p:cNvSpPr txBox="1"/>
           <p:nvPr/>
         </p:nvSpPr>
@@ -9276,7 +9900,7 @@
       </p:sp>
       <p:sp>
         <p:nvSpPr>
-          <p:cNvPr id="31" name="Text 28"/>
+          <p:cNvPr id="32" name="Text 29"/>
           <p:cNvSpPr txBox="1"/>
           <p:nvPr/>
         </p:nvSpPr>
@@ -9307,7 +9931,7 @@
                 <a:ea typeface="Poppins Medium" pitchFamily="34" charset="-122"/>
                 <a:cs typeface="Poppins Medium" pitchFamily="34" charset="-120"/>
               </a:rPr>
-              <a:t>Devnet sur les ports 51233 et 51234 seulement</a:t>
+              <a:t>Shares carry lsfMPTCanTrade, OfferCreate refused</a:t>
             </a:r>
             <a:endParaRPr lang="en-US" sz="1400" dirty="0"/>
           </a:p>
@@ -9315,14 +9939,14 @@
       </p:sp>
       <p:sp>
         <p:nvSpPr>
-          <p:cNvPr id="32" name="Shape 29"/>
+          <p:cNvPr id="33" name="Shape 30"/>
           <p:cNvSpPr/>
           <p:nvPr/>
         </p:nvSpPr>
         <p:spPr>
           <a:xfrm>
             <a:off x="1280160" y="4636008"/>
-            <a:ext cx="813816" cy="292608"/>
+            <a:ext cx="1156716" cy="292608"/>
           </a:xfrm>
           <a:prstGeom prst="roundRect">
             <a:avLst>
@@ -9337,14 +9961,14 @@
       </p:sp>
       <p:sp>
         <p:nvSpPr>
-          <p:cNvPr id="33" name="Text 30"/>
+          <p:cNvPr id="34" name="Text 31"/>
           <p:cNvSpPr txBox="1"/>
           <p:nvPr/>
         </p:nvSpPr>
         <p:spPr>
           <a:xfrm>
             <a:off x="1280160" y="4636008"/>
-            <a:ext cx="813816" cy="292608"/>
+            <a:ext cx="1156716" cy="292608"/>
           </a:xfrm>
           <a:prstGeom prst="rect">
             <a:avLst/>
@@ -9368,7 +9992,7 @@
                 <a:ea typeface="Menlo" pitchFamily="34" charset="-122"/>
                 <a:cs typeface="Menlo" pitchFamily="34" charset="-120"/>
               </a:rPr>
-              <a:t>réseau</a:t>
+              <a:t>temDISABLED</a:t>
             </a:r>
             <a:endParaRPr lang="en-US" sz="900" dirty="0"/>
           </a:p>
@@ -9376,7 +10000,7 @@
       </p:sp>
       <p:sp>
         <p:nvSpPr>
-          <p:cNvPr id="34" name="Shape 31"/>
+          <p:cNvPr id="35" name="Shape 32"/>
           <p:cNvSpPr/>
           <p:nvPr/>
         </p:nvSpPr>
@@ -9396,7 +10020,7 @@
       </p:sp>
       <p:sp>
         <p:nvSpPr>
-          <p:cNvPr id="35" name="Shape 32"/>
+          <p:cNvPr id="36" name="Shape 33"/>
           <p:cNvSpPr/>
           <p:nvPr/>
         </p:nvSpPr>
@@ -9416,7 +10040,7 @@
       </p:sp>
       <p:sp>
         <p:nvSpPr>
-          <p:cNvPr id="36" name="Text 33"/>
+          <p:cNvPr id="37" name="Text 34"/>
           <p:cNvSpPr txBox="1"/>
           <p:nvPr/>
         </p:nvSpPr>
@@ -9455,7 +10079,7 @@
       </p:sp>
       <p:sp>
         <p:nvSpPr>
-          <p:cNvPr id="37" name="Text 34"/>
+          <p:cNvPr id="38" name="Text 35"/>
           <p:cNvSpPr txBox="1"/>
           <p:nvPr/>
         </p:nvSpPr>
@@ -9486,7 +10110,7 @@
                 <a:ea typeface="Poppins Medium" pitchFamily="34" charset="-122"/>
                 <a:cs typeface="Poppins Medium" pitchFamily="34" charset="-120"/>
               </a:rPr>
-              <a:t>Aucun flag ne ferme un vault aux dépôts</a:t>
+              <a:t>No flag closes a vault to deposits</a:t>
             </a:r>
             <a:endParaRPr lang="en-US" sz="1400" dirty="0"/>
           </a:p>
@@ -9494,7 +10118,7 @@
       </p:sp>
       <p:sp>
         <p:nvSpPr>
-          <p:cNvPr id="38" name="Shape 35"/>
+          <p:cNvPr id="39" name="Shape 36"/>
           <p:cNvSpPr/>
           <p:nvPr/>
         </p:nvSpPr>
@@ -9516,7 +10140,7 @@
       </p:sp>
       <p:sp>
         <p:nvSpPr>
-          <p:cNvPr id="39" name="Text 36"/>
+          <p:cNvPr id="40" name="Text 37"/>
           <p:cNvSpPr txBox="1"/>
           <p:nvPr/>
         </p:nvSpPr>
@@ -9555,193 +10179,14 @@
       </p:sp>
       <p:sp>
         <p:nvSpPr>
-          <p:cNvPr id="40" name="Shape 37"/>
-          <p:cNvSpPr/>
-          <p:nvPr/>
-        </p:nvSpPr>
-        <p:spPr>
-          <a:xfrm>
-            <a:off x="804672" y="5074920"/>
-            <a:ext cx="5015484" cy="9144"/>
-          </a:xfrm>
-          <a:prstGeom prst="rect">
-            <a:avLst/>
-          </a:prstGeom>
-          <a:solidFill>
-            <a:srgbClr val="E2E5E8"/>
-          </a:solidFill>
-          <a:ln/>
-        </p:spPr>
-      </p:sp>
-      <p:sp>
-        <p:nvSpPr>
-          <p:cNvPr id="41" name="Shape 38"/>
-          <p:cNvSpPr/>
-          <p:nvPr/>
-        </p:nvSpPr>
-        <p:spPr>
-          <a:xfrm>
-            <a:off x="804672" y="5312664"/>
-            <a:ext cx="310896" cy="310896"/>
-          </a:xfrm>
-          <a:prstGeom prst="ellipse">
-            <a:avLst/>
-          </a:prstGeom>
-          <a:solidFill>
-            <a:srgbClr val="001C5C"/>
-          </a:solidFill>
-          <a:ln/>
-        </p:spPr>
-      </p:sp>
-      <p:sp>
-        <p:nvSpPr>
-          <p:cNvPr id="42" name="Text 39"/>
-          <p:cNvSpPr txBox="1"/>
-          <p:nvPr/>
-        </p:nvSpPr>
-        <p:spPr>
-          <a:xfrm>
-            <a:off x="804672" y="5312664"/>
-            <a:ext cx="310896" cy="310896"/>
-          </a:xfrm>
-          <a:prstGeom prst="rect">
-            <a:avLst/>
-          </a:prstGeom>
-          <a:noFill/>
-          <a:ln/>
-        </p:spPr>
-        <p:txBody>
-          <a:bodyPr wrap="square" lIns="0" tIns="0" rIns="0" bIns="0" rtlCol="0" anchor="ctr"/>
-          <a:lstStyle/>
-          <a:p>
-            <a:pPr algn="ctr" indent="0" marL="0">
-              <a:buNone/>
-            </a:pPr>
-            <a:r>
-              <a:rPr lang="en-US" sz="950" b="1" dirty="0">
-                <a:solidFill>
-                  <a:srgbClr val="FFFFFF"/>
-                </a:solidFill>
-                <a:latin typeface="Poppins" pitchFamily="34" charset="0"/>
-                <a:ea typeface="Poppins" pitchFamily="34" charset="-122"/>
-                <a:cs typeface="Poppins" pitchFamily="34" charset="-120"/>
-              </a:rPr>
-              <a:t>10</a:t>
-            </a:r>
-            <a:endParaRPr lang="en-US" sz="950" dirty="0"/>
-          </a:p>
-        </p:txBody>
-      </p:sp>
-      <p:sp>
-        <p:nvSpPr>
-          <p:cNvPr id="43" name="Text 40"/>
-          <p:cNvSpPr txBox="1"/>
-          <p:nvPr/>
-        </p:nvSpPr>
-        <p:spPr>
-          <a:xfrm>
-            <a:off x="1280160" y="5312664"/>
-            <a:ext cx="4539996" cy="310896"/>
-          </a:xfrm>
-          <a:prstGeom prst="rect">
-            <a:avLst/>
-          </a:prstGeom>
-          <a:noFill/>
-          <a:ln/>
-        </p:spPr>
-        <p:txBody>
-          <a:bodyPr wrap="square" lIns="0" tIns="0" rIns="0" bIns="0" rtlCol="0" anchor="ctr"/>
-          <a:lstStyle/>
-          <a:p>
-            <a:pPr algn="l" indent="0" marL="0">
-              <a:buNone/>
-            </a:pPr>
-            <a:r>
-              <a:rPr lang="en-US" sz="1400" dirty="0">
-                <a:solidFill>
-                  <a:srgbClr val="001C5C"/>
-                </a:solidFill>
-                <a:latin typeface="Poppins Medium" pitchFamily="34" charset="0"/>
-                <a:ea typeface="Poppins Medium" pitchFamily="34" charset="-122"/>
-                <a:cs typeface="Poppins Medium" pitchFamily="34" charset="-120"/>
-              </a:rPr>
-              <a:t>Parts de vault lsfMPTCanTrade, OfferCreate refusé</a:t>
-            </a:r>
-            <a:endParaRPr lang="en-US" sz="1400" dirty="0"/>
-          </a:p>
-        </p:txBody>
-      </p:sp>
-      <p:sp>
-        <p:nvSpPr>
-          <p:cNvPr id="44" name="Shape 41"/>
-          <p:cNvSpPr/>
-          <p:nvPr/>
-        </p:nvSpPr>
-        <p:spPr>
-          <a:xfrm>
-            <a:off x="1280160" y="5733288"/>
-            <a:ext cx="1156716" cy="292608"/>
-          </a:xfrm>
-          <a:prstGeom prst="roundRect">
-            <a:avLst>
-              <a:gd name="adj" fmla="val 50000"/>
-            </a:avLst>
-          </a:prstGeom>
-          <a:solidFill>
-            <a:srgbClr val="EBF4FF"/>
-          </a:solidFill>
-          <a:ln/>
-        </p:spPr>
-      </p:sp>
-      <p:sp>
-        <p:nvSpPr>
-          <p:cNvPr id="45" name="Text 42"/>
-          <p:cNvSpPr txBox="1"/>
-          <p:nvPr/>
-        </p:nvSpPr>
-        <p:spPr>
-          <a:xfrm>
-            <a:off x="1280160" y="5733288"/>
-            <a:ext cx="1156716" cy="292608"/>
-          </a:xfrm>
-          <a:prstGeom prst="rect">
-            <a:avLst/>
-          </a:prstGeom>
-          <a:noFill/>
-          <a:ln/>
-        </p:spPr>
-        <p:txBody>
-          <a:bodyPr wrap="square" lIns="0" tIns="0" rIns="0" bIns="0" rtlCol="0" anchor="ctr"/>
-          <a:lstStyle/>
-          <a:p>
-            <a:pPr algn="ctr" indent="0" marL="0">
-              <a:buNone/>
-            </a:pPr>
-            <a:r>
-              <a:rPr lang="en-US" sz="900" dirty="0">
-                <a:solidFill>
-                  <a:srgbClr val="0045C6"/>
-                </a:solidFill>
-                <a:latin typeface="Menlo" pitchFamily="34" charset="0"/>
-                <a:ea typeface="Menlo" pitchFamily="34" charset="-122"/>
-                <a:cs typeface="Menlo" pitchFamily="34" charset="-120"/>
-              </a:rPr>
-              <a:t>temDISABLED</a:t>
-            </a:r>
-            <a:endParaRPr lang="en-US" sz="900" dirty="0"/>
-          </a:p>
-        </p:txBody>
-      </p:sp>
-      <p:sp>
-        <p:nvSpPr>
-          <p:cNvPr id="46" name="Text 43"/>
-          <p:cNvSpPr txBox="1"/>
-          <p:nvPr/>
-        </p:nvSpPr>
-        <p:spPr>
-          <a:xfrm>
-            <a:off x="6844284" y="5349240"/>
-            <a:ext cx="4539996" cy="548640"/>
+          <p:cNvPr id="41" name="Text 38"/>
+          <p:cNvSpPr txBox="1"/>
+          <p:nvPr/>
+        </p:nvSpPr>
+        <p:spPr>
+          <a:xfrm>
+            <a:off x="1280160" y="5349240"/>
+            <a:ext cx="10104120" cy="548640"/>
           </a:xfrm>
           <a:prstGeom prst="rect">
             <a:avLst/>
@@ -9765,7 +10210,7 @@
                 <a:ea typeface="Poppins Light" pitchFamily="34" charset="-122"/>
                 <a:cs typeface="Poppins Light" pitchFamily="34" charset="-120"/>
               </a:rPr>
-              <a:t>Sévérité et correction proposée pour chacun dans le rapport.</a:t>
+              <a:t>Category, severity, repro steps and proposed fix for each in the report.</a:t>
             </a:r>
             <a:endParaRPr lang="en-US" sz="1300" dirty="0"/>
           </a:p>

</xml_diff>

<commit_message>
Restore the demo's refused withdrawal to the README and align the report and deck
README: 7AB5622E back in the VaultWithdraw rejections, so the 143 hashes
cited in the report are all in the deliverables again; note that the devnet
also runs LendingProtocolV1_1; short Limits section the deck notes refer to.

FEEDBACK.md and FEEDBACK.pdf: impairment timings marked as script clock with
the ledger close time, late payment at 11 s by ledger close time, finding 7
names and links its opensource.ripple.com source, finding 8 no longer lists
amendments.

Deck: notes point to README Limits, slide 5 counts the 12 rejections of the
README table, slide 7 subtitle holds for both captures. pptx rebuilt, PDF
re-exported.

Co-Authored-By: Claude Fable 5.1 <noreply@anthropic.com>
</commit_message>
<xml_diff>
--- a/deck/exit-lane.pptx
+++ b/deck/exit-lane.pptx
@@ -780,7 +780,7 @@
               <a:rPr lang="en-US" dirty="0"/>
               <a:t>0:40 → 1:00 (20 s)
 No XLS-66 transaction transfers a loan. But the vault share is an MPT, so it can be transferred. She sells it over the counter, at 97% of its value, with two escrows under the same SHA-256 condition: to take the shares, the buyer publishes the secret that pays the seller.
-Q&amp;A: the seller's escrow expires before the buyer's so she has time to collect. Limit: the buyer holds a free one-hour option (README, Known limitations). BatchV1_1 is enabled, another atomic path, not tested.</a:t>
+Q&amp;A: the seller's escrow expires before the buyer's so she has time to collect. Limit: the buyer holds a free one-hour option (README, Limits). BatchV1_1 is enabled, another atomic path, not tested.</a:t>
             </a:r>
             <a:endParaRPr lang="en-US" dirty="0"/>
           </a:p>
@@ -1142,7 +1142,7 @@
             <a:r>
               <a:rPr lang="en-US" dirty="0"/>
               <a:t>2:40 → 3:05 (25 s)
-Two: a loan 10 seconds late, within its grace period. Without the flag: tecEXPIRED, on the left. With tfLoanLatePayment: success, on the right, and the explorer shows that flag in hex. The failure is defined in XLS-66, but not in the xrpl.org LoanPay reference.
+Two: a loan 11 seconds late, within its grace period. Without the flag: tecEXPIRED, on the left. Same amount with tfLoanLatePayment: success, on the right, and the explorer shows that flag in hex. The failure is defined in XLS-66, but not in the xrpl.org LoanPay reference.
 Fix: add tecEXPIRED to the reference with the flag as the remedy, and name the flag in the explorer.</a:t>
             </a:r>
             <a:endParaRPr lang="en-US" dirty="0"/>
@@ -2951,7 +2951,7 @@
       </p:sp>
       <p:pic>
         <p:nvPicPr>
-          <p:cNvPr id="17" name="Image 1" descr="/Users/charlypupier/Documents/Hackathon XRPL/xrpl-lending/deck/shots/d-wall-type.png">    </p:cNvPr>
+          <p:cNvPr id="17" name="Image 1" descr="/Users/charlypupier/Documents/Hackathon XRPL/xrpl-lending/bonus/deck-source/shots/d-wall-type.png">    </p:cNvPr>
           <p:cNvPicPr>
             <a:picLocks noChangeAspect="1"/>
           </p:cNvPicPr>
@@ -2975,7 +2975,7 @@
       </p:pic>
       <p:pic>
         <p:nvPicPr>
-          <p:cNvPr id="18" name="Image 2" descr="/Users/charlypupier/Documents/Hackathon XRPL/xrpl-lending/deck/shots/d-wall-status.png">    </p:cNvPr>
+          <p:cNvPr id="18" name="Image 2" descr="/Users/charlypupier/Documents/Hackathon XRPL/xrpl-lending/bonus/deck-source/shots/d-wall-status.png">    </p:cNvPr>
           <p:cNvPicPr>
             <a:picLocks noChangeAspect="1"/>
           </p:cNvPicPr>
@@ -5565,7 +5565,7 @@
                 <a:ea typeface="Menlo" pitchFamily="34" charset="-122"/>
                 <a:cs typeface="Menlo" pitchFamily="34" charset="-120"/>
               </a:rPr>
-              <a:t>6 × tec + 2 controls</a:t>
+              <a:t>12 × tec in the README</a:t>
             </a:r>
             <a:endParaRPr lang="en-US" sz="1200" dirty="0"/>
           </a:p>
@@ -7186,7 +7186,7 @@
                 <a:ea typeface="Poppins Light" pitchFamily="34" charset="-122"/>
                 <a:cs typeface="Poppins Light" pitchFamily="34" charset="-120"/>
               </a:rPr>
-              <a:t>Loan past due, still within its grace period.</a:t>
+              <a:t>Same loan, same amount, past its due date.</a:t>
             </a:r>
             <a:endParaRPr lang="en-US" sz="1600" dirty="0"/>
           </a:p>
@@ -7340,7 +7340,7 @@
       </p:sp>
       <p:pic>
         <p:nvPicPr>
-          <p:cNvPr id="12" name="Image 1" descr="/Users/charlypupier/Documents/Hackathon XRPL/xrpl-lending/deck/shots/f1a-type.png">    </p:cNvPr>
+          <p:cNvPr id="12" name="Image 1" descr="/Users/charlypupier/Documents/Hackathon XRPL/xrpl-lending/bonus/deck-source/shots/f1a-type.png">    </p:cNvPr>
           <p:cNvPicPr>
             <a:picLocks noChangeAspect="1"/>
           </p:cNvPicPr>
@@ -7364,7 +7364,7 @@
       </p:pic>
       <p:pic>
         <p:nvPicPr>
-          <p:cNvPr id="13" name="Image 2" descr="/Users/charlypupier/Documents/Hackathon XRPL/xrpl-lending/deck/shots/f1a-status.png">    </p:cNvPr>
+          <p:cNvPr id="13" name="Image 2" descr="/Users/charlypupier/Documents/Hackathon XRPL/xrpl-lending/bonus/deck-source/shots/f1a-status.png">    </p:cNvPr>
           <p:cNvPicPr>
             <a:picLocks noChangeAspect="1"/>
           </p:cNvPicPr>
@@ -7534,7 +7534,7 @@
       </p:sp>
       <p:pic>
         <p:nvPicPr>
-          <p:cNvPr id="20" name="Image 3" descr="/Users/charlypupier/Documents/Hackathon XRPL/xrpl-lending/deck/shots/f1b-type.png">    </p:cNvPr>
+          <p:cNvPr id="20" name="Image 3" descr="/Users/charlypupier/Documents/Hackathon XRPL/xrpl-lending/bonus/deck-source/shots/f1b-type.png">    </p:cNvPr>
           <p:cNvPicPr>
             <a:picLocks noChangeAspect="1"/>
           </p:cNvPicPr>
@@ -7558,7 +7558,7 @@
       </p:pic>
       <p:pic>
         <p:nvPicPr>
-          <p:cNvPr id="21" name="Image 4" descr="/Users/charlypupier/Documents/Hackathon XRPL/xrpl-lending/deck/shots/f1b-flags.png">    </p:cNvPr>
+          <p:cNvPr id="21" name="Image 4" descr="/Users/charlypupier/Documents/Hackathon XRPL/xrpl-lending/bonus/deck-source/shots/f1b-flags.png">    </p:cNvPr>
           <p:cNvPicPr>
             <a:picLocks noChangeAspect="1"/>
           </p:cNvPicPr>
@@ -8627,7 +8627,7 @@
       </p:sp>
       <p:pic>
         <p:nvPicPr>
-          <p:cNvPr id="22" name="Image 1" descr="/Users/charlypupier/Documents/Hackathon XRPL/xrpl-lending/deck/shots/f3a-type.png">    </p:cNvPr>
+          <p:cNvPr id="22" name="Image 1" descr="/Users/charlypupier/Documents/Hackathon XRPL/xrpl-lending/bonus/deck-source/shots/f3a-type.png">    </p:cNvPr>
           <p:cNvPicPr>
             <a:picLocks noChangeAspect="1"/>
           </p:cNvPicPr>
@@ -8651,7 +8651,7 @@
       </p:pic>
       <p:pic>
         <p:nvPicPr>
-          <p:cNvPr id="23" name="Image 2" descr="/Users/charlypupier/Documents/Hackathon XRPL/xrpl-lending/deck/shots/f3a-meta.png">    </p:cNvPr>
+          <p:cNvPr id="23" name="Image 2" descr="/Users/charlypupier/Documents/Hackathon XRPL/xrpl-lending/bonus/deck-source/shots/f3a-meta.png">    </p:cNvPr>
           <p:cNvPicPr>
             <a:picLocks noChangeAspect="1"/>
           </p:cNvPicPr>
@@ -8860,7 +8860,7 @@
       </p:sp>
       <p:pic>
         <p:nvPicPr>
-          <p:cNvPr id="31" name="Image 3" descr="/Users/charlypupier/Documents/Hackathon XRPL/xrpl-lending/deck/shots/f3b-type.png">    </p:cNvPr>
+          <p:cNvPr id="31" name="Image 3" descr="/Users/charlypupier/Documents/Hackathon XRPL/xrpl-lending/bonus/deck-source/shots/f3b-type.png">    </p:cNvPr>
           <p:cNvPicPr>
             <a:picLocks noChangeAspect="1"/>
           </p:cNvPicPr>
@@ -8884,7 +8884,7 @@
       </p:pic>
       <p:pic>
         <p:nvPicPr>
-          <p:cNvPr id="32" name="Image 4" descr="/Users/charlypupier/Documents/Hackathon XRPL/xrpl-lending/deck/shots/f3b-amount.png">    </p:cNvPr>
+          <p:cNvPr id="32" name="Image 4" descr="/Users/charlypupier/Documents/Hackathon XRPL/xrpl-lending/bonus/deck-source/shots/f3b-amount.png">    </p:cNvPr>
           <p:cNvPicPr>
             <a:picLocks noChangeAspect="1"/>
           </p:cNvPicPr>
@@ -8908,7 +8908,7 @@
       </p:pic>
       <p:pic>
         <p:nvPicPr>
-          <p:cNvPr id="33" name="Image 5" descr="/Users/charlypupier/Documents/Hackathon XRPL/xrpl-lending/deck/shots/f3b-date.png">    </p:cNvPr>
+          <p:cNvPr id="33" name="Image 5" descr="/Users/charlypupier/Documents/Hackathon XRPL/xrpl-lending/bonus/deck-source/shots/f3b-date.png">    </p:cNvPr>
           <p:cNvPicPr>
             <a:picLocks noChangeAspect="1"/>
           </p:cNvPicPr>

</xml_diff>

<commit_message>
Rename the repository to exit-lane-xrpl
Co-Authored-By: Claude Opus 5 <noreply@anthropic.com>
</commit_message>
<xml_diff>
--- a/deck/exit-lane.pptx
+++ b/deck/exit-lane.pptx
@@ -2307,7 +2307,7 @@
                 <a:ea typeface="Menlo" pitchFamily="34" charset="-122"/>
                 <a:cs typeface="Menlo" pitchFamily="34" charset="-120"/>
               </a:rPr>
-              <a:t>github.com/charlyppr/xrpl-lending</a:t>
+              <a:t>github.com/charlyppr/exit-lane-xrpl</a:t>
             </a:r>
             <a:endParaRPr lang="en-US" sz="2100" dirty="0"/>
           </a:p>
@@ -4252,7 +4252,7 @@
                 <a:ea typeface="Menlo" pitchFamily="34" charset="-122"/>
                 <a:cs typeface="Menlo" pitchFamily="34" charset="-120"/>
               </a:rPr>
-              <a:t>~/xrpl-lending  $ node scripts/demo.mjs --auto</a:t>
+              <a:t>~/exit-lane-xrpl  $ node scripts/demo.mjs --auto</a:t>
             </a:r>
             <a:endParaRPr lang="en-US" sz="900" dirty="0"/>
           </a:p>

</xml_diff>

<commit_message>
Replace the hackathon-only finding 7 and scope the report beyond the devnet
The V1.1 LoanBrokerSet revert exists only on the ripple/lending-hackathon
branch of rippled, which is develop plus that one revert, so it concerns no
other network. Finding 7 now covers the xrpl.org claim that a share Payment
creates the payee's MPToken, while the ledger returns tecNO_AUTH.

Every other finding was re-checked against rippled develop, the xrpl.org
source and xrpl.js. Finding 1 now states that xrpl@5.2.0 always signs with
the CPT prefix; finding 5 drops the devnet-specific Clio request; finding 8
names MPTokensV2; the faucet minor issue is replaced by the undocumented
LoanManage no-op; Limits notes that the hashes live on the hackathon devnet.
Deck slides 6 and 9, both PDFs and the raw log are updated.

Co-Authored-By: Claude Opus 5 <noreply@anthropic.com>
</commit_message>
<xml_diff>
--- a/deck/exit-lane.pptx
+++ b/deck/exit-lane.pptx
@@ -1052,8 +1052,8 @@
             <a:r>
               <a:rPr lang="en-US" dirty="0"/>
               <a:t>2:10 → 2:40 (30 s)
-One: fixCleanup3_4_0 is enabled on the devnet and missing from xrpl.org. It changes two things. Impairment: the tutorial says to impair before the due date, the ledger answers tecTOO_SOON until the due date, on the left. The borrower's signature on LoanSet: a new prefix, which the xrpl 4.6.0 helper does not use, on the right.
-Fix: list the amendment on xrpl.org, update the tutorial, sign with encodeForSigningCounterparty in xrpl.js.</a:t>
+One: fixCleanup3_4_0 is enabled on the devnet and missing from xrpl.org. It changes two things. Impairment: the tutorial says to impair before the due date, the ledger answers tecTOO_SOON until the due date, on the left. The borrower's signature on LoanSet: a new prefix, which the xrpl 4.6.0 helper does not use, on the right. xrpl 5.2.0, released on Friday, always uses the new prefix, so it breaks on networks without the amendment.
+Fix: list the amendment on xrpl.org, update the tutorial, and pick the prefix in xrpl.js from the network's amendments.</a:t>
             </a:r>
             <a:endParaRPr lang="en-US" dirty="0"/>
           </a:p>
@@ -1322,7 +1322,7 @@
             <a:r>
               <a:rPr lang="en-US" dirty="0"/>
               <a:t>3:35 → 3:50 (15 s)
-Six more findings, each with its category, severity, repro steps and fix in the report. Only mention number 7: the hackathon branch reverted the V1.1 restriction on LoanBrokerSet, and the brief does not say so.</a:t>
+Six more findings, each with its category, severity, repro steps and fix in the report. Only mention number 7, because it is our use case: xrpl.org says sending vault shares creates the recipient's token entry. The ledger answers tecNO_AUTH until the recipient opts in with MPTokenAuthorize.</a:t>
             </a:r>
             <a:endParaRPr lang="en-US" dirty="0"/>
           </a:p>
@@ -6896,7 +6896,7 @@
                 <a:ea typeface="Poppins Medium" pitchFamily="34" charset="-122"/>
                 <a:cs typeface="Poppins Medium" pitchFamily="34" charset="-120"/>
               </a:rPr>
-              <a:t>xrpl@4.6.0</a:t>
+              <a:t>LoanSet helper</a:t>
             </a:r>
             <a:endParaRPr lang="en-US" sz="1500" dirty="0"/>
           </a:p>
@@ -6935,7 +6935,7 @@
                 <a:ea typeface="Poppins" pitchFamily="34" charset="-122"/>
                 <a:cs typeface="Poppins" pitchFamily="34" charset="-120"/>
               </a:rPr>
-              <a:t>signLoanSetByCounterparty signs with the previous prefix.</a:t>
+              <a:t>previous prefix in xrpl@4.6.0, always CPT in xrpl@5.2.0.</a:t>
             </a:r>
             <a:endParaRPr lang="en-US" sz="1500" dirty="0"/>
           </a:p>
@@ -7013,7 +7013,7 @@
                 <a:ea typeface="Poppins" pitchFamily="34" charset="-122"/>
                 <a:cs typeface="Poppins" pitchFamily="34" charset="-120"/>
               </a:rPr>
-              <a:t>list the amendment, sign with encodeForSigningCounterparty.</a:t>
+              <a:t>list the amendment, pick the prefix from the network.</a:t>
             </a:r>
             <a:endParaRPr lang="en-US" sz="1500" dirty="0"/>
           </a:p>
@@ -9752,7 +9752,7 @@
                 <a:ea typeface="Poppins Medium" pitchFamily="34" charset="-122"/>
                 <a:cs typeface="Poppins Medium" pitchFamily="34" charset="-120"/>
               </a:rPr>
-              <a:t>V1.1 LoanBrokerSet restriction reverted</a:t>
+              <a:t>Share Payment to a new holder refused</a:t>
             </a:r>
             <a:endParaRPr lang="en-US" sz="1400" dirty="0"/>
           </a:p>
@@ -9813,7 +9813,7 @@
                 <a:ea typeface="Menlo" pitchFamily="34" charset="-122"/>
                 <a:cs typeface="Menlo" pitchFamily="34" charset="-120"/>
               </a:rPr>
-              <a:t>tesSUCCESS</a:t>
+              <a:t>tecNO_AUTH</a:t>
             </a:r>
             <a:endParaRPr lang="en-US" sz="900" dirty="0"/>
           </a:p>

</xml_diff>

<commit_message>
Re-sort the findings by severity and remove the gap on page 3
Findings stay High 1 to 3, Medium 4 to 8, Low 9. Within Medium, the two docs
that contradict the ledger come first (share Payment, lsfMPTCanTrade), then
the read commands, the sole-holder exception and the shared result codes, the
order that leaves no empty column space in the three-page PDF. The Low legend
now reads "cheap to work around, or cosmetic", which no longer conflicts with
finding 2. Anchors, cross-references, deck slide 9 and the script index follow
the new numbering.

Co-Authored-By: Claude Opus 5 <noreply@anthropic.com>
</commit_message>
<xml_diff>
--- a/deck/exit-lane.pptx
+++ b/deck/exit-lane.pptx
@@ -1322,7 +1322,7 @@
             <a:r>
               <a:rPr lang="en-US" dirty="0"/>
               <a:t>3:35 → 3:50 (15 s)
-Six more findings, each with its category, severity, repro steps and fix in the report. Only mention number 7, because it is our use case: xrpl.org says sending vault shares creates the recipient's token entry. The ledger answers tecNO_AUTH until the recipient opts in with MPTokenAuthorize.</a:t>
+Six more findings, ordered by severity, each with its category, repro steps and fix in the report. Only mention number 4, because it is our use case: xrpl.org says sending vault shares creates the recipient's token entry. The ledger answers tecNO_AUTH until the recipient opts in with MPTokenAuthorize.</a:t>
             </a:r>
             <a:endParaRPr lang="en-US" dirty="0"/>
           </a:p>
@@ -9215,7 +9215,7 @@
                 <a:ea typeface="Poppins Medium" pitchFamily="34" charset="-122"/>
                 <a:cs typeface="Poppins Medium" pitchFamily="34" charset="-120"/>
               </a:rPr>
-              <a:t>Sole-holder exception missing from xrpl.org</a:t>
+              <a:t>Share Payment to a new holder refused</a:t>
             </a:r>
             <a:endParaRPr lang="en-US" sz="1400" dirty="0"/>
           </a:p>
@@ -9230,7 +9230,7 @@
         <p:spPr>
           <a:xfrm>
             <a:off x="1280160" y="2441448"/>
-            <a:ext cx="1362456" cy="292608"/>
+            <a:ext cx="1088136" cy="292608"/>
           </a:xfrm>
           <a:prstGeom prst="roundRect">
             <a:avLst>
@@ -9252,7 +9252,7 @@
         <p:spPr>
           <a:xfrm>
             <a:off x="1280160" y="2441448"/>
-            <a:ext cx="1362456" cy="292608"/>
+            <a:ext cx="1088136" cy="292608"/>
           </a:xfrm>
           <a:prstGeom prst="rect">
             <a:avLst/>
@@ -9276,7 +9276,7 @@
                 <a:ea typeface="Menlo" pitchFamily="34" charset="-122"/>
                 <a:cs typeface="Menlo" pitchFamily="34" charset="-120"/>
               </a:rPr>
-              <a:t>LossUnrealized</a:t>
+              <a:t>tecNO_AUTH</a:t>
             </a:r>
             <a:endParaRPr lang="en-US" sz="900" dirty="0"/>
           </a:p>
@@ -9394,7 +9394,7 @@
                 <a:ea typeface="Poppins Medium" pitchFamily="34" charset="-122"/>
                 <a:cs typeface="Poppins Medium" pitchFamily="34" charset="-120"/>
               </a:rPr>
-              <a:t>No loan_info or loan_broker_info</a:t>
+              <a:t>Shares carry lsfMPTCanTrade, OfferCreate refused</a:t>
             </a:r>
             <a:endParaRPr lang="en-US" sz="1400" dirty="0"/>
           </a:p>
@@ -9409,7 +9409,7 @@
         <p:spPr>
           <a:xfrm>
             <a:off x="6844284" y="2441448"/>
-            <a:ext cx="1088136" cy="292608"/>
+            <a:ext cx="1156716" cy="292608"/>
           </a:xfrm>
           <a:prstGeom prst="roundRect">
             <a:avLst>
@@ -9431,7 +9431,7 @@
         <p:spPr>
           <a:xfrm>
             <a:off x="6844284" y="2441448"/>
-            <a:ext cx="1088136" cy="292608"/>
+            <a:ext cx="1156716" cy="292608"/>
           </a:xfrm>
           <a:prstGeom prst="rect">
             <a:avLst/>
@@ -9455,7 +9455,7 @@
                 <a:ea typeface="Menlo" pitchFamily="34" charset="-122"/>
                 <a:cs typeface="Menlo" pitchFamily="34" charset="-120"/>
               </a:rPr>
-              <a:t>unknownCmd</a:t>
+              <a:t>temDISABLED</a:t>
             </a:r>
             <a:endParaRPr lang="en-US" sz="900" dirty="0"/>
           </a:p>
@@ -9573,7 +9573,7 @@
                 <a:ea typeface="Poppins Medium" pitchFamily="34" charset="-122"/>
                 <a:cs typeface="Poppins Medium" pitchFamily="34" charset="-120"/>
               </a:rPr>
-              <a:t>Four codes, two or three causes each</a:t>
+              <a:t>No loan_info or loan_broker_info</a:t>
             </a:r>
             <a:endParaRPr lang="en-US" sz="1400" dirty="0"/>
           </a:p>
@@ -9588,7 +9588,7 @@
         <p:spPr>
           <a:xfrm>
             <a:off x="1280160" y="3538728"/>
-            <a:ext cx="1842516" cy="292608"/>
+            <a:ext cx="1088136" cy="292608"/>
           </a:xfrm>
           <a:prstGeom prst="roundRect">
             <a:avLst>
@@ -9610,7 +9610,7 @@
         <p:spPr>
           <a:xfrm>
             <a:off x="1280160" y="3538728"/>
-            <a:ext cx="1842516" cy="292608"/>
+            <a:ext cx="1088136" cy="292608"/>
           </a:xfrm>
           <a:prstGeom prst="rect">
             <a:avLst/>
@@ -9634,7 +9634,7 @@
                 <a:ea typeface="Menlo" pitchFamily="34" charset="-122"/>
                 <a:cs typeface="Menlo" pitchFamily="34" charset="-120"/>
               </a:rPr>
-              <a:t>tecINSUFFICIENT_FUNDS</a:t>
+              <a:t>unknownCmd</a:t>
             </a:r>
             <a:endParaRPr lang="en-US" sz="900" dirty="0"/>
           </a:p>
@@ -9752,7 +9752,7 @@
                 <a:ea typeface="Poppins Medium" pitchFamily="34" charset="-122"/>
                 <a:cs typeface="Poppins Medium" pitchFamily="34" charset="-120"/>
               </a:rPr>
-              <a:t>Share Payment to a new holder refused</a:t>
+              <a:t>Sole-holder exception missing from xrpl.org</a:t>
             </a:r>
             <a:endParaRPr lang="en-US" sz="1400" dirty="0"/>
           </a:p>
@@ -9767,7 +9767,7 @@
         <p:spPr>
           <a:xfrm>
             <a:off x="6844284" y="3538728"/>
-            <a:ext cx="1088136" cy="292608"/>
+            <a:ext cx="1362456" cy="292608"/>
           </a:xfrm>
           <a:prstGeom prst="roundRect">
             <a:avLst>
@@ -9789,7 +9789,7 @@
         <p:spPr>
           <a:xfrm>
             <a:off x="6844284" y="3538728"/>
-            <a:ext cx="1088136" cy="292608"/>
+            <a:ext cx="1362456" cy="292608"/>
           </a:xfrm>
           <a:prstGeom prst="rect">
             <a:avLst/>
@@ -9813,7 +9813,7 @@
                 <a:ea typeface="Menlo" pitchFamily="34" charset="-122"/>
                 <a:cs typeface="Menlo" pitchFamily="34" charset="-120"/>
               </a:rPr>
-              <a:t>tecNO_AUTH</a:t>
+              <a:t>LossUnrealized</a:t>
             </a:r>
             <a:endParaRPr lang="en-US" sz="900" dirty="0"/>
           </a:p>
@@ -9931,7 +9931,7 @@
                 <a:ea typeface="Poppins Medium" pitchFamily="34" charset="-122"/>
                 <a:cs typeface="Poppins Medium" pitchFamily="34" charset="-120"/>
               </a:rPr>
-              <a:t>Shares carry lsfMPTCanTrade, OfferCreate refused</a:t>
+              <a:t>Four codes, two or three causes each</a:t>
             </a:r>
             <a:endParaRPr lang="en-US" sz="1400" dirty="0"/>
           </a:p>
@@ -9946,7 +9946,7 @@
         <p:spPr>
           <a:xfrm>
             <a:off x="1280160" y="4636008"/>
-            <a:ext cx="1156716" cy="292608"/>
+            <a:ext cx="1842516" cy="292608"/>
           </a:xfrm>
           <a:prstGeom prst="roundRect">
             <a:avLst>
@@ -9968,7 +9968,7 @@
         <p:spPr>
           <a:xfrm>
             <a:off x="1280160" y="4636008"/>
-            <a:ext cx="1156716" cy="292608"/>
+            <a:ext cx="1842516" cy="292608"/>
           </a:xfrm>
           <a:prstGeom prst="rect">
             <a:avLst/>
@@ -9992,7 +9992,7 @@
                 <a:ea typeface="Menlo" pitchFamily="34" charset="-122"/>
                 <a:cs typeface="Menlo" pitchFamily="34" charset="-120"/>
               </a:rPr>
-              <a:t>temDISABLED</a:t>
+              <a:t>tecINSUFFICIENT_FUNDS</a:t>
             </a:r>
             <a:endParaRPr lang="en-US" sz="900" dirty="0"/>
           </a:p>

</xml_diff>

<commit_message>
Scope the 143 verified transactions to all deliverables and reconfirm three minor issues
The count covers the report, the README and the raw log, not the report alone.
Reworded in FEEDBACK.md, FEEDBACK.pdf, slide 10 and its notes. Minor issues table
extended with LoanManage typos, due-date close time, validateLoanManage and
submitAndWait behaviour; limits paragraph made explicit.

Co-Authored-By: Claude Opus 5 <noreply@anthropic.com>
</commit_message>
<xml_diff>
--- a/deck/exit-lane.pptx
+++ b/deck/exit-lane.pptx
@@ -601,7 +601,7 @@
             <a:r>
               <a:rPr lang="en-US" dirty="0"/>
               <a:t>3:50 → 4:00 (10 s)
-Everything is in FEEDBACK.md, and in three pages in FEEDBACK.pdf. The 143 hashes cited were re-checked on the ledger before submission. Thank you.</a:t>
+Everything is in FEEDBACK.md, and in three pages in FEEDBACK.pdf. The 143 transactions cited across the report, the README and the raw log were re-checked on the ledger before submission. Thank you.</a:t>
             </a:r>
             <a:endParaRPr lang="en-US" dirty="0"/>
           </a:p>
@@ -2248,7 +2248,7 @@
                 <a:ea typeface="Poppins Light" pitchFamily="34" charset="-122"/>
                 <a:cs typeface="Poppins Light" pitchFamily="34" charset="-120"/>
               </a:rPr>
-              <a:t>hashes cited, re-checked on the ledger before submission</a:t>
+              <a:t>transactions cited in report, README and raw log, re-checked on the ledger</a:t>
             </a:r>
             <a:endParaRPr lang="en-US" sz="1900" dirty="0"/>
           </a:p>

</xml_diff>